<commit_message>
Proposta Surcin: alinha preço às opções Essencial e Completa da precificação v2
Co-Authored-By: Claude Opus 5.5 (1M context) <noreply@anthropic.com>
Claude-Session: https://claude.ai/code/session_0127xFh2xB8HoQ18BDMAY2QJ
</commit_message>
<xml_diff>
--- a/proposta-surcin/06-apresentacao-proposta.pptx
+++ b/proposta-surcin/06-apresentacao-proposta.pptx
@@ -4007,7 +4007,7 @@
                 </a:solidFill>
                 <a:latin typeface="Calibri"/>
               </a:rPr>
-              <a:t>Reunião de descoberta</a:t>
+              <a:t>Reunião inicial e diagnóstico preliminar</a:t>
             </a:r>
           </a:p>
           <a:p>
@@ -4039,7 +4039,7 @@
                 </a:solidFill>
                 <a:latin typeface="Calibri"/>
               </a:rPr>
-              <a:t>Concluída</a:t>
+              <a:t>Concluída, sem custo</a:t>
             </a:r>
           </a:p>
         </p:txBody>
@@ -4114,7 +4114,7 @@
                 </a:solidFill>
                 <a:latin typeface="Calibri"/>
               </a:rPr>
-              <a:t>Diagnóstico e estrutura organizacional</a:t>
+              <a:t>Mapeamento dos processos atuais</a:t>
             </a:r>
           </a:p>
           <a:p>
@@ -4221,7 +4221,7 @@
                 </a:solidFill>
                 <a:latin typeface="Calibri"/>
               </a:rPr>
-              <a:t>Mapeamento detalhado de processos</a:t>
+              <a:t>Estrutura organizacional</a:t>
             </a:r>
           </a:p>
           <a:p>
@@ -4267,6 +4267,113 @@
         <p:spPr>
           <a:xfrm>
             <a:off x="7235999" y="2160000"/>
+            <a:ext cx="2052000" cy="2520000"/>
+          </a:xfrm>
+          <a:prstGeom prst="roundRect">
+            <a:avLst>
+              <a:gd name="adj" fmla="val 8000"/>
+            </a:avLst>
+          </a:prstGeom>
+          <a:solidFill>
+            <a:srgbClr val="1F3A5F"/>
+          </a:solidFill>
+          <a:ln>
+            <a:noFill/>
+          </a:ln>
+          <a:effectLst/>
+        </p:spPr>
+        <p:style>
+          <a:lnRef idx="1">
+            <a:schemeClr val="accent1"/>
+          </a:lnRef>
+          <a:fillRef idx="3">
+            <a:schemeClr val="accent1"/>
+          </a:fillRef>
+          <a:effectRef idx="2">
+            <a:schemeClr val="accent1"/>
+          </a:effectRef>
+          <a:fontRef idx="minor">
+            <a:schemeClr val="lt1"/>
+          </a:fontRef>
+        </p:style>
+        <p:txBody>
+          <a:bodyPr rtlCol="0" anchor="t" wrap="square" lIns="180000" rIns="180000" tIns="180000"/>
+          <a:lstStyle/>
+          <a:p>
+            <a:pPr algn="l">
+              <a:spcAft>
+                <a:spcPts val="600"/>
+              </a:spcAft>
+            </a:pPr>
+            <a:r>
+              <a:rPr sz="1500" b="1">
+                <a:solidFill>
+                  <a:srgbClr val="FFFFFF"/>
+                </a:solidFill>
+                <a:latin typeface="Calibri"/>
+              </a:rPr>
+              <a:t>Etapa 3</a:t>
+            </a:r>
+          </a:p>
+          <a:p>
+            <a:pPr algn="l">
+              <a:spcAft>
+                <a:spcPts val="600"/>
+              </a:spcAft>
+            </a:pPr>
+            <a:r>
+              <a:rPr sz="1500" b="0">
+                <a:solidFill>
+                  <a:srgbClr val="FFFFFF"/>
+                </a:solidFill>
+                <a:latin typeface="Calibri"/>
+              </a:rPr>
+              <a:t>Fluxos otimizados e plano de automação</a:t>
+            </a:r>
+          </a:p>
+          <a:p>
+            <a:pPr algn="l">
+              <a:spcAft>
+                <a:spcPts val="600"/>
+              </a:spcAft>
+            </a:pPr>
+            <a:r>
+              <a:rPr sz="1500" b="0">
+                <a:solidFill>
+                  <a:srgbClr val="FFFFFF"/>
+                </a:solidFill>
+                <a:latin typeface="Calibri"/>
+              </a:rPr>
+              <a:t/>
+            </a:r>
+          </a:p>
+          <a:p>
+            <a:pPr algn="l">
+              <a:spcAft>
+                <a:spcPts val="600"/>
+              </a:spcAft>
+            </a:pPr>
+            <a:r>
+              <a:rPr sz="1500" b="0">
+                <a:solidFill>
+                  <a:srgbClr val="FFFFFF"/>
+                </a:solidFill>
+                <a:latin typeface="Calibri"/>
+              </a:rPr>
+              <a:t>Nesta proposta</a:t>
+            </a:r>
+          </a:p>
+        </p:txBody>
+      </p:sp>
+      <p:sp>
+        <p:nvSpPr>
+          <p:cNvPr id="10" name="Rounded Rectangle 9"/>
+          <p:cNvSpPr/>
+          <p:nvPr/>
+        </p:nvSpPr>
+        <p:spPr>
+          <a:xfrm>
+            <a:off x="9432000" y="2160000"/>
             <a:ext cx="2052000" cy="2520000"/>
           </a:xfrm>
           <a:prstGeom prst="roundRect">
@@ -4312,7 +4419,7 @@
                 </a:solidFill>
                 <a:latin typeface="Calibri"/>
               </a:rPr>
-              <a:t>Etapa 3</a:t>
+              <a:t>Etapa 4</a:t>
             </a:r>
           </a:p>
           <a:p>
@@ -4328,7 +4435,7 @@
                 </a:solidFill>
                 <a:latin typeface="Calibri"/>
               </a:rPr>
-              <a:t>Implementação em pacotes</a:t>
+              <a:t>Implementação e acompanhamento</a:t>
             </a:r>
           </a:p>
           <a:p>
@@ -4361,113 +4468,6 @@
                 <a:latin typeface="Calibri"/>
               </a:rPr>
               <a:t>Proposta futura</a:t>
-            </a:r>
-          </a:p>
-        </p:txBody>
-      </p:sp>
-      <p:sp>
-        <p:nvSpPr>
-          <p:cNvPr id="10" name="Rounded Rectangle 9"/>
-          <p:cNvSpPr/>
-          <p:nvPr/>
-        </p:nvSpPr>
-        <p:spPr>
-          <a:xfrm>
-            <a:off x="9432000" y="2160000"/>
-            <a:ext cx="2052000" cy="2520000"/>
-          </a:xfrm>
-          <a:prstGeom prst="roundRect">
-            <a:avLst>
-              <a:gd name="adj" fmla="val 8000"/>
-            </a:avLst>
-          </a:prstGeom>
-          <a:solidFill>
-            <a:srgbClr val="E8EEF5"/>
-          </a:solidFill>
-          <a:ln>
-            <a:noFill/>
-          </a:ln>
-          <a:effectLst/>
-        </p:spPr>
-        <p:style>
-          <a:lnRef idx="1">
-            <a:schemeClr val="accent1"/>
-          </a:lnRef>
-          <a:fillRef idx="3">
-            <a:schemeClr val="accent1"/>
-          </a:fillRef>
-          <a:effectRef idx="2">
-            <a:schemeClr val="accent1"/>
-          </a:effectRef>
-          <a:fontRef idx="minor">
-            <a:schemeClr val="lt1"/>
-          </a:fontRef>
-        </p:style>
-        <p:txBody>
-          <a:bodyPr rtlCol="0" anchor="t" wrap="square" lIns="180000" rIns="180000" tIns="180000"/>
-          <a:lstStyle/>
-          <a:p>
-            <a:pPr algn="l">
-              <a:spcAft>
-                <a:spcPts val="600"/>
-              </a:spcAft>
-            </a:pPr>
-            <a:r>
-              <a:rPr sz="1500" b="1">
-                <a:solidFill>
-                  <a:srgbClr val="1F3A5F"/>
-                </a:solidFill>
-                <a:latin typeface="Calibri"/>
-              </a:rPr>
-              <a:t>Etapa 4</a:t>
-            </a:r>
-          </a:p>
-          <a:p>
-            <a:pPr algn="l">
-              <a:spcAft>
-                <a:spcPts val="600"/>
-              </a:spcAft>
-            </a:pPr>
-            <a:r>
-              <a:rPr sz="1500" b="0">
-                <a:solidFill>
-                  <a:srgbClr val="1F3A5F"/>
-                </a:solidFill>
-                <a:latin typeface="Calibri"/>
-              </a:rPr>
-              <a:t>Acompanhamento mensal</a:t>
-            </a:r>
-          </a:p>
-          <a:p>
-            <a:pPr algn="l">
-              <a:spcAft>
-                <a:spcPts val="600"/>
-              </a:spcAft>
-            </a:pPr>
-            <a:r>
-              <a:rPr sz="1500" b="0">
-                <a:solidFill>
-                  <a:srgbClr val="1F3A5F"/>
-                </a:solidFill>
-                <a:latin typeface="Calibri"/>
-              </a:rPr>
-              <a:t/>
-            </a:r>
-          </a:p>
-          <a:p>
-            <a:pPr algn="l">
-              <a:spcAft>
-                <a:spcPts val="600"/>
-              </a:spcAft>
-            </a:pPr>
-            <a:r>
-              <a:rPr sz="1500" b="0">
-                <a:solidFill>
-                  <a:srgbClr val="1F3A5F"/>
-                </a:solidFill>
-                <a:latin typeface="Calibri"/>
-              </a:rPr>
-              <a:t>Opcional</a:t>
             </a:r>
           </a:p>
         </p:txBody>
@@ -5118,7 +5118,7 @@
                 </a:solidFill>
                 <a:latin typeface="Calibri"/>
               </a:rPr>
-              <a:t>Entregável da Etapa 1: organograma atual e proposto, papéis e responsabilidades por área, matriz RACI (quem executa, aprova, é consultado e informado) e as dependências da Direção.</a:t>
+              <a:t>Entregável da Etapa 2: organograma atual e proposto, papéis e responsabilidades por área, matriz RACI (quem executa, aprova, é consultado e informado) e as dependências da Direção.</a:t>
             </a:r>
           </a:p>
         </p:txBody>
@@ -5760,7 +5760,7 @@
                 </a:solidFill>
                 <a:latin typeface="Calibri"/>
               </a:rPr>
-              <a:t>Entregáveis e cronograma</a:t>
+              <a:t>Duas opções de escopo</a:t>
             </a:r>
           </a:p>
         </p:txBody>
@@ -5799,7 +5799,7 @@
                 </a:solidFill>
                 <a:latin typeface="Calibri"/>
               </a:rPr>
-              <a:t>8 semanas, cerca de 10 horas por semana, reuniões fora do horário comercial</a:t>
+              <a:t>Você escolhe o tamanho; a Essencial pode virar Completa depois</a:t>
             </a:r>
           </a:p>
         </p:txBody>
@@ -5897,7 +5897,7 @@
                 </a:solidFill>
                 <a:latin typeface="Calibri"/>
               </a:rPr>
-              <a:t>Etapa 1 · semanas 1 a 4</a:t>
+              <a:t>Essencial · 4 a 5 semanas</a:t>
             </a:r>
           </a:p>
           <a:p>
@@ -5913,7 +5913,7 @@
                 </a:solidFill>
                 <a:latin typeface="Calibri"/>
               </a:rPr>
-              <a:t>• Entrevistas com a equipe (até 6)</a:t>
+              <a:t>• Entrevistas com até 4 pessoas</a:t>
             </a:r>
           </a:p>
           <a:p>
@@ -5929,7 +5929,7 @@
                 </a:solidFill>
                 <a:latin typeface="Calibri"/>
               </a:rPr>
-              <a:t>• Inventário das ferramentas</a:t>
+              <a:t>• Até 5 processos mapeados</a:t>
             </a:r>
           </a:p>
           <a:p>
@@ -5945,7 +5945,7 @@
                 </a:solidFill>
                 <a:latin typeface="Calibri"/>
               </a:rPr>
-              <a:t>• Relatório de diagnóstico</a:t>
+              <a:t>• Gargalos e dependências</a:t>
             </a:r>
           </a:p>
           <a:p>
@@ -5961,7 +5961,7 @@
                 </a:solidFill>
                 <a:latin typeface="Calibri"/>
               </a:rPr>
-              <a:t>• Organograma, papéis e RACI</a:t>
+              <a:t>• Organograma e matriz de responsabilidades</a:t>
             </a:r>
           </a:p>
           <a:p>
@@ -5977,7 +5977,7 @@
                 </a:solidFill>
                 <a:latin typeface="Calibri"/>
               </a:rPr>
-              <a:t>• Escolha dos processos prioritários</a:t>
+              <a:t>• Lista priorizada de automações</a:t>
             </a:r>
           </a:p>
         </p:txBody>
@@ -5999,7 +5999,7 @@
             </a:avLst>
           </a:prstGeom>
           <a:solidFill>
-            <a:srgbClr val="E8EEF5"/>
+            <a:srgbClr val="1F3A5F"/>
           </a:solidFill>
           <a:ln>
             <a:noFill/>
@@ -6032,11 +6032,11 @@
             <a:r>
               <a:rPr sz="1500" b="1">
                 <a:solidFill>
-                  <a:srgbClr val="1F3A5F"/>
-                </a:solidFill>
-                <a:latin typeface="Calibri"/>
-              </a:rPr>
-              <a:t>Etapa 2 · semanas 5 a 8</a:t>
+                  <a:srgbClr val="FFFFFF"/>
+                </a:solidFill>
+                <a:latin typeface="Calibri"/>
+              </a:rPr>
+              <a:t>Completa (recomendada) · 8 a 9 semanas</a:t>
             </a:r>
           </a:p>
           <a:p>
@@ -6048,11 +6048,11 @@
             <a:r>
               <a:rPr sz="1500" b="0">
                 <a:solidFill>
-                  <a:srgbClr val="1F3A5F"/>
-                </a:solidFill>
-                <a:latin typeface="Calibri"/>
-              </a:rPr>
-              <a:t>• Até 4 processos mapeados</a:t>
+                  <a:srgbClr val="FFFFFF"/>
+                </a:solidFill>
+                <a:latin typeface="Calibri"/>
+              </a:rPr>
+              <a:t>• Entrevistas com até 5 pessoas</a:t>
             </a:r>
           </a:p>
           <a:p>
@@ -6064,11 +6064,11 @@
             <a:r>
               <a:rPr sz="1500" b="0">
                 <a:solidFill>
-                  <a:srgbClr val="1F3A5F"/>
-                </a:solidFill>
-                <a:latin typeface="Calibri"/>
-              </a:rPr>
-              <a:t>• Fluxos atuais e otimizados</a:t>
+                  <a:srgbClr val="FFFFFF"/>
+                </a:solidFill>
+                <a:latin typeface="Calibri"/>
+              </a:rPr>
+              <a:t>• Até 8 processos mapeados</a:t>
             </a:r>
           </a:p>
           <a:p>
@@ -6080,7 +6080,7 @@
             <a:r>
               <a:rPr sz="1500" b="0">
                 <a:solidFill>
-                  <a:srgbClr val="1F3A5F"/>
+                  <a:srgbClr val="FFFFFF"/>
                 </a:solidFill>
                 <a:latin typeface="Calibri"/>
               </a:rPr>
@@ -6096,11 +6096,11 @@
             <a:r>
               <a:rPr sz="1500" b="0">
                 <a:solidFill>
-                  <a:srgbClr val="1F3A5F"/>
-                </a:solidFill>
-                <a:latin typeface="Calibri"/>
-              </a:rPr>
-              <a:t>• Backlog de automação priorizado</a:t>
+                  <a:srgbClr val="FFFFFF"/>
+                </a:solidFill>
+                <a:latin typeface="Calibri"/>
+              </a:rPr>
+              <a:t>• Organograma atual e proposto, papéis e responsabilidades</a:t>
             </a:r>
           </a:p>
           <a:p>
@@ -6112,11 +6112,27 @@
             <a:r>
               <a:rPr sz="1500" b="0">
                 <a:solidFill>
-                  <a:srgbClr val="1F3A5F"/>
-                </a:solidFill>
-                <a:latin typeface="Calibri"/>
-              </a:rPr>
-              <a:t>• Proposta de implementação</a:t>
+                  <a:srgbClr val="FFFFFF"/>
+                </a:solidFill>
+                <a:latin typeface="Calibri"/>
+              </a:rPr>
+              <a:t>• 5 fluxos otimizados</a:t>
+            </a:r>
+          </a:p>
+          <a:p>
+            <a:pPr algn="l">
+              <a:spcAft>
+                <a:spcPts val="600"/>
+              </a:spcAft>
+            </a:pPr>
+            <a:r>
+              <a:rPr sz="1500" b="0">
+                <a:solidFill>
+                  <a:srgbClr val="FFFFFF"/>
+                </a:solidFill>
+                <a:latin typeface="Calibri"/>
+              </a:rPr>
+              <a:t>• Plano de automação com esforço estimado</a:t>
             </a:r>
           </a:p>
         </p:txBody>
@@ -6255,7 +6271,7 @@
                 </a:solidFill>
                 <a:latin typeface="Calibri"/>
               </a:rPr>
-              <a:t>Preço fechado por etapa. A implementação é orçada depois, por pacotes.</a:t>
+              <a:t>Preço fechado. A implementação é orçada depois, por pacotes.</a:t>
             </a:r>
           </a:p>
         </p:txBody>
@@ -6308,7 +6324,7 @@
         <p:spPr>
           <a:xfrm>
             <a:off x="648000" y="1908000"/>
-            <a:ext cx="3456000" cy="2340000"/>
+            <a:ext cx="5256000" cy="2340000"/>
           </a:xfrm>
           <a:prstGeom prst="roundRect">
             <a:avLst>
@@ -6353,7 +6369,7 @@
                 </a:solidFill>
                 <a:latin typeface="Calibri"/>
               </a:rPr>
-              <a:t>Etapa 1</a:t>
+              <a:t>Essencial</a:t>
             </a:r>
           </a:p>
           <a:p>
@@ -6369,7 +6385,7 @@
                 </a:solidFill>
                 <a:latin typeface="Calibri"/>
               </a:rPr>
-              <a:t>R$ 6.300</a:t>
+              <a:t>R$ 7.800</a:t>
             </a:r>
           </a:p>
           <a:p>
@@ -6385,7 +6401,7 @@
                 </a:solidFill>
                 <a:latin typeface="Calibri"/>
               </a:rPr>
-              <a:t>Diagnóstico e estrutura</a:t>
+              <a:t>50% no aceite, 50% na entrega</a:t>
             </a:r>
           </a:p>
         </p:txBody>
@@ -6398,99 +6414,8 @@
         </p:nvSpPr>
         <p:spPr>
           <a:xfrm>
-            <a:off x="4320000" y="1908000"/>
-            <a:ext cx="3456000" cy="2340000"/>
-          </a:xfrm>
-          <a:prstGeom prst="roundRect">
-            <a:avLst>
-              <a:gd name="adj" fmla="val 8000"/>
-            </a:avLst>
-          </a:prstGeom>
-          <a:solidFill>
-            <a:srgbClr val="E8EEF5"/>
-          </a:solidFill>
-          <a:ln>
-            <a:noFill/>
-          </a:ln>
-          <a:effectLst/>
-        </p:spPr>
-        <p:style>
-          <a:lnRef idx="1">
-            <a:schemeClr val="accent1"/>
-          </a:lnRef>
-          <a:fillRef idx="3">
-            <a:schemeClr val="accent1"/>
-          </a:fillRef>
-          <a:effectRef idx="2">
-            <a:schemeClr val="accent1"/>
-          </a:effectRef>
-          <a:fontRef idx="minor">
-            <a:schemeClr val="lt1"/>
-          </a:fontRef>
-        </p:style>
-        <p:txBody>
-          <a:bodyPr rtlCol="0" anchor="t" wrap="square" lIns="180000" rIns="180000" tIns="180000"/>
-          <a:lstStyle/>
-          <a:p>
-            <a:pPr algn="l">
-              <a:spcAft>
-                <a:spcPts val="600"/>
-              </a:spcAft>
-            </a:pPr>
-            <a:r>
-              <a:rPr sz="2000" b="1">
-                <a:solidFill>
-                  <a:srgbClr val="1F3A5F"/>
-                </a:solidFill>
-                <a:latin typeface="Calibri"/>
-              </a:rPr>
-              <a:t>Etapa 2</a:t>
-            </a:r>
-          </a:p>
-          <a:p>
-            <a:pPr algn="l">
-              <a:spcAft>
-                <a:spcPts val="600"/>
-              </a:spcAft>
-            </a:pPr>
-            <a:r>
-              <a:rPr sz="2000" b="1">
-                <a:solidFill>
-                  <a:srgbClr val="1F3A5F"/>
-                </a:solidFill>
-                <a:latin typeface="Calibri"/>
-              </a:rPr>
-              <a:t>R$ 6.800</a:t>
-            </a:r>
-          </a:p>
-          <a:p>
-            <a:pPr algn="l">
-              <a:spcAft>
-                <a:spcPts val="600"/>
-              </a:spcAft>
-            </a:pPr>
-            <a:r>
-              <a:rPr sz="2000" b="1">
-                <a:solidFill>
-                  <a:srgbClr val="1F3A5F"/>
-                </a:solidFill>
-                <a:latin typeface="Calibri"/>
-              </a:rPr>
-              <a:t>Mapeamento de até 4 processos</a:t>
-            </a:r>
-          </a:p>
-        </p:txBody>
-      </p:sp>
-      <p:sp>
-        <p:nvSpPr>
-          <p:cNvPr id="8" name="Rounded Rectangle 7"/>
-          <p:cNvSpPr/>
-          <p:nvPr/>
-        </p:nvSpPr>
-        <p:spPr>
-          <a:xfrm>
-            <a:off x="7992000" y="1908000"/>
-            <a:ext cx="3456000" cy="2340000"/>
+            <a:off x="6263999" y="1908000"/>
+            <a:ext cx="5256000" cy="2340000"/>
           </a:xfrm>
           <a:prstGeom prst="roundRect">
             <a:avLst>
@@ -6535,7 +6460,7 @@
                 </a:solidFill>
                 <a:latin typeface="Calibri"/>
               </a:rPr>
-              <a:t>Etapas 1 e 2</a:t>
+              <a:t>Completa (recomendada)</a:t>
             </a:r>
           </a:p>
           <a:p>
@@ -6551,7 +6476,7 @@
                 </a:solidFill>
                 <a:latin typeface="Calibri"/>
               </a:rPr>
-              <a:t>R$ 11.900</a:t>
+              <a:t>R$ 14.800</a:t>
             </a:r>
           </a:p>
           <a:p>
@@ -6567,14 +6492,14 @@
                 </a:solidFill>
                 <a:latin typeface="Calibri"/>
               </a:rPr>
-              <a:t>Contratadas juntas</a:t>
-            </a:r>
-          </a:p>
-        </p:txBody>
-      </p:sp>
-      <p:sp>
-        <p:nvSpPr>
-          <p:cNvPr id="9" name="TextBox 8"/>
+              <a:t>30% no aceite, 35% no mapeamento, 35% na entrega final</a:t>
+            </a:r>
+          </a:p>
+        </p:txBody>
+      </p:sp>
+      <p:sp>
+        <p:nvSpPr>
+          <p:cNvPr id="8" name="TextBox 7"/>
           <p:cNvSpPr txBox="1"/>
           <p:nvPr/>
         </p:nvSpPr>
@@ -6606,7 +6531,7 @@
                 </a:solidFill>
                 <a:latin typeface="Calibri"/>
               </a:rPr>
-              <a:t>50% no início e 50% na entrega de cada etapa · processo adicional R$ 1.250</a:t>
+              <a:t>A reunião inicial e esta proposta não foram cobradas.</a:t>
             </a:r>
           </a:p>
           <a:p>
@@ -6800,7 +6725,7 @@
                 </a:solidFill>
                 <a:latin typeface="Calibri"/>
               </a:rPr>
-              <a:t>1. Aceite da proposta (Etapa 1 ou Etapas 1 e 2)</a:t>
+              <a:t>1. Escolha da opção e aceite da proposta</a:t>
             </a:r>
           </a:p>
           <a:p>

</xml_diff>

<commit_message>
Proposta Surcin v2: documentos e slides atualizados com a transcrição da reunião
Co-Authored-By: Claude Opus 5.5 (1M context) <noreply@anthropic.com>
Claude-Session: https://claude.ai/code/session_0127xFh2xB8HoQ18BDMAY2QJ
</commit_message>
<xml_diff>
--- a/proposta-surcin/06-apresentacao-proposta.pptx
+++ b/proposta-surcin/06-apresentacao-proposta.pptx
@@ -13,6 +13,7 @@
     <p:sldId id="261" r:id="rId12"/>
     <p:sldId id="262" r:id="rId13"/>
     <p:sldId id="263" r:id="rId14"/>
+    <p:sldId id="264" r:id="rId15"/>
   </p:sldIdLst>
   <p:sldSz cx="12192119" cy="6858000" type="screen4x3"/>
   <p:notesSz cx="6858000" cy="9144000"/>
@@ -3211,7 +3212,7 @@
                 </a:solidFill>
                 <a:latin typeface="Calibri"/>
               </a:rPr>
-              <a:t>Proposta de consultoria para a Surcin Consultoria</a:t>
+              <a:t>Proposta de consultoria para a Surcin</a:t>
             </a:r>
           </a:p>
         </p:txBody>
@@ -3250,7 +3251,7 @@
                 </a:solidFill>
                 <a:latin typeface="Calibri"/>
               </a:rPr>
-              <a:t>Renato [sobrenome] · 15 de outubro de 2026</a:t>
+              <a:t>Renato [sobrenome] · R2 Tech Consulting · 15 de outubro de 2026</a:t>
             </a:r>
           </a:p>
         </p:txBody>
@@ -3389,7 +3390,7 @@
                 </a:solidFill>
                 <a:latin typeface="Calibri"/>
               </a:rPr>
-              <a:t>Nossa reunião de 2h30 já é o início do diagnóstico</a:t>
+              <a:t>"Eu tenho um processo. Ele só não está eficiente."</a:t>
             </a:r>
           </a:p>
         </p:txBody>
@@ -3428,7 +3429,7 @@
                 </a:solidFill>
                 <a:latin typeface="Calibri"/>
               </a:rPr>
-              <a:t>Surcin Consultoria · Proposta de consultoria · Confidencial</a:t>
+              <a:t>Surcin · Proposta de consultoria · Confidencial</a:t>
             </a:r>
           </a:p>
         </p:txBody>
@@ -3441,8 +3442,8 @@
         </p:nvSpPr>
         <p:spPr>
           <a:xfrm>
-            <a:off x="648000" y="1800000"/>
-            <a:ext cx="5220000" cy="3780000"/>
+            <a:off x="648000" y="1728000"/>
+            <a:ext cx="3456000" cy="4140000"/>
           </a:xfrm>
           <a:prstGeom prst="roundRect">
             <a:avLst>
@@ -3481,141 +3482,109 @@
               </a:spcAft>
             </a:pPr>
             <a:r>
-              <a:rPr sz="1600" b="1">
+              <a:rPr sz="1400" b="1">
                 <a:solidFill>
                   <a:srgbClr val="1F3A5F"/>
                 </a:solidFill>
                 <a:latin typeface="Calibri"/>
               </a:rPr>
-              <a:t>Áreas</a:t>
-            </a:r>
-          </a:p>
-          <a:p>
-            <a:pPr algn="l">
-              <a:spcAft>
-                <a:spcPts val="600"/>
-              </a:spcAft>
-            </a:pPr>
-            <a:r>
-              <a:rPr sz="1600" b="0">
+              <a:t>A Surcin hoje</a:t>
+            </a:r>
+          </a:p>
+          <a:p>
+            <a:pPr algn="l">
+              <a:spcAft>
+                <a:spcPts val="600"/>
+              </a:spcAft>
+            </a:pPr>
+            <a:r>
+              <a:rPr sz="1400" b="0">
                 <a:solidFill>
                   <a:srgbClr val="1F3A5F"/>
                 </a:solidFill>
                 <a:latin typeface="Calibri"/>
               </a:rPr>
-              <a:t>Departamento Pessoal</a:t>
-            </a:r>
-          </a:p>
-          <a:p>
-            <a:pPr algn="l">
-              <a:spcAft>
-                <a:spcPts val="600"/>
-              </a:spcAft>
-            </a:pPr>
-            <a:r>
-              <a:rPr sz="1600" b="0">
+              <a:t>• ~40 clientes de contabilidade</a:t>
+            </a:r>
+          </a:p>
+          <a:p>
+            <a:pPr algn="l">
+              <a:spcAft>
+                <a:spcPts val="600"/>
+              </a:spcAft>
+            </a:pPr>
+            <a:r>
+              <a:rPr sz="1400" b="0">
                 <a:solidFill>
                   <a:srgbClr val="1F3A5F"/>
                 </a:solidFill>
                 <a:latin typeface="Calibri"/>
               </a:rPr>
-              <a:t>Financeiro</a:t>
-            </a:r>
-          </a:p>
-          <a:p>
-            <a:pPr algn="l">
-              <a:spcAft>
-                <a:spcPts val="600"/>
-              </a:spcAft>
-            </a:pPr>
-            <a:r>
-              <a:rPr sz="1600" b="0">
+              <a:t>• 12 a 16 clientes de financeiro</a:t>
+            </a:r>
+          </a:p>
+          <a:p>
+            <a:pPr algn="l">
+              <a:spcAft>
+                <a:spcPts val="600"/>
+              </a:spcAft>
+            </a:pPr>
+            <a:r>
+              <a:rPr sz="1400" b="0">
                 <a:solidFill>
                   <a:srgbClr val="1F3A5F"/>
                 </a:solidFill>
                 <a:latin typeface="Calibri"/>
               </a:rPr>
-              <a:t>Contabilidade</a:t>
-            </a:r>
-          </a:p>
-          <a:p>
-            <a:pPr algn="l">
-              <a:spcAft>
-                <a:spcPts val="600"/>
-              </a:spcAft>
-            </a:pPr>
-            <a:r>
-              <a:rPr sz="1600" b="0">
+              <a:t>• DP com ~25 vidas</a:t>
+            </a:r>
+          </a:p>
+          <a:p>
+            <a:pPr algn="l">
+              <a:spcAft>
+                <a:spcPts val="600"/>
+              </a:spcAft>
+            </a:pPr>
+            <a:r>
+              <a:rPr sz="1400" b="0">
                 <a:solidFill>
                   <a:srgbClr val="1F3A5F"/>
                 </a:solidFill>
                 <a:latin typeface="Calibri"/>
               </a:rPr>
-              <a:t>Vendas</a:t>
-            </a:r>
-          </a:p>
-          <a:p>
-            <a:pPr algn="l">
-              <a:spcAft>
-                <a:spcPts val="600"/>
-              </a:spcAft>
-            </a:pPr>
-            <a:r>
-              <a:rPr sz="1600" b="0">
+              <a:t>• ~20 processos jurídicos legados</a:t>
+            </a:r>
+          </a:p>
+          <a:p>
+            <a:pPr algn="l">
+              <a:spcAft>
+                <a:spcPts val="600"/>
+              </a:spcAft>
+            </a:pPr>
+            <a:r>
+              <a:rPr sz="1400" b="0">
                 <a:solidFill>
                   <a:srgbClr val="1F3A5F"/>
                 </a:solidFill>
                 <a:latin typeface="Calibri"/>
               </a:rPr>
-              <a:t/>
-            </a:r>
-          </a:p>
-          <a:p>
-            <a:pPr algn="l">
-              <a:spcAft>
-                <a:spcPts val="600"/>
-              </a:spcAft>
-            </a:pPr>
-            <a:r>
-              <a:rPr sz="1600" b="0">
+              <a:t>• Júlia, Vitória, Tamara e Alana</a:t>
+            </a:r>
+          </a:p>
+          <a:p>
+            <a:pPr algn="l">
+              <a:spcAft>
+                <a:spcPts val="600"/>
+              </a:spcAft>
+            </a:pPr>
+            <a:r>
+              <a:rPr sz="1400" b="0">
                 <a:solidFill>
                   <a:srgbClr val="1F3A5F"/>
                 </a:solidFill>
                 <a:latin typeface="Calibri"/>
               </a:rPr>
-              <a:t>Ferramentas</a:t>
-            </a:r>
-          </a:p>
-          <a:p>
-            <a:pPr algn="l">
-              <a:spcAft>
-                <a:spcPts val="600"/>
-              </a:spcAft>
-            </a:pPr>
-            <a:r>
-              <a:rPr sz="1600" b="0">
-                <a:solidFill>
-                  <a:srgbClr val="1F3A5F"/>
-                </a:solidFill>
-                <a:latin typeface="Calibri"/>
-              </a:rPr>
-              <a:t>Conta Azul · Domínio · Veri · Jusbrasil</a:t>
-            </a:r>
-          </a:p>
-          <a:p>
-            <a:pPr algn="l">
-              <a:spcAft>
-                <a:spcPts val="600"/>
-              </a:spcAft>
-            </a:pPr>
-            <a:r>
-              <a:rPr sz="1600" b="0">
-                <a:solidFill>
-                  <a:srgbClr val="1F3A5F"/>
-                </a:solidFill>
-                <a:latin typeface="Calibri"/>
-              </a:rPr>
-              <a:t>OneDrive · Trello · NetsApp</a:t>
+              <a:t>• Trello, OneDrive, Veri, Domínio, Conta Azul</a:t>
             </a:r>
           </a:p>
         </p:txBody>
@@ -3628,8 +3597,8 @@
         </p:nvSpPr>
         <p:spPr>
           <a:xfrm>
-            <a:off x="6300000" y="1800000"/>
-            <a:ext cx="5220000" cy="3780000"/>
+            <a:off x="4356000" y="1728000"/>
+            <a:ext cx="3456000" cy="4140000"/>
           </a:xfrm>
           <a:prstGeom prst="roundRect">
             <a:avLst>
@@ -3668,93 +3637,216 @@
               </a:spcAft>
             </a:pPr>
             <a:r>
-              <a:rPr sz="1600" b="1">
+              <a:rPr sz="1400" b="1">
                 <a:solidFill>
                   <a:srgbClr val="1F3A5F"/>
                 </a:solidFill>
                 <a:latin typeface="Calibri"/>
               </a:rPr>
-              <a:t>Principais dores</a:t>
-            </a:r>
-          </a:p>
-          <a:p>
-            <a:pPr algn="l">
-              <a:spcAft>
-                <a:spcPts val="600"/>
-              </a:spcAft>
-            </a:pPr>
-            <a:r>
-              <a:rPr sz="1600" b="0">
+              <a:t>O que dói</a:t>
+            </a:r>
+          </a:p>
+          <a:p>
+            <a:pPr algn="l">
+              <a:spcAft>
+                <a:spcPts val="600"/>
+              </a:spcAft>
+            </a:pPr>
+            <a:r>
+              <a:rPr sz="1400" b="0">
                 <a:solidFill>
                   <a:srgbClr val="1F3A5F"/>
                 </a:solidFill>
                 <a:latin typeface="Calibri"/>
               </a:rPr>
-              <a:t>1. [PREENCHER com a transcrição]</a:t>
-            </a:r>
-          </a:p>
-          <a:p>
-            <a:pPr algn="l">
-              <a:spcAft>
-                <a:spcPts val="600"/>
-              </a:spcAft>
-            </a:pPr>
-            <a:r>
-              <a:rPr sz="1600" b="0">
+              <a:t>• Tudo passa por você</a:t>
+            </a:r>
+          </a:p>
+          <a:p>
+            <a:pPr algn="l">
+              <a:spcAft>
+                <a:spcPts val="600"/>
+              </a:spcAft>
+            </a:pPr>
+            <a:r>
+              <a:rPr sz="1400" b="0">
                 <a:solidFill>
                   <a:srgbClr val="1F3A5F"/>
                 </a:solidFill>
                 <a:latin typeface="Calibri"/>
               </a:rPr>
-              <a:t>2. [PREENCHER]</a:t>
-            </a:r>
-          </a:p>
-          <a:p>
-            <a:pPr algn="l">
-              <a:spcAft>
-                <a:spcPts val="600"/>
-              </a:spcAft>
-            </a:pPr>
-            <a:r>
-              <a:rPr sz="1600" b="0">
+              <a:t>• Contabilidade sem responsável técnico</a:t>
+            </a:r>
+          </a:p>
+          <a:p>
+            <a:pPr algn="l">
+              <a:spcAft>
+                <a:spcPts val="600"/>
+              </a:spcAft>
+            </a:pPr>
+            <a:r>
+              <a:rPr sz="1400" b="0">
                 <a:solidFill>
                   <a:srgbClr val="1F3A5F"/>
                 </a:solidFill>
                 <a:latin typeface="Calibri"/>
               </a:rPr>
-              <a:t>3. [PREENCHER]</a:t>
-            </a:r>
-          </a:p>
-          <a:p>
-            <a:pPr algn="l">
-              <a:spcAft>
-                <a:spcPts val="600"/>
-              </a:spcAft>
-            </a:pPr>
-            <a:r>
-              <a:rPr sz="1600" b="0">
+              <a:t>• Erro de agosto no Domínio: multa e cliente perdido</a:t>
+            </a:r>
+          </a:p>
+          <a:p>
+            <a:pPr algn="l">
+              <a:spcAft>
+                <a:spcPts val="600"/>
+              </a:spcAft>
+            </a:pPr>
+            <a:r>
+              <a:rPr sz="1400" b="0">
                 <a:solidFill>
                   <a:srgbClr val="1F3A5F"/>
                 </a:solidFill>
                 <a:latin typeface="Calibri"/>
               </a:rPr>
-              <a:t/>
-            </a:r>
-          </a:p>
-          <a:p>
-            <a:pPr algn="l">
-              <a:spcAft>
-                <a:spcPts val="600"/>
-              </a:spcAft>
-            </a:pPr>
-            <a:r>
-              <a:rPr sz="1600" b="0">
+              <a:t>• Fechamento financeiro concentrado no fim do mês</a:t>
+            </a:r>
+          </a:p>
+          <a:p>
+            <a:pPr algn="l">
+              <a:spcAft>
+                <a:spcPts val="600"/>
+              </a:spcAft>
+            </a:pPr>
+            <a:r>
+              <a:rPr sz="1400" b="0">
                 <a:solidFill>
                   <a:srgbClr val="1F3A5F"/>
                 </a:solidFill>
                 <a:latin typeface="Calibri"/>
               </a:rPr>
-              <a:t>Objetivo: organizar e automatizar os processos do escritório</a:t>
+              <a:t>• Sem métricas para premiar a equipe</a:t>
+            </a:r>
+          </a:p>
+        </p:txBody>
+      </p:sp>
+      <p:sp>
+        <p:nvSpPr>
+          <p:cNvPr id="8" name="Rounded Rectangle 7"/>
+          <p:cNvSpPr/>
+          <p:nvPr/>
+        </p:nvSpPr>
+        <p:spPr>
+          <a:xfrm>
+            <a:off x="8063999" y="1728000"/>
+            <a:ext cx="3456000" cy="4140000"/>
+          </a:xfrm>
+          <a:prstGeom prst="roundRect">
+            <a:avLst>
+              <a:gd name="adj" fmla="val 8000"/>
+            </a:avLst>
+          </a:prstGeom>
+          <a:solidFill>
+            <a:srgbClr val="1F3A5F"/>
+          </a:solidFill>
+          <a:ln>
+            <a:noFill/>
+          </a:ln>
+          <a:effectLst/>
+        </p:spPr>
+        <p:style>
+          <a:lnRef idx="1">
+            <a:schemeClr val="accent1"/>
+          </a:lnRef>
+          <a:fillRef idx="3">
+            <a:schemeClr val="accent1"/>
+          </a:fillRef>
+          <a:effectRef idx="2">
+            <a:schemeClr val="accent1"/>
+          </a:effectRef>
+          <a:fontRef idx="minor">
+            <a:schemeClr val="lt1"/>
+          </a:fontRef>
+        </p:style>
+        <p:txBody>
+          <a:bodyPr rtlCol="0" anchor="t" wrap="square" lIns="180000" rIns="180000" tIns="180000"/>
+          <a:lstStyle/>
+          <a:p>
+            <a:pPr algn="l">
+              <a:spcAft>
+                <a:spcPts val="600"/>
+              </a:spcAft>
+            </a:pPr>
+            <a:r>
+              <a:rPr sz="1400" b="1">
+                <a:solidFill>
+                  <a:srgbClr val="FFFFFF"/>
+                </a:solidFill>
+                <a:latin typeface="Calibri"/>
+              </a:rPr>
+              <a:t>O que você quer</a:t>
+            </a:r>
+          </a:p>
+          <a:p>
+            <a:pPr algn="l">
+              <a:spcAft>
+                <a:spcPts val="600"/>
+              </a:spcAft>
+            </a:pPr>
+            <a:r>
+              <a:rPr sz="1400" b="0">
+                <a:solidFill>
+                  <a:srgbClr val="FFFFFF"/>
+                </a:solidFill>
+                <a:latin typeface="Calibri"/>
+              </a:rPr>
+              <a:t>• Equipe com autonomia</a:t>
+            </a:r>
+          </a:p>
+          <a:p>
+            <a:pPr algn="l">
+              <a:spcAft>
+                <a:spcPts val="600"/>
+              </a:spcAft>
+            </a:pPr>
+            <a:r>
+              <a:rPr sz="1400" b="0">
+                <a:solidFill>
+                  <a:srgbClr val="FFFFFF"/>
+                </a:solidFill>
+                <a:latin typeface="Calibri"/>
+              </a:rPr>
+              <a:t>• Escalar com as mesmas pessoas</a:t>
+            </a:r>
+          </a:p>
+          <a:p>
+            <a:pPr algn="l">
+              <a:spcAft>
+                <a:spcPts val="600"/>
+              </a:spcAft>
+            </a:pPr>
+            <a:r>
+              <a:rPr sz="1400" b="0">
+                <a:solidFill>
+                  <a:srgbClr val="FFFFFF"/>
+                </a:solidFill>
+                <a:latin typeface="Calibri"/>
+              </a:rPr>
+              <a:t>• Tempo para a prova de 13/12</a:t>
+            </a:r>
+          </a:p>
+          <a:p>
+            <a:pPr algn="l">
+              <a:spcAft>
+                <a:spcPts val="600"/>
+              </a:spcAft>
+            </a:pPr>
+            <a:r>
+              <a:rPr sz="1400" b="0">
+                <a:solidFill>
+                  <a:srgbClr val="FFFFFF"/>
+                </a:solidFill>
+                <a:latin typeface="Calibri"/>
+              </a:rPr>
+              <a:t>• Entrar em 2027 pronta para contratar e vender</a:t>
             </a:r>
           </a:p>
         </p:txBody>
@@ -3893,7 +3985,7 @@
                 </a:solidFill>
                 <a:latin typeface="Calibri"/>
               </a:rPr>
-              <a:t>Entender antes de automatizar. Cada etapa termina com uma entrega e uma decisão sua.</a:t>
+              <a:t>Partir do que você já construiu. Entender antes de automatizar.</a:t>
             </a:r>
           </a:p>
         </p:txBody>
@@ -3932,7 +4024,7 @@
                 </a:solidFill>
                 <a:latin typeface="Calibri"/>
               </a:rPr>
-              <a:t>Surcin Consultoria · Proposta de consultoria · Confidencial</a:t>
+              <a:t>Surcin · Proposta de consultoria · Confidencial</a:t>
             </a:r>
           </a:p>
         </p:txBody>
@@ -4606,7 +4698,7 @@
                 </a:solidFill>
                 <a:latin typeface="Calibri"/>
               </a:rPr>
-              <a:t>Exemplo do entregável · hipótese inicial para validarmos juntas</a:t>
+              <a:t>Hipótese para validarmos juntas: organizar pelo caminho do cliente</a:t>
             </a:r>
           </a:p>
         </p:txBody>
@@ -4645,7 +4737,7 @@
                 </a:solidFill>
                 <a:latin typeface="Calibri"/>
               </a:rPr>
-              <a:t>Surcin Consultoria · Proposta de consultoria · Confidencial</a:t>
+              <a:t>Surcin · Proposta de consultoria · Confidencial</a:t>
             </a:r>
           </a:p>
         </p:txBody>
@@ -4658,7 +4750,7 @@
         </p:nvSpPr>
         <p:spPr>
           <a:xfrm>
-            <a:off x="4464000" y="1728000"/>
+            <a:off x="4464000" y="1620000"/>
             <a:ext cx="3240000" cy="648000"/>
           </a:xfrm>
           <a:prstGeom prst="roundRect">
@@ -4717,8 +4809,8 @@
         </p:nvSpPr>
         <p:spPr>
           <a:xfrm>
-            <a:off x="648000" y="2951999"/>
-            <a:ext cx="2052000" cy="864000"/>
+            <a:off x="648000" y="2736000"/>
+            <a:ext cx="2052000" cy="936000"/>
           </a:xfrm>
           <a:prstGeom prst="roundRect">
             <a:avLst>
@@ -4763,7 +4855,7 @@
                 </a:solidFill>
                 <a:latin typeface="Calibri"/>
               </a:rPr>
-              <a:t>Departamento Pessoal</a:t>
+              <a:t>Revisão técnica</a:t>
             </a:r>
           </a:p>
           <a:p>
@@ -4779,7 +4871,7 @@
                 </a:solidFill>
                 <a:latin typeface="Calibri"/>
               </a:rPr>
-              <a:t>Responsável: ?</a:t>
+              <a:t>Contador(a) em 2027</a:t>
             </a:r>
           </a:p>
         </p:txBody>
@@ -4792,8 +4884,8 @@
         </p:nvSpPr>
         <p:spPr>
           <a:xfrm>
-            <a:off x="2844000" y="2951999"/>
-            <a:ext cx="2052000" cy="864000"/>
+            <a:off x="2844000" y="2736000"/>
+            <a:ext cx="2052000" cy="936000"/>
           </a:xfrm>
           <a:prstGeom prst="roundRect">
             <a:avLst>
@@ -4838,7 +4930,7 @@
                 </a:solidFill>
                 <a:latin typeface="Calibri"/>
               </a:rPr>
-              <a:t>Contabilidade e Fiscal</a:t>
+              <a:t>Entrada e relacionamento</a:t>
             </a:r>
           </a:p>
           <a:p>
@@ -4854,7 +4946,7 @@
                 </a:solidFill>
                 <a:latin typeface="Calibri"/>
               </a:rPr>
-              <a:t>Responsável: ?</a:t>
+              <a:t>Júlia</a:t>
             </a:r>
           </a:p>
         </p:txBody>
@@ -4867,8 +4959,8 @@
         </p:nvSpPr>
         <p:spPr>
           <a:xfrm>
-            <a:off x="5040000" y="2951999"/>
-            <a:ext cx="2052000" cy="864000"/>
+            <a:off x="5040000" y="2736000"/>
+            <a:ext cx="2052000" cy="936000"/>
           </a:xfrm>
           <a:prstGeom prst="roundRect">
             <a:avLst>
@@ -4929,7 +5021,7 @@
                 </a:solidFill>
                 <a:latin typeface="Calibri"/>
               </a:rPr>
-              <a:t>Responsável: ?</a:t>
+              <a:t>Vitória</a:t>
             </a:r>
           </a:p>
         </p:txBody>
@@ -4942,8 +5034,8 @@
         </p:nvSpPr>
         <p:spPr>
           <a:xfrm>
-            <a:off x="7235999" y="2951999"/>
-            <a:ext cx="2052000" cy="864000"/>
+            <a:off x="7235999" y="2736000"/>
+            <a:ext cx="2052000" cy="936000"/>
           </a:xfrm>
           <a:prstGeom prst="roundRect">
             <a:avLst>
@@ -4988,7 +5080,7 @@
                 </a:solidFill>
                 <a:latin typeface="Calibri"/>
               </a:rPr>
-              <a:t>Comercial / Vendas</a:t>
+              <a:t>Departamento Pessoal</a:t>
             </a:r>
           </a:p>
           <a:p>
@@ -5004,7 +5096,7 @@
                 </a:solidFill>
                 <a:latin typeface="Calibri"/>
               </a:rPr>
-              <a:t>Responsável: ?</a:t>
+              <a:t>Tamara</a:t>
             </a:r>
           </a:p>
         </p:txBody>
@@ -5017,8 +5109,8 @@
         </p:nvSpPr>
         <p:spPr>
           <a:xfrm>
-            <a:off x="9432000" y="2951999"/>
-            <a:ext cx="2052000" cy="864000"/>
+            <a:off x="9432000" y="2736000"/>
+            <a:ext cx="2052000" cy="936000"/>
           </a:xfrm>
           <a:prstGeom prst="roundRect">
             <a:avLst>
@@ -5063,7 +5155,7 @@
                 </a:solidFill>
                 <a:latin typeface="Calibri"/>
               </a:rPr>
-              <a:t>Apoio adm. [?]</a:t>
+              <a:t>Jurídico</a:t>
             </a:r>
           </a:p>
           <a:p>
@@ -5079,7 +5171,7 @@
                 </a:solidFill>
                 <a:latin typeface="Calibri"/>
               </a:rPr>
-              <a:t>Responsável: ?</a:t>
+              <a:t>Legado: a decidir</a:t>
             </a:r>
           </a:p>
         </p:txBody>
@@ -5092,8 +5184,8 @@
         </p:nvSpPr>
         <p:spPr>
           <a:xfrm>
-            <a:off x="648000" y="4248000"/>
-            <a:ext cx="10800000" cy="1620000"/>
+            <a:off x="648000" y="4068000"/>
+            <a:ext cx="10800000" cy="1800000"/>
           </a:xfrm>
           <a:prstGeom prst="rect">
             <a:avLst/>
@@ -5118,7 +5210,23 @@
                 </a:solidFill>
                 <a:latin typeface="Calibri"/>
               </a:rPr>
-              <a:t>Entregável da Etapa 2: organograma atual e proposto, papéis e responsabilidades por área, matriz RACI (quem executa, aprova, é consultado e informado) e as dependências da Direção.</a:t>
+              <a:t>Entregável: organograma atual e proposto, papéis, responsabilidades e indicadores por função.</a:t>
+            </a:r>
+          </a:p>
+          <a:p>
+            <a:pPr algn="l">
+              <a:spcAft>
+                <a:spcPts val="600"/>
+              </a:spcAft>
+            </a:pPr>
+            <a:r>
+              <a:rPr sz="1500" b="0">
+                <a:solidFill>
+                  <a:srgbClr val="595959"/>
+                </a:solidFill>
+                <a:latin typeface="Calibri"/>
+              </a:rPr>
+              <a:t>É a base para delegar revisões, receber o(a) contador(a) e criar a remuneração por pontos.</a:t>
             </a:r>
           </a:p>
         </p:txBody>
@@ -5218,7 +5326,7 @@
                 </a:solidFill>
                 <a:latin typeface="Calibri"/>
               </a:rPr>
-              <a:t>Mapeamento de processos</a:t>
+              <a:t>Processos identificados</a:t>
             </a:r>
           </a:p>
         </p:txBody>
@@ -5257,7 +5365,7 @@
                 </a:solidFill>
                 <a:latin typeface="Calibri"/>
               </a:rPr>
-              <a:t>Quatro passos, sempre ouvindo quem executa</a:t>
+              <a:t>11 processos; a prioridade inicial é onde há mais risco e mais tempo gasto</a:t>
             </a:r>
           </a:p>
         </p:txBody>
@@ -5296,7 +5404,7 @@
                 </a:solidFill>
                 <a:latin typeface="Calibri"/>
               </a:rPr>
-              <a:t>Surcin Consultoria · Proposta de consultoria · Confidencial</a:t>
+              <a:t>Surcin · Proposta de consultoria · Confidencial</a:t>
             </a:r>
           </a:p>
         </p:txBody>
@@ -5309,8 +5417,179 @@
         </p:nvSpPr>
         <p:spPr>
           <a:xfrm>
-            <a:off x="648000" y="1980000"/>
-            <a:ext cx="2592000" cy="2880000"/>
+            <a:off x="648000" y="1728000"/>
+            <a:ext cx="5220000" cy="4140000"/>
+          </a:xfrm>
+          <a:prstGeom prst="roundRect">
+            <a:avLst>
+              <a:gd name="adj" fmla="val 8000"/>
+            </a:avLst>
+          </a:prstGeom>
+          <a:solidFill>
+            <a:srgbClr val="1F3A5F"/>
+          </a:solidFill>
+          <a:ln>
+            <a:noFill/>
+          </a:ln>
+          <a:effectLst/>
+        </p:spPr>
+        <p:style>
+          <a:lnRef idx="1">
+            <a:schemeClr val="accent1"/>
+          </a:lnRef>
+          <a:fillRef idx="3">
+            <a:schemeClr val="accent1"/>
+          </a:fillRef>
+          <a:effectRef idx="2">
+            <a:schemeClr val="accent1"/>
+          </a:effectRef>
+          <a:fontRef idx="minor">
+            <a:schemeClr val="lt1"/>
+          </a:fontRef>
+        </p:style>
+        <p:txBody>
+          <a:bodyPr rtlCol="0" anchor="t" wrap="square" lIns="180000" rIns="180000" tIns="180000"/>
+          <a:lstStyle/>
+          <a:p>
+            <a:pPr algn="l">
+              <a:spcAft>
+                <a:spcPts val="600"/>
+              </a:spcAft>
+            </a:pPr>
+            <a:r>
+              <a:rPr sz="1500" b="1">
+                <a:solidFill>
+                  <a:srgbClr val="FFFFFF"/>
+                </a:solidFill>
+                <a:latin typeface="Calibri"/>
+              </a:rPr>
+              <a:t>Prioridade 1</a:t>
+            </a:r>
+          </a:p>
+          <a:p>
+            <a:pPr algn="l">
+              <a:spcAft>
+                <a:spcPts val="600"/>
+              </a:spcAft>
+            </a:pPr>
+            <a:r>
+              <a:rPr sz="1500" b="0">
+                <a:solidFill>
+                  <a:srgbClr val="FFFFFF"/>
+                </a:solidFill>
+                <a:latin typeface="Calibri"/>
+              </a:rPr>
+              <a:t>• Fiscal mensal (44 clientes, risco de multa)</a:t>
+            </a:r>
+          </a:p>
+          <a:p>
+            <a:pPr algn="l">
+              <a:spcAft>
+                <a:spcPts val="600"/>
+              </a:spcAft>
+            </a:pPr>
+            <a:r>
+              <a:rPr sz="1500" b="0">
+                <a:solidFill>
+                  <a:srgbClr val="FFFFFF"/>
+                </a:solidFill>
+                <a:latin typeface="Calibri"/>
+              </a:rPr>
+              <a:t>• Conciliação e fechamento financeiro</a:t>
+            </a:r>
+          </a:p>
+          <a:p>
+            <a:pPr algn="l">
+              <a:spcAft>
+                <a:spcPts val="600"/>
+              </a:spcAft>
+            </a:pPr>
+            <a:r>
+              <a:rPr sz="1500" b="0">
+                <a:solidFill>
+                  <a:srgbClr val="FFFFFF"/>
+                </a:solidFill>
+                <a:latin typeface="Calibri"/>
+              </a:rPr>
+              <a:t/>
+            </a:r>
+          </a:p>
+          <a:p>
+            <a:pPr algn="l">
+              <a:spcAft>
+                <a:spcPts val="600"/>
+              </a:spcAft>
+            </a:pPr>
+            <a:r>
+              <a:rPr sz="1500" b="0">
+                <a:solidFill>
+                  <a:srgbClr val="FFFFFF"/>
+                </a:solidFill>
+                <a:latin typeface="Calibri"/>
+              </a:rPr>
+              <a:t>Prioridade 2</a:t>
+            </a:r>
+          </a:p>
+          <a:p>
+            <a:pPr algn="l">
+              <a:spcAft>
+                <a:spcPts val="600"/>
+              </a:spcAft>
+            </a:pPr>
+            <a:r>
+              <a:rPr sz="1500" b="0">
+                <a:solidFill>
+                  <a:srgbClr val="FFFFFF"/>
+                </a:solidFill>
+                <a:latin typeface="Calibri"/>
+              </a:rPr>
+              <a:t>• Implantação de novos clientes</a:t>
+            </a:r>
+          </a:p>
+          <a:p>
+            <a:pPr algn="l">
+              <a:spcAft>
+                <a:spcPts val="600"/>
+              </a:spcAft>
+            </a:pPr>
+            <a:r>
+              <a:rPr sz="1500" b="0">
+                <a:solidFill>
+                  <a:srgbClr val="FFFFFF"/>
+                </a:solidFill>
+                <a:latin typeface="Calibri"/>
+              </a:rPr>
+              <a:t>• Atendimento e triagem</a:t>
+            </a:r>
+          </a:p>
+          <a:p>
+            <a:pPr algn="l">
+              <a:spcAft>
+                <a:spcPts val="600"/>
+              </a:spcAft>
+            </a:pPr>
+            <a:r>
+              <a:rPr sz="1500" b="0">
+                <a:solidFill>
+                  <a:srgbClr val="FFFFFF"/>
+                </a:solidFill>
+                <a:latin typeface="Calibri"/>
+              </a:rPr>
+              <a:t>• Emissão de notas</a:t>
+            </a:r>
+          </a:p>
+        </p:txBody>
+      </p:sp>
+      <p:sp>
+        <p:nvSpPr>
+          <p:cNvPr id="7" name="Rounded Rectangle 6"/>
+          <p:cNvSpPr/>
+          <p:nvPr/>
+        </p:nvSpPr>
+        <p:spPr>
+          <a:xfrm>
+            <a:off x="6300000" y="1728000"/>
+            <a:ext cx="5220000" cy="4140000"/>
           </a:xfrm>
           <a:prstGeom prst="roundRect">
             <a:avLst>
@@ -5355,7 +5634,7 @@
                 </a:solidFill>
                 <a:latin typeface="Calibri"/>
               </a:rPr>
-              <a:t>1. Ouvir</a:t>
+              <a:t>Prioridade 3</a:t>
             </a:r>
           </a:p>
           <a:p>
@@ -5371,6 +5650,86 @@
                 </a:solidFill>
                 <a:latin typeface="Calibri"/>
               </a:rPr>
+              <a:t>• Pagamentos dos clientes do financeiro</a:t>
+            </a:r>
+          </a:p>
+          <a:p>
+            <a:pPr algn="l">
+              <a:spcAft>
+                <a:spcPts val="600"/>
+              </a:spcAft>
+            </a:pPr>
+            <a:r>
+              <a:rPr sz="1500" b="0">
+                <a:solidFill>
+                  <a:srgbClr val="1F3A5F"/>
+                </a:solidFill>
+                <a:latin typeface="Calibri"/>
+              </a:rPr>
+              <a:t>• Folha e DP</a:t>
+            </a:r>
+          </a:p>
+          <a:p>
+            <a:pPr algn="l">
+              <a:spcAft>
+                <a:spcPts val="600"/>
+              </a:spcAft>
+            </a:pPr>
+            <a:r>
+              <a:rPr sz="1500" b="0">
+                <a:solidFill>
+                  <a:srgbClr val="1F3A5F"/>
+                </a:solidFill>
+                <a:latin typeface="Calibri"/>
+              </a:rPr>
+              <a:t>• Comercial</a:t>
+            </a:r>
+          </a:p>
+          <a:p>
+            <a:pPr algn="l">
+              <a:spcAft>
+                <a:spcPts val="600"/>
+              </a:spcAft>
+            </a:pPr>
+            <a:r>
+              <a:rPr sz="1500" b="0">
+                <a:solidFill>
+                  <a:srgbClr val="1F3A5F"/>
+                </a:solidFill>
+                <a:latin typeface="Calibri"/>
+              </a:rPr>
+              <a:t>• Abertura de empresa</a:t>
+            </a:r>
+          </a:p>
+          <a:p>
+            <a:pPr algn="l">
+              <a:spcAft>
+                <a:spcPts val="600"/>
+              </a:spcAft>
+            </a:pPr>
+            <a:r>
+              <a:rPr sz="1500" b="0">
+                <a:solidFill>
+                  <a:srgbClr val="1F3A5F"/>
+                </a:solidFill>
+                <a:latin typeface="Calibri"/>
+              </a:rPr>
+              <a:t>• Acompanhamento jurídico</a:t>
+            </a:r>
+          </a:p>
+          <a:p>
+            <a:pPr algn="l">
+              <a:spcAft>
+                <a:spcPts val="600"/>
+              </a:spcAft>
+            </a:pPr>
+            <a:r>
+              <a:rPr sz="1500" b="0">
+                <a:solidFill>
+                  <a:srgbClr val="1F3A5F"/>
+                </a:solidFill>
+                <a:latin typeface="Calibri"/>
+              </a:rPr>
               <a:t/>
             </a:r>
           </a:p>
@@ -5387,280 +5746,7 @@
                 </a:solidFill>
                 <a:latin typeface="Calibri"/>
               </a:rPr>
-              <a:t>Entrevistas de 45 a 60 min com a equipe: insumos, passos, sistemas, esperas</a:t>
-            </a:r>
-          </a:p>
-        </p:txBody>
-      </p:sp>
-      <p:sp>
-        <p:nvSpPr>
-          <p:cNvPr id="7" name="Rounded Rectangle 6"/>
-          <p:cNvSpPr/>
-          <p:nvPr/>
-        </p:nvSpPr>
-        <p:spPr>
-          <a:xfrm>
-            <a:off x="3384000" y="1980000"/>
-            <a:ext cx="2592000" cy="2880000"/>
-          </a:xfrm>
-          <a:prstGeom prst="roundRect">
-            <a:avLst>
-              <a:gd name="adj" fmla="val 8000"/>
-            </a:avLst>
-          </a:prstGeom>
-          <a:solidFill>
-            <a:srgbClr val="E8EEF5"/>
-          </a:solidFill>
-          <a:ln>
-            <a:noFill/>
-          </a:ln>
-          <a:effectLst/>
-        </p:spPr>
-        <p:style>
-          <a:lnRef idx="1">
-            <a:schemeClr val="accent1"/>
-          </a:lnRef>
-          <a:fillRef idx="3">
-            <a:schemeClr val="accent1"/>
-          </a:fillRef>
-          <a:effectRef idx="2">
-            <a:schemeClr val="accent1"/>
-          </a:effectRef>
-          <a:fontRef idx="minor">
-            <a:schemeClr val="lt1"/>
-          </a:fontRef>
-        </p:style>
-        <p:txBody>
-          <a:bodyPr rtlCol="0" anchor="t" wrap="square" lIns="180000" rIns="180000" tIns="180000"/>
-          <a:lstStyle/>
-          <a:p>
-            <a:pPr algn="l">
-              <a:spcAft>
-                <a:spcPts val="600"/>
-              </a:spcAft>
-            </a:pPr>
-            <a:r>
-              <a:rPr sz="1500" b="1">
-                <a:solidFill>
-                  <a:srgbClr val="1F3A5F"/>
-                </a:solidFill>
-                <a:latin typeface="Calibri"/>
-              </a:rPr>
-              <a:t>2. Desenhar</a:t>
-            </a:r>
-          </a:p>
-          <a:p>
-            <a:pPr algn="l">
-              <a:spcAft>
-                <a:spcPts val="600"/>
-              </a:spcAft>
-            </a:pPr>
-            <a:r>
-              <a:rPr sz="1500" b="0">
-                <a:solidFill>
-                  <a:srgbClr val="1F3A5F"/>
-                </a:solidFill>
-                <a:latin typeface="Calibri"/>
-              </a:rPr>
-              <a:t/>
-            </a:r>
-          </a:p>
-          <a:p>
-            <a:pPr algn="l">
-              <a:spcAft>
-                <a:spcPts val="600"/>
-              </a:spcAft>
-            </a:pPr>
-            <a:r>
-              <a:rPr sz="1500" b="0">
-                <a:solidFill>
-                  <a:srgbClr val="1F3A5F"/>
-                </a:solidFill>
-                <a:latin typeface="Calibri"/>
-              </a:rPr>
-              <a:t>Fluxo atual em raias, validado por quem faz</a:t>
-            </a:r>
-          </a:p>
-        </p:txBody>
-      </p:sp>
-      <p:sp>
-        <p:nvSpPr>
-          <p:cNvPr id="8" name="Rounded Rectangle 7"/>
-          <p:cNvSpPr/>
-          <p:nvPr/>
-        </p:nvSpPr>
-        <p:spPr>
-          <a:xfrm>
-            <a:off x="6120000" y="1980000"/>
-            <a:ext cx="2592000" cy="2880000"/>
-          </a:xfrm>
-          <a:prstGeom prst="roundRect">
-            <a:avLst>
-              <a:gd name="adj" fmla="val 8000"/>
-            </a:avLst>
-          </a:prstGeom>
-          <a:solidFill>
-            <a:srgbClr val="E8EEF5"/>
-          </a:solidFill>
-          <a:ln>
-            <a:noFill/>
-          </a:ln>
-          <a:effectLst/>
-        </p:spPr>
-        <p:style>
-          <a:lnRef idx="1">
-            <a:schemeClr val="accent1"/>
-          </a:lnRef>
-          <a:fillRef idx="3">
-            <a:schemeClr val="accent1"/>
-          </a:fillRef>
-          <a:effectRef idx="2">
-            <a:schemeClr val="accent1"/>
-          </a:effectRef>
-          <a:fontRef idx="minor">
-            <a:schemeClr val="lt1"/>
-          </a:fontRef>
-        </p:style>
-        <p:txBody>
-          <a:bodyPr rtlCol="0" anchor="t" wrap="square" lIns="180000" rIns="180000" tIns="180000"/>
-          <a:lstStyle/>
-          <a:p>
-            <a:pPr algn="l">
-              <a:spcAft>
-                <a:spcPts val="600"/>
-              </a:spcAft>
-            </a:pPr>
-            <a:r>
-              <a:rPr sz="1500" b="1">
-                <a:solidFill>
-                  <a:srgbClr val="1F3A5F"/>
-                </a:solidFill>
-                <a:latin typeface="Calibri"/>
-              </a:rPr>
-              <a:t>3. Encontrar gargalos</a:t>
-            </a:r>
-          </a:p>
-          <a:p>
-            <a:pPr algn="l">
-              <a:spcAft>
-                <a:spcPts val="600"/>
-              </a:spcAft>
-            </a:pPr>
-            <a:r>
-              <a:rPr sz="1500" b="0">
-                <a:solidFill>
-                  <a:srgbClr val="1F3A5F"/>
-                </a:solidFill>
-                <a:latin typeface="Calibri"/>
-              </a:rPr>
-              <a:t/>
-            </a:r>
-          </a:p>
-          <a:p>
-            <a:pPr algn="l">
-              <a:spcAft>
-                <a:spcPts val="600"/>
-              </a:spcAft>
-            </a:pPr>
-            <a:r>
-              <a:rPr sz="1500" b="0">
-                <a:solidFill>
-                  <a:srgbClr val="1F3A5F"/>
-                </a:solidFill>
-                <a:latin typeface="Calibri"/>
-              </a:rPr>
-              <a:t>Esperas, retrabalho, aprovações concentradas, dependências</a:t>
-            </a:r>
-          </a:p>
-        </p:txBody>
-      </p:sp>
-      <p:sp>
-        <p:nvSpPr>
-          <p:cNvPr id="9" name="Rounded Rectangle 8"/>
-          <p:cNvSpPr/>
-          <p:nvPr/>
-        </p:nvSpPr>
-        <p:spPr>
-          <a:xfrm>
-            <a:off x="8856000" y="1980000"/>
-            <a:ext cx="2592000" cy="2880000"/>
-          </a:xfrm>
-          <a:prstGeom prst="roundRect">
-            <a:avLst>
-              <a:gd name="adj" fmla="val 8000"/>
-            </a:avLst>
-          </a:prstGeom>
-          <a:solidFill>
-            <a:srgbClr val="E8EEF5"/>
-          </a:solidFill>
-          <a:ln>
-            <a:noFill/>
-          </a:ln>
-          <a:effectLst/>
-        </p:spPr>
-        <p:style>
-          <a:lnRef idx="1">
-            <a:schemeClr val="accent1"/>
-          </a:lnRef>
-          <a:fillRef idx="3">
-            <a:schemeClr val="accent1"/>
-          </a:fillRef>
-          <a:effectRef idx="2">
-            <a:schemeClr val="accent1"/>
-          </a:effectRef>
-          <a:fontRef idx="minor">
-            <a:schemeClr val="lt1"/>
-          </a:fontRef>
-        </p:style>
-        <p:txBody>
-          <a:bodyPr rtlCol="0" anchor="t" wrap="square" lIns="180000" rIns="180000" tIns="180000"/>
-          <a:lstStyle/>
-          <a:p>
-            <a:pPr algn="l">
-              <a:spcAft>
-                <a:spcPts val="600"/>
-              </a:spcAft>
-            </a:pPr>
-            <a:r>
-              <a:rPr sz="1500" b="1">
-                <a:solidFill>
-                  <a:srgbClr val="1F3A5F"/>
-                </a:solidFill>
-                <a:latin typeface="Calibri"/>
-              </a:rPr>
-              <a:t>4. Otimizar</a:t>
-            </a:r>
-          </a:p>
-          <a:p>
-            <a:pPr algn="l">
-              <a:spcAft>
-                <a:spcPts val="600"/>
-              </a:spcAft>
-            </a:pPr>
-            <a:r>
-              <a:rPr sz="1500" b="0">
-                <a:solidFill>
-                  <a:srgbClr val="1F3A5F"/>
-                </a:solidFill>
-                <a:latin typeface="Calibri"/>
-              </a:rPr>
-              <a:t/>
-            </a:r>
-          </a:p>
-          <a:p>
-            <a:pPr algn="l">
-              <a:spcAft>
-                <a:spcPts val="600"/>
-              </a:spcAft>
-            </a:pPr>
-            <a:r>
-              <a:rPr sz="1500" b="0">
-                <a:solidFill>
-                  <a:srgbClr val="1F3A5F"/>
-                </a:solidFill>
-                <a:latin typeface="Calibri"/>
-              </a:rPr>
-              <a:t>Simplificar primeiro, depois listar automações com esforço e ganho</a:t>
+              <a:t>Escolha final na primeira semana, com você.</a:t>
             </a:r>
           </a:p>
         </p:txBody>
@@ -5838,7 +5924,7 @@
                 </a:solidFill>
                 <a:latin typeface="Calibri"/>
               </a:rPr>
-              <a:t>Surcin Consultoria · Proposta de consultoria · Confidencial</a:t>
+              <a:t>Surcin · Proposta de consultoria · Confidencial</a:t>
             </a:r>
           </a:p>
         </p:txBody>
@@ -5897,7 +5983,7 @@
                 </a:solidFill>
                 <a:latin typeface="Calibri"/>
               </a:rPr>
-              <a:t>Essencial · 4 a 5 semanas</a:t>
+              <a:t>Essencial · 19/10 a ~22/11</a:t>
             </a:r>
           </a:p>
           <a:p>
@@ -5913,7 +5999,7 @@
                 </a:solidFill>
                 <a:latin typeface="Calibri"/>
               </a:rPr>
-              <a:t>• Entrevistas com até 4 pessoas</a:t>
+              <a:t>• Entrevistas com 4 pessoas</a:t>
             </a:r>
           </a:p>
           <a:p>
@@ -6036,7 +6122,7 @@
                 </a:solidFill>
                 <a:latin typeface="Calibri"/>
               </a:rPr>
-              <a:t>Completa (recomendada) · 8 a 9 semanas</a:t>
+              <a:t>Completa (recomendada) · 19/10 a 18/12</a:t>
             </a:r>
           </a:p>
           <a:p>
@@ -6100,7 +6186,7 @@
                 </a:solidFill>
                 <a:latin typeface="Calibri"/>
               </a:rPr>
-              <a:t>• Organograma atual e proposto, papéis e responsabilidades</a:t>
+              <a:t>• Organograma, papéis e indicadores</a:t>
             </a:r>
           </a:p>
           <a:p>
@@ -6132,7 +6218,7 @@
                 </a:solidFill>
                 <a:latin typeface="Calibri"/>
               </a:rPr>
-              <a:t>• Plano de automação com esforço estimado</a:t>
+              <a:t>• Plano de automação com esforço e custo</a:t>
             </a:r>
           </a:p>
         </p:txBody>
@@ -6232,7 +6318,7 @@
                 </a:solidFill>
                 <a:latin typeface="Calibri"/>
               </a:rPr>
-              <a:t>Investimento</a:t>
+              <a:t>Cronograma</a:t>
             </a:r>
           </a:p>
         </p:txBody>
@@ -6271,7 +6357,7 @@
                 </a:solidFill>
                 <a:latin typeface="Calibri"/>
               </a:rPr>
-              <a:t>Preço fechado. A implementação é orçada depois, por pacotes.</a:t>
+              <a:t>Cerca de 7 horas suas no total, sem reuniões na semana dos fechamentos nem na semana da prova</a:t>
             </a:r>
           </a:p>
         </p:txBody>
@@ -6310,7 +6396,7 @@
                 </a:solidFill>
                 <a:latin typeface="Calibri"/>
               </a:rPr>
-              <a:t>Surcin Consultoria · Proposta de consultoria · Confidencial</a:t>
+              <a:t>Surcin · Proposta de consultoria · Confidencial</a:t>
             </a:r>
           </a:p>
         </p:txBody>
@@ -6323,8 +6409,8 @@
         </p:nvSpPr>
         <p:spPr>
           <a:xfrm>
-            <a:off x="648000" y="1908000"/>
-            <a:ext cx="5256000" cy="2340000"/>
+            <a:off x="648000" y="2160000"/>
+            <a:ext cx="1710000" cy="1980000"/>
           </a:xfrm>
           <a:prstGeom prst="roundRect">
             <a:avLst>
@@ -6363,45 +6449,29 @@
               </a:spcAft>
             </a:pPr>
             <a:r>
-              <a:rPr sz="2000" b="1">
+              <a:rPr sz="1500" b="1">
                 <a:solidFill>
                   <a:srgbClr val="1F3A5F"/>
                 </a:solidFill>
                 <a:latin typeface="Calibri"/>
               </a:rPr>
-              <a:t>Essencial</a:t>
-            </a:r>
-          </a:p>
-          <a:p>
-            <a:pPr algn="l">
-              <a:spcAft>
-                <a:spcPts val="600"/>
-              </a:spcAft>
-            </a:pPr>
-            <a:r>
-              <a:rPr sz="2000" b="1">
+              <a:t>19/10</a:t>
+            </a:r>
+          </a:p>
+          <a:p>
+            <a:pPr algn="l">
+              <a:spcAft>
+                <a:spcPts val="600"/>
+              </a:spcAft>
+            </a:pPr>
+            <a:r>
+              <a:rPr sz="1500" b="0">
                 <a:solidFill>
                   <a:srgbClr val="1F3A5F"/>
                 </a:solidFill>
                 <a:latin typeface="Calibri"/>
               </a:rPr>
-              <a:t>R$ 7.800</a:t>
-            </a:r>
-          </a:p>
-          <a:p>
-            <a:pPr algn="l">
-              <a:spcAft>
-                <a:spcPts val="600"/>
-              </a:spcAft>
-            </a:pPr>
-            <a:r>
-              <a:rPr sz="2000" b="1">
-                <a:solidFill>
-                  <a:srgbClr val="1F3A5F"/>
-                </a:solidFill>
-                <a:latin typeface="Calibri"/>
-              </a:rPr>
-              <a:t>50% no aceite, 50% na entrega</a:t>
+              <a:t>Kick-off e entrevistas</a:t>
             </a:r>
           </a:p>
         </p:txBody>
@@ -6414,8 +6484,83 @@
         </p:nvSpPr>
         <p:spPr>
           <a:xfrm>
-            <a:off x="6263999" y="1908000"/>
-            <a:ext cx="5256000" cy="2340000"/>
+            <a:off x="2466000" y="2160000"/>
+            <a:ext cx="1710000" cy="1980000"/>
+          </a:xfrm>
+          <a:prstGeom prst="roundRect">
+            <a:avLst>
+              <a:gd name="adj" fmla="val 8000"/>
+            </a:avLst>
+          </a:prstGeom>
+          <a:solidFill>
+            <a:srgbClr val="E8EEF5"/>
+          </a:solidFill>
+          <a:ln>
+            <a:noFill/>
+          </a:ln>
+          <a:effectLst/>
+        </p:spPr>
+        <p:style>
+          <a:lnRef idx="1">
+            <a:schemeClr val="accent1"/>
+          </a:lnRef>
+          <a:fillRef idx="3">
+            <a:schemeClr val="accent1"/>
+          </a:fillRef>
+          <a:effectRef idx="2">
+            <a:schemeClr val="accent1"/>
+          </a:effectRef>
+          <a:fontRef idx="minor">
+            <a:schemeClr val="lt1"/>
+          </a:fontRef>
+        </p:style>
+        <p:txBody>
+          <a:bodyPr rtlCol="0" anchor="t" wrap="square" lIns="180000" rIns="180000" tIns="180000"/>
+          <a:lstStyle/>
+          <a:p>
+            <a:pPr algn="l">
+              <a:spcAft>
+                <a:spcPts val="600"/>
+              </a:spcAft>
+            </a:pPr>
+            <a:r>
+              <a:rPr sz="1500" b="1">
+                <a:solidFill>
+                  <a:srgbClr val="1F3A5F"/>
+                </a:solidFill>
+                <a:latin typeface="Calibri"/>
+              </a:rPr>
+              <a:t>26/10</a:t>
+            </a:r>
+          </a:p>
+          <a:p>
+            <a:pPr algn="l">
+              <a:spcAft>
+                <a:spcPts val="600"/>
+              </a:spcAft>
+            </a:pPr>
+            <a:r>
+              <a:rPr sz="1500" b="0">
+                <a:solidFill>
+                  <a:srgbClr val="1F3A5F"/>
+                </a:solidFill>
+                <a:latin typeface="Calibri"/>
+              </a:rPr>
+              <a:t>Entrevistas com Tamara e Vitória</a:t>
+            </a:r>
+          </a:p>
+        </p:txBody>
+      </p:sp>
+      <p:sp>
+        <p:nvSpPr>
+          <p:cNvPr id="8" name="Rounded Rectangle 7"/>
+          <p:cNvSpPr/>
+          <p:nvPr/>
+        </p:nvSpPr>
+        <p:spPr>
+          <a:xfrm>
+            <a:off x="4284000" y="2160000"/>
+            <a:ext cx="1710000" cy="1980000"/>
           </a:xfrm>
           <a:prstGeom prst="roundRect">
             <a:avLst>
@@ -6454,100 +6599,254 @@
               </a:spcAft>
             </a:pPr>
             <a:r>
-              <a:rPr sz="2000" b="1">
+              <a:rPr sz="1500" b="1">
                 <a:solidFill>
                   <a:srgbClr val="FFFFFF"/>
                 </a:solidFill>
                 <a:latin typeface="Calibri"/>
               </a:rPr>
-              <a:t>Completa (recomendada)</a:t>
-            </a:r>
-          </a:p>
-          <a:p>
-            <a:pPr algn="l">
-              <a:spcAft>
-                <a:spcPts val="600"/>
-              </a:spcAft>
-            </a:pPr>
-            <a:r>
-              <a:rPr sz="2000" b="1">
+              <a:t>15/11</a:t>
+            </a:r>
+          </a:p>
+          <a:p>
+            <a:pPr algn="l">
+              <a:spcAft>
+                <a:spcPts val="600"/>
+              </a:spcAft>
+            </a:pPr>
+            <a:r>
+              <a:rPr sz="1500" b="0">
                 <a:solidFill>
                   <a:srgbClr val="FFFFFF"/>
                 </a:solidFill>
                 <a:latin typeface="Calibri"/>
               </a:rPr>
-              <a:t>R$ 14.800</a:t>
-            </a:r>
-          </a:p>
-          <a:p>
-            <a:pPr algn="l">
-              <a:spcAft>
-                <a:spcPts val="600"/>
-              </a:spcAft>
-            </a:pPr>
-            <a:r>
-              <a:rPr sz="2000" b="1">
+              <a:t>Entrega do mapeamento</a:t>
+            </a:r>
+          </a:p>
+        </p:txBody>
+      </p:sp>
+      <p:sp>
+        <p:nvSpPr>
+          <p:cNvPr id="9" name="Rounded Rectangle 8"/>
+          <p:cNvSpPr/>
+          <p:nvPr/>
+        </p:nvSpPr>
+        <p:spPr>
+          <a:xfrm>
+            <a:off x="6102000" y="2160000"/>
+            <a:ext cx="1710000" cy="1980000"/>
+          </a:xfrm>
+          <a:prstGeom prst="roundRect">
+            <a:avLst>
+              <a:gd name="adj" fmla="val 8000"/>
+            </a:avLst>
+          </a:prstGeom>
+          <a:solidFill>
+            <a:srgbClr val="E8EEF5"/>
+          </a:solidFill>
+          <a:ln>
+            <a:noFill/>
+          </a:ln>
+          <a:effectLst/>
+        </p:spPr>
+        <p:style>
+          <a:lnRef idx="1">
+            <a:schemeClr val="accent1"/>
+          </a:lnRef>
+          <a:fillRef idx="3">
+            <a:schemeClr val="accent1"/>
+          </a:fillRef>
+          <a:effectRef idx="2">
+            <a:schemeClr val="accent1"/>
+          </a:effectRef>
+          <a:fontRef idx="minor">
+            <a:schemeClr val="lt1"/>
+          </a:fontRef>
+        </p:style>
+        <p:txBody>
+          <a:bodyPr rtlCol="0" anchor="t" wrap="square" lIns="180000" rIns="180000" tIns="180000"/>
+          <a:lstStyle/>
+          <a:p>
+            <a:pPr algn="l">
+              <a:spcAft>
+                <a:spcPts val="600"/>
+              </a:spcAft>
+            </a:pPr>
+            <a:r>
+              <a:rPr sz="1500" b="1">
+                <a:solidFill>
+                  <a:srgbClr val="1F3A5F"/>
+                </a:solidFill>
+                <a:latin typeface="Calibri"/>
+              </a:rPr>
+              <a:t>29/11</a:t>
+            </a:r>
+          </a:p>
+          <a:p>
+            <a:pPr algn="l">
+              <a:spcAft>
+                <a:spcPts val="600"/>
+              </a:spcAft>
+            </a:pPr>
+            <a:r>
+              <a:rPr sz="1500" b="0">
+                <a:solidFill>
+                  <a:srgbClr val="1F3A5F"/>
+                </a:solidFill>
+                <a:latin typeface="Calibri"/>
+              </a:rPr>
+              <a:t>Estrutura organizacional</a:t>
+            </a:r>
+          </a:p>
+        </p:txBody>
+      </p:sp>
+      <p:sp>
+        <p:nvSpPr>
+          <p:cNvPr id="10" name="Rounded Rectangle 9"/>
+          <p:cNvSpPr/>
+          <p:nvPr/>
+        </p:nvSpPr>
+        <p:spPr>
+          <a:xfrm>
+            <a:off x="7920000" y="2160000"/>
+            <a:ext cx="1710000" cy="1980000"/>
+          </a:xfrm>
+          <a:prstGeom prst="roundRect">
+            <a:avLst>
+              <a:gd name="adj" fmla="val 8000"/>
+            </a:avLst>
+          </a:prstGeom>
+          <a:solidFill>
+            <a:srgbClr val="FFF4D6"/>
+          </a:solidFill>
+          <a:ln>
+            <a:noFill/>
+          </a:ln>
+          <a:effectLst/>
+        </p:spPr>
+        <p:style>
+          <a:lnRef idx="1">
+            <a:schemeClr val="accent1"/>
+          </a:lnRef>
+          <a:fillRef idx="3">
+            <a:schemeClr val="accent1"/>
+          </a:fillRef>
+          <a:effectRef idx="2">
+            <a:schemeClr val="accent1"/>
+          </a:effectRef>
+          <a:fontRef idx="minor">
+            <a:schemeClr val="lt1"/>
+          </a:fontRef>
+        </p:style>
+        <p:txBody>
+          <a:bodyPr rtlCol="0" anchor="t" wrap="square" lIns="180000" rIns="180000" tIns="180000"/>
+          <a:lstStyle/>
+          <a:p>
+            <a:pPr algn="l">
+              <a:spcAft>
+                <a:spcPts val="600"/>
+              </a:spcAft>
+            </a:pPr>
+            <a:r>
+              <a:rPr sz="1500" b="1">
+                <a:solidFill>
+                  <a:srgbClr val="1F3A5F"/>
+                </a:solidFill>
+                <a:latin typeface="Calibri"/>
+              </a:rPr>
+              <a:t>13/12</a:t>
+            </a:r>
+          </a:p>
+          <a:p>
+            <a:pPr algn="l">
+              <a:spcAft>
+                <a:spcPts val="600"/>
+              </a:spcAft>
+            </a:pPr>
+            <a:r>
+              <a:rPr sz="1500" b="0">
+                <a:solidFill>
+                  <a:srgbClr val="1F3A5F"/>
+                </a:solidFill>
+                <a:latin typeface="Calibri"/>
+              </a:rPr>
+              <a:t>Sua prova (sem reuniões)</a:t>
+            </a:r>
+          </a:p>
+        </p:txBody>
+      </p:sp>
+      <p:sp>
+        <p:nvSpPr>
+          <p:cNvPr id="11" name="Rounded Rectangle 10"/>
+          <p:cNvSpPr/>
+          <p:nvPr/>
+        </p:nvSpPr>
+        <p:spPr>
+          <a:xfrm>
+            <a:off x="9738000" y="2160000"/>
+            <a:ext cx="1710000" cy="1980000"/>
+          </a:xfrm>
+          <a:prstGeom prst="roundRect">
+            <a:avLst>
+              <a:gd name="adj" fmla="val 8000"/>
+            </a:avLst>
+          </a:prstGeom>
+          <a:solidFill>
+            <a:srgbClr val="1F3A5F"/>
+          </a:solidFill>
+          <a:ln>
+            <a:noFill/>
+          </a:ln>
+          <a:effectLst/>
+        </p:spPr>
+        <p:style>
+          <a:lnRef idx="1">
+            <a:schemeClr val="accent1"/>
+          </a:lnRef>
+          <a:fillRef idx="3">
+            <a:schemeClr val="accent1"/>
+          </a:fillRef>
+          <a:effectRef idx="2">
+            <a:schemeClr val="accent1"/>
+          </a:effectRef>
+          <a:fontRef idx="minor">
+            <a:schemeClr val="lt1"/>
+          </a:fontRef>
+        </p:style>
+        <p:txBody>
+          <a:bodyPr rtlCol="0" anchor="t" wrap="square" lIns="180000" rIns="180000" tIns="180000"/>
+          <a:lstStyle/>
+          <a:p>
+            <a:pPr algn="l">
+              <a:spcAft>
+                <a:spcPts val="600"/>
+              </a:spcAft>
+            </a:pPr>
+            <a:r>
+              <a:rPr sz="1500" b="1">
                 <a:solidFill>
                   <a:srgbClr val="FFFFFF"/>
                 </a:solidFill>
                 <a:latin typeface="Calibri"/>
               </a:rPr>
-              <a:t>30% no aceite, 35% no mapeamento, 35% na entrega final</a:t>
-            </a:r>
-          </a:p>
-        </p:txBody>
-      </p:sp>
-      <p:sp>
-        <p:nvSpPr>
-          <p:cNvPr id="8" name="TextBox 7"/>
-          <p:cNvSpPr txBox="1"/>
-          <p:nvPr/>
-        </p:nvSpPr>
-        <p:spPr>
-          <a:xfrm>
-            <a:off x="648000" y="4536000"/>
-            <a:ext cx="10800000" cy="1440000"/>
-          </a:xfrm>
-          <a:prstGeom prst="rect">
-            <a:avLst/>
-          </a:prstGeom>
-          <a:noFill/>
-        </p:spPr>
-        <p:txBody>
-          <a:bodyPr wrap="square" anchor="t" lIns="180000" rIns="180000" tIns="180000">
-            <a:spAutoFit/>
-          </a:bodyPr>
-          <a:lstStyle/>
-          <a:p>
-            <a:pPr algn="l">
-              <a:spcAft>
-                <a:spcPts val="600"/>
-              </a:spcAft>
-            </a:pPr>
-            <a:r>
-              <a:rPr sz="1400" b="0">
-                <a:solidFill>
-                  <a:srgbClr val="595959"/>
-                </a:solidFill>
-                <a:latin typeface="Calibri"/>
-              </a:rPr>
-              <a:t>A reunião inicial e esta proposta não foram cobradas.</a:t>
-            </a:r>
-          </a:p>
-          <a:p>
-            <a:pPr algn="l">
-              <a:spcAft>
-                <a:spcPts val="600"/>
-              </a:spcAft>
-            </a:pPr>
-            <a:r>
-              <a:rPr sz="1400" b="0">
-                <a:solidFill>
-                  <a:srgbClr val="595959"/>
-                </a:solidFill>
-                <a:latin typeface="Calibri"/>
-              </a:rPr>
-              <a:t>Fora do escopo: desenvolvimento de automações, integrações, suporte contínuo e licenças.</a:t>
+              <a:t>18/12</a:t>
+            </a:r>
+          </a:p>
+          <a:p>
+            <a:pPr algn="l">
+              <a:spcAft>
+                <a:spcPts val="600"/>
+              </a:spcAft>
+            </a:pPr>
+            <a:r>
+              <a:rPr sz="1500" b="0">
+                <a:solidFill>
+                  <a:srgbClr val="FFFFFF"/>
+                </a:solidFill>
+                <a:latin typeface="Calibri"/>
+              </a:rPr>
+              <a:t>Apresentação final</a:t>
             </a:r>
           </a:p>
         </p:txBody>
@@ -6647,7 +6946,7 @@
                 </a:solidFill>
                 <a:latin typeface="Calibri"/>
               </a:rPr>
-              <a:t>Próximos passos</a:t>
+              <a:t>Investimento</a:t>
             </a:r>
           </a:p>
         </p:txBody>
@@ -6660,8 +6959,8 @@
         </p:nvSpPr>
         <p:spPr>
           <a:xfrm>
-            <a:off x="648000" y="6336000"/>
-            <a:ext cx="10800000" cy="288000"/>
+            <a:off x="648000" y="1152000"/>
+            <a:ext cx="10800000" cy="432000"/>
           </a:xfrm>
           <a:prstGeom prst="rect">
             <a:avLst/>
@@ -6680,13 +6979,13 @@
               </a:spcAft>
             </a:pPr>
             <a:r>
-              <a:rPr sz="900" b="0">
+              <a:rPr sz="1600" b="0">
                 <a:solidFill>
                   <a:srgbClr val="595959"/>
                 </a:solidFill>
                 <a:latin typeface="Calibri"/>
               </a:rPr>
-              <a:t>Surcin Consultoria · Proposta de consultoria · Confidencial</a:t>
+              <a:t>Preço fechado. A implementação é orçada depois, por pacotes.</a:t>
             </a:r>
           </a:p>
         </p:txBody>
@@ -6699,8 +6998,8 @@
         </p:nvSpPr>
         <p:spPr>
           <a:xfrm>
-            <a:off x="648000" y="1620000"/>
-            <a:ext cx="10800000" cy="3600000"/>
+            <a:off x="648000" y="6336000"/>
+            <a:ext cx="10800000" cy="288000"/>
           </a:xfrm>
           <a:prstGeom prst="rect">
             <a:avLst/>
@@ -6719,6 +7018,421 @@
               </a:spcAft>
             </a:pPr>
             <a:r>
+              <a:rPr sz="900" b="0">
+                <a:solidFill>
+                  <a:srgbClr val="595959"/>
+                </a:solidFill>
+                <a:latin typeface="Calibri"/>
+              </a:rPr>
+              <a:t>Surcin · Proposta de consultoria · Confidencial</a:t>
+            </a:r>
+          </a:p>
+        </p:txBody>
+      </p:sp>
+      <p:sp>
+        <p:nvSpPr>
+          <p:cNvPr id="6" name="Rounded Rectangle 5"/>
+          <p:cNvSpPr/>
+          <p:nvPr/>
+        </p:nvSpPr>
+        <p:spPr>
+          <a:xfrm>
+            <a:off x="648000" y="1908000"/>
+            <a:ext cx="5256000" cy="2340000"/>
+          </a:xfrm>
+          <a:prstGeom prst="roundRect">
+            <a:avLst>
+              <a:gd name="adj" fmla="val 8000"/>
+            </a:avLst>
+          </a:prstGeom>
+          <a:solidFill>
+            <a:srgbClr val="E8EEF5"/>
+          </a:solidFill>
+          <a:ln>
+            <a:noFill/>
+          </a:ln>
+          <a:effectLst/>
+        </p:spPr>
+        <p:style>
+          <a:lnRef idx="1">
+            <a:schemeClr val="accent1"/>
+          </a:lnRef>
+          <a:fillRef idx="3">
+            <a:schemeClr val="accent1"/>
+          </a:fillRef>
+          <a:effectRef idx="2">
+            <a:schemeClr val="accent1"/>
+          </a:effectRef>
+          <a:fontRef idx="minor">
+            <a:schemeClr val="lt1"/>
+          </a:fontRef>
+        </p:style>
+        <p:txBody>
+          <a:bodyPr rtlCol="0" anchor="t" wrap="square" lIns="180000" rIns="180000" tIns="180000"/>
+          <a:lstStyle/>
+          <a:p>
+            <a:pPr algn="l">
+              <a:spcAft>
+                <a:spcPts val="600"/>
+              </a:spcAft>
+            </a:pPr>
+            <a:r>
+              <a:rPr sz="2000" b="1">
+                <a:solidFill>
+                  <a:srgbClr val="1F3A5F"/>
+                </a:solidFill>
+                <a:latin typeface="Calibri"/>
+              </a:rPr>
+              <a:t>Essencial</a:t>
+            </a:r>
+          </a:p>
+          <a:p>
+            <a:pPr algn="l">
+              <a:spcAft>
+                <a:spcPts val="600"/>
+              </a:spcAft>
+            </a:pPr>
+            <a:r>
+              <a:rPr sz="2000" b="1">
+                <a:solidFill>
+                  <a:srgbClr val="1F3A5F"/>
+                </a:solidFill>
+                <a:latin typeface="Calibri"/>
+              </a:rPr>
+              <a:t>R$ 7.800</a:t>
+            </a:r>
+          </a:p>
+          <a:p>
+            <a:pPr algn="l">
+              <a:spcAft>
+                <a:spcPts val="600"/>
+              </a:spcAft>
+            </a:pPr>
+            <a:r>
+              <a:rPr sz="2000" b="1">
+                <a:solidFill>
+                  <a:srgbClr val="1F3A5F"/>
+                </a:solidFill>
+                <a:latin typeface="Calibri"/>
+              </a:rPr>
+              <a:t>50% no aceite, 50% na entrega</a:t>
+            </a:r>
+          </a:p>
+        </p:txBody>
+      </p:sp>
+      <p:sp>
+        <p:nvSpPr>
+          <p:cNvPr id="7" name="Rounded Rectangle 6"/>
+          <p:cNvSpPr/>
+          <p:nvPr/>
+        </p:nvSpPr>
+        <p:spPr>
+          <a:xfrm>
+            <a:off x="6263999" y="1908000"/>
+            <a:ext cx="5256000" cy="2340000"/>
+          </a:xfrm>
+          <a:prstGeom prst="roundRect">
+            <a:avLst>
+              <a:gd name="adj" fmla="val 8000"/>
+            </a:avLst>
+          </a:prstGeom>
+          <a:solidFill>
+            <a:srgbClr val="1F3A5F"/>
+          </a:solidFill>
+          <a:ln>
+            <a:noFill/>
+          </a:ln>
+          <a:effectLst/>
+        </p:spPr>
+        <p:style>
+          <a:lnRef idx="1">
+            <a:schemeClr val="accent1"/>
+          </a:lnRef>
+          <a:fillRef idx="3">
+            <a:schemeClr val="accent1"/>
+          </a:fillRef>
+          <a:effectRef idx="2">
+            <a:schemeClr val="accent1"/>
+          </a:effectRef>
+          <a:fontRef idx="minor">
+            <a:schemeClr val="lt1"/>
+          </a:fontRef>
+        </p:style>
+        <p:txBody>
+          <a:bodyPr rtlCol="0" anchor="t" wrap="square" lIns="180000" rIns="180000" tIns="180000"/>
+          <a:lstStyle/>
+          <a:p>
+            <a:pPr algn="l">
+              <a:spcAft>
+                <a:spcPts val="600"/>
+              </a:spcAft>
+            </a:pPr>
+            <a:r>
+              <a:rPr sz="2000" b="1">
+                <a:solidFill>
+                  <a:srgbClr val="FFFFFF"/>
+                </a:solidFill>
+                <a:latin typeface="Calibri"/>
+              </a:rPr>
+              <a:t>Completa (recomendada)</a:t>
+            </a:r>
+          </a:p>
+          <a:p>
+            <a:pPr algn="l">
+              <a:spcAft>
+                <a:spcPts val="600"/>
+              </a:spcAft>
+            </a:pPr>
+            <a:r>
+              <a:rPr sz="2000" b="1">
+                <a:solidFill>
+                  <a:srgbClr val="FFFFFF"/>
+                </a:solidFill>
+                <a:latin typeface="Calibri"/>
+              </a:rPr>
+              <a:t>R$ 14.800</a:t>
+            </a:r>
+          </a:p>
+          <a:p>
+            <a:pPr algn="l">
+              <a:spcAft>
+                <a:spcPts val="600"/>
+              </a:spcAft>
+            </a:pPr>
+            <a:r>
+              <a:rPr sz="2000" b="1">
+                <a:solidFill>
+                  <a:srgbClr val="FFFFFF"/>
+                </a:solidFill>
+                <a:latin typeface="Calibri"/>
+              </a:rPr>
+              <a:t>30% no aceite, 35% no mapeamento, 35% na entrega final</a:t>
+            </a:r>
+          </a:p>
+        </p:txBody>
+      </p:sp>
+      <p:sp>
+        <p:nvSpPr>
+          <p:cNvPr id="8" name="TextBox 7"/>
+          <p:cNvSpPr txBox="1"/>
+          <p:nvPr/>
+        </p:nvSpPr>
+        <p:spPr>
+          <a:xfrm>
+            <a:off x="648000" y="4536000"/>
+            <a:ext cx="10800000" cy="1440000"/>
+          </a:xfrm>
+          <a:prstGeom prst="rect">
+            <a:avLst/>
+          </a:prstGeom>
+          <a:noFill/>
+        </p:spPr>
+        <p:txBody>
+          <a:bodyPr wrap="square" anchor="t" lIns="180000" rIns="180000" tIns="180000">
+            <a:spAutoFit/>
+          </a:bodyPr>
+          <a:lstStyle/>
+          <a:p>
+            <a:pPr algn="l">
+              <a:spcAft>
+                <a:spcPts val="600"/>
+              </a:spcAft>
+            </a:pPr>
+            <a:r>
+              <a:rPr sz="1400" b="0">
+                <a:solidFill>
+                  <a:srgbClr val="595959"/>
+                </a:solidFill>
+                <a:latin typeface="Calibri"/>
+              </a:rPr>
+              <a:t>A reunião inicial e esta proposta não foram cobradas.</a:t>
+            </a:r>
+          </a:p>
+          <a:p>
+            <a:pPr algn="l">
+              <a:spcAft>
+                <a:spcPts val="600"/>
+              </a:spcAft>
+            </a:pPr>
+            <a:r>
+              <a:rPr sz="1400" b="0">
+                <a:solidFill>
+                  <a:srgbClr val="595959"/>
+                </a:solidFill>
+                <a:latin typeface="Calibri"/>
+              </a:rPr>
+              <a:t>Fora do escopo: automações, correção do Domínio, migração de contas, programa de bonificação e licenças.</a:t>
+            </a:r>
+          </a:p>
+        </p:txBody>
+      </p:sp>
+    </p:spTree>
+  </p:cSld>
+  <p:clrMapOvr>
+    <a:masterClrMapping/>
+  </p:clrMapOvr>
+</p:sld>
+</file>
+
+<file path=ppt/slides/slide9.xml><?xml version="1.0" encoding="utf-8"?>
+<p:sld xmlns:a="http://schemas.openxmlformats.org/drawingml/2006/main" xmlns:p="http://schemas.openxmlformats.org/presentationml/2006/main" xmlns:r="http://schemas.openxmlformats.org/officeDocument/2006/relationships">
+  <p:cSld>
+    <p:spTree>
+      <p:nvGrpSpPr>
+        <p:cNvPr id="1" name=""/>
+        <p:cNvGrpSpPr/>
+        <p:nvPr/>
+      </p:nvGrpSpPr>
+      <p:grpSpPr/>
+      <p:sp>
+        <p:nvSpPr>
+          <p:cNvPr id="2" name="Rectangle 1"/>
+          <p:cNvSpPr/>
+          <p:nvPr/>
+        </p:nvSpPr>
+        <p:spPr>
+          <a:xfrm>
+            <a:off x="0" y="0"/>
+            <a:ext cx="12192119" cy="180000"/>
+          </a:xfrm>
+          <a:prstGeom prst="rect">
+            <a:avLst/>
+          </a:prstGeom>
+          <a:solidFill>
+            <a:srgbClr val="1F3A5F"/>
+          </a:solidFill>
+          <a:ln>
+            <a:noFill/>
+          </a:ln>
+        </p:spPr>
+        <p:style>
+          <a:lnRef idx="1">
+            <a:schemeClr val="accent1"/>
+          </a:lnRef>
+          <a:fillRef idx="3">
+            <a:schemeClr val="accent1"/>
+          </a:fillRef>
+          <a:effectRef idx="2">
+            <a:schemeClr val="accent1"/>
+          </a:effectRef>
+          <a:fontRef idx="minor">
+            <a:schemeClr val="lt1"/>
+          </a:fontRef>
+        </p:style>
+        <p:txBody>
+          <a:bodyPr rtlCol="0" anchor="ctr"/>
+          <a:lstStyle/>
+          <a:p>
+            <a:pPr algn="ctr"/>
+          </a:p>
+        </p:txBody>
+      </p:sp>
+      <p:sp>
+        <p:nvSpPr>
+          <p:cNvPr id="3" name="TextBox 2"/>
+          <p:cNvSpPr txBox="1"/>
+          <p:nvPr/>
+        </p:nvSpPr>
+        <p:spPr>
+          <a:xfrm>
+            <a:off x="648000" y="468000"/>
+            <a:ext cx="10800000" cy="720000"/>
+          </a:xfrm>
+          <a:prstGeom prst="rect">
+            <a:avLst/>
+          </a:prstGeom>
+          <a:noFill/>
+        </p:spPr>
+        <p:txBody>
+          <a:bodyPr wrap="square" anchor="t" lIns="180000" rIns="180000" tIns="180000">
+            <a:spAutoFit/>
+          </a:bodyPr>
+          <a:lstStyle/>
+          <a:p>
+            <a:pPr algn="l">
+              <a:spcAft>
+                <a:spcPts val="600"/>
+              </a:spcAft>
+            </a:pPr>
+            <a:r>
+              <a:rPr sz="3000" b="1">
+                <a:solidFill>
+                  <a:srgbClr val="1F3A5F"/>
+                </a:solidFill>
+                <a:latin typeface="Calibri"/>
+              </a:rPr>
+              <a:t>Próximos passos</a:t>
+            </a:r>
+          </a:p>
+        </p:txBody>
+      </p:sp>
+      <p:sp>
+        <p:nvSpPr>
+          <p:cNvPr id="4" name="TextBox 3"/>
+          <p:cNvSpPr txBox="1"/>
+          <p:nvPr/>
+        </p:nvSpPr>
+        <p:spPr>
+          <a:xfrm>
+            <a:off x="648000" y="6336000"/>
+            <a:ext cx="10800000" cy="288000"/>
+          </a:xfrm>
+          <a:prstGeom prst="rect">
+            <a:avLst/>
+          </a:prstGeom>
+          <a:noFill/>
+        </p:spPr>
+        <p:txBody>
+          <a:bodyPr wrap="square" anchor="t" lIns="180000" rIns="180000" tIns="180000">
+            <a:spAutoFit/>
+          </a:bodyPr>
+          <a:lstStyle/>
+          <a:p>
+            <a:pPr algn="l">
+              <a:spcAft>
+                <a:spcPts val="600"/>
+              </a:spcAft>
+            </a:pPr>
+            <a:r>
+              <a:rPr sz="900" b="0">
+                <a:solidFill>
+                  <a:srgbClr val="595959"/>
+                </a:solidFill>
+                <a:latin typeface="Calibri"/>
+              </a:rPr>
+              <a:t>Surcin · Proposta de consultoria · Confidencial</a:t>
+            </a:r>
+          </a:p>
+        </p:txBody>
+      </p:sp>
+      <p:sp>
+        <p:nvSpPr>
+          <p:cNvPr id="5" name="TextBox 4"/>
+          <p:cNvSpPr txBox="1"/>
+          <p:nvPr/>
+        </p:nvSpPr>
+        <p:spPr>
+          <a:xfrm>
+            <a:off x="648000" y="1620000"/>
+            <a:ext cx="10800000" cy="3960000"/>
+          </a:xfrm>
+          <a:prstGeom prst="rect">
+            <a:avLst/>
+          </a:prstGeom>
+          <a:noFill/>
+        </p:spPr>
+        <p:txBody>
+          <a:bodyPr wrap="square" anchor="t" lIns="180000" rIns="180000" tIns="180000">
+            <a:spAutoFit/>
+          </a:bodyPr>
+          <a:lstStyle/>
+          <a:p>
+            <a:pPr algn="l">
+              <a:spcAft>
+                <a:spcPts val="600"/>
+              </a:spcAft>
+            </a:pPr>
+            <a:r>
               <a:rPr sz="1800" b="0">
                 <a:solidFill>
                   <a:srgbClr val="1F3A5F"/>
@@ -6757,7 +7471,7 @@
                 </a:solidFill>
                 <a:latin typeface="Calibri"/>
               </a:rPr>
-              <a:t>3. Kick-off e agenda das entrevistas com a equipe</a:t>
+              <a:t>3. Kick-off na semana de 19/10, com a Júlia como ponto focal</a:t>
             </a:r>
           </a:p>
           <a:p>
@@ -6789,7 +7503,7 @@
                 </a:solidFill>
                 <a:latin typeface="Calibri"/>
               </a:rPr>
-              <a:t>Perguntas para hoje:</a:t>
+              <a:t>Para confirmar hoje:</a:t>
             </a:r>
           </a:p>
           <a:p>
@@ -6805,7 +7519,7 @@
                 </a:solidFill>
                 <a:latin typeface="Calibri"/>
               </a:rPr>
-              <a:t>• Quantas pessoas trabalham em cada área?</a:t>
+              <a:t>• Quantos clientes há em cada serviço?</a:t>
             </a:r>
           </a:p>
           <a:p>
@@ -6821,7 +7535,7 @@
                 </a:solidFill>
                 <a:latin typeface="Calibri"/>
               </a:rPr>
-              <a:t>• Qual dor, se resolvida primeiro, mais mudaria o seu dia a dia?</a:t>
+              <a:t>• Qual processo, resolvido primeiro, mais devolve seu tempo?</a:t>
             </a:r>
           </a:p>
           <a:p>
@@ -6837,7 +7551,23 @@
                 </a:solidFill>
                 <a:latin typeface="Calibri"/>
               </a:rPr>
-              <a:t>• A equipe pode conversar antes das 10h, no almoço ou após 19h30?</a:t>
+              <a:t>• A equipe pode conversar antes das 10h30 ou no almoço?</a:t>
+            </a:r>
+          </a:p>
+          <a:p>
+            <a:pPr algn="l">
+              <a:spcAft>
+                <a:spcPts val="600"/>
+              </a:spcAft>
+            </a:pPr>
+            <a:r>
+              <a:rPr sz="1800" b="0">
+                <a:solidFill>
+                  <a:srgbClr val="1F3A5F"/>
+                </a:solidFill>
+                <a:latin typeface="Calibri"/>
+              </a:rPr>
+              <a:t>• Quem vai corrigir a configuração do Domínio?</a:t>
             </a:r>
           </a:p>
         </p:txBody>

</xml_diff>

<commit_message>
Proposta Surcin v3: cruza reunião, briefing e anotações do Gemini
Co-Authored-By: Claude Opus 5.5 (1M context) <noreply@anthropic.com>
Claude-Session: https://claude.ai/code/session_0127xFh2xB8HoQ18BDMAY2QJ
</commit_message>
<xml_diff>
--- a/proposta-surcin/06-apresentacao-proposta.pptx
+++ b/proposta-surcin/06-apresentacao-proposta.pptx
@@ -14,6 +14,8 @@
     <p:sldId id="262" r:id="rId13"/>
     <p:sldId id="263" r:id="rId14"/>
     <p:sldId id="264" r:id="rId15"/>
+    <p:sldId id="265" r:id="rId16"/>
+    <p:sldId id="266" r:id="rId17"/>
   </p:sldIdLst>
   <p:sldSz cx="12192119" cy="6858000" type="screen4x3"/>
   <p:notesSz cx="6858000" cy="9144000"/>
@@ -3212,7 +3214,7 @@
                 </a:solidFill>
                 <a:latin typeface="Calibri"/>
               </a:rPr>
-              <a:t>Proposta de consultoria para a Surcin</a:t>
+              <a:t>Proposta de consultoria para a Surcin Assessoria Empresarial</a:t>
             </a:r>
           </a:p>
         </p:txBody>
@@ -3252,6 +3254,1017 @@
                 <a:latin typeface="Calibri"/>
               </a:rPr>
               <a:t>Renato [sobrenome] · R2 Tech Consulting · 15 de outubro de 2026</a:t>
+            </a:r>
+          </a:p>
+        </p:txBody>
+      </p:sp>
+    </p:spTree>
+  </p:cSld>
+  <p:clrMapOvr>
+    <a:masterClrMapping/>
+  </p:clrMapOvr>
+</p:sld>
+</file>
+
+<file path=ppt/slides/slide10.xml><?xml version="1.0" encoding="utf-8"?>
+<p:sld xmlns:a="http://schemas.openxmlformats.org/drawingml/2006/main" xmlns:p="http://schemas.openxmlformats.org/presentationml/2006/main" xmlns:r="http://schemas.openxmlformats.org/officeDocument/2006/relationships">
+  <p:cSld>
+    <p:spTree>
+      <p:nvGrpSpPr>
+        <p:cNvPr id="1" name=""/>
+        <p:cNvGrpSpPr/>
+        <p:nvPr/>
+      </p:nvGrpSpPr>
+      <p:grpSpPr/>
+      <p:sp>
+        <p:nvSpPr>
+          <p:cNvPr id="2" name="Rectangle 1"/>
+          <p:cNvSpPr/>
+          <p:nvPr/>
+        </p:nvSpPr>
+        <p:spPr>
+          <a:xfrm>
+            <a:off x="0" y="0"/>
+            <a:ext cx="12192119" cy="180000"/>
+          </a:xfrm>
+          <a:prstGeom prst="rect">
+            <a:avLst/>
+          </a:prstGeom>
+          <a:solidFill>
+            <a:srgbClr val="1F3A5F"/>
+          </a:solidFill>
+          <a:ln>
+            <a:noFill/>
+          </a:ln>
+        </p:spPr>
+        <p:style>
+          <a:lnRef idx="1">
+            <a:schemeClr val="accent1"/>
+          </a:lnRef>
+          <a:fillRef idx="3">
+            <a:schemeClr val="accent1"/>
+          </a:fillRef>
+          <a:effectRef idx="2">
+            <a:schemeClr val="accent1"/>
+          </a:effectRef>
+          <a:fontRef idx="minor">
+            <a:schemeClr val="lt1"/>
+          </a:fontRef>
+        </p:style>
+        <p:txBody>
+          <a:bodyPr rtlCol="0" anchor="ctr"/>
+          <a:lstStyle/>
+          <a:p>
+            <a:pPr algn="ctr"/>
+          </a:p>
+        </p:txBody>
+      </p:sp>
+      <p:sp>
+        <p:nvSpPr>
+          <p:cNvPr id="3" name="TextBox 2"/>
+          <p:cNvSpPr txBox="1"/>
+          <p:nvPr/>
+        </p:nvSpPr>
+        <p:spPr>
+          <a:xfrm>
+            <a:off x="648000" y="468000"/>
+            <a:ext cx="10800000" cy="720000"/>
+          </a:xfrm>
+          <a:prstGeom prst="rect">
+            <a:avLst/>
+          </a:prstGeom>
+          <a:noFill/>
+        </p:spPr>
+        <p:txBody>
+          <a:bodyPr wrap="square" anchor="t" lIns="180000" rIns="180000" tIns="180000">
+            <a:spAutoFit/>
+          </a:bodyPr>
+          <a:lstStyle/>
+          <a:p>
+            <a:pPr algn="l">
+              <a:spcAft>
+                <a:spcPts val="600"/>
+              </a:spcAft>
+            </a:pPr>
+            <a:r>
+              <a:rPr sz="3000" b="1">
+                <a:solidFill>
+                  <a:srgbClr val="1F3A5F"/>
+                </a:solidFill>
+                <a:latin typeface="Calibri"/>
+              </a:rPr>
+              <a:t>Depois: implantação em módulos</a:t>
+            </a:r>
+          </a:p>
+        </p:txBody>
+      </p:sp>
+      <p:sp>
+        <p:nvSpPr>
+          <p:cNvPr id="4" name="TextBox 3"/>
+          <p:cNvSpPr txBox="1"/>
+          <p:nvPr/>
+        </p:nvSpPr>
+        <p:spPr>
+          <a:xfrm>
+            <a:off x="648000" y="1152000"/>
+            <a:ext cx="10800000" cy="432000"/>
+          </a:xfrm>
+          <a:prstGeom prst="rect">
+            <a:avLst/>
+          </a:prstGeom>
+          <a:noFill/>
+        </p:spPr>
+        <p:txBody>
+          <a:bodyPr wrap="square" anchor="t" lIns="180000" rIns="180000" tIns="180000">
+            <a:spAutoFit/>
+          </a:bodyPr>
+          <a:lstStyle/>
+          <a:p>
+            <a:pPr algn="l">
+              <a:spcAft>
+                <a:spcPts val="600"/>
+              </a:spcAft>
+            </a:pPr>
+            <a:r>
+              <a:rPr sz="1600" b="0">
+                <a:solidFill>
+                  <a:srgbClr val="595959"/>
+                </a:solidFill>
+                <a:latin typeface="Calibri"/>
+              </a:rPr>
+              <a:t>Cada módulo é orçado após o plano, com prova de viabilidade e pagamento sempre humano</a:t>
+            </a:r>
+          </a:p>
+        </p:txBody>
+      </p:sp>
+      <p:sp>
+        <p:nvSpPr>
+          <p:cNvPr id="5" name="TextBox 4"/>
+          <p:cNvSpPr txBox="1"/>
+          <p:nvPr/>
+        </p:nvSpPr>
+        <p:spPr>
+          <a:xfrm>
+            <a:off x="648000" y="6336000"/>
+            <a:ext cx="10800000" cy="288000"/>
+          </a:xfrm>
+          <a:prstGeom prst="rect">
+            <a:avLst/>
+          </a:prstGeom>
+          <a:noFill/>
+        </p:spPr>
+        <p:txBody>
+          <a:bodyPr wrap="square" anchor="t" lIns="180000" rIns="180000" tIns="180000">
+            <a:spAutoFit/>
+          </a:bodyPr>
+          <a:lstStyle/>
+          <a:p>
+            <a:pPr algn="l">
+              <a:spcAft>
+                <a:spcPts val="600"/>
+              </a:spcAft>
+            </a:pPr>
+            <a:r>
+              <a:rPr sz="900" b="0">
+                <a:solidFill>
+                  <a:srgbClr val="595959"/>
+                </a:solidFill>
+                <a:latin typeface="Calibri"/>
+              </a:rPr>
+              <a:t>Surcin · Proposta de consultoria · Confidencial</a:t>
+            </a:r>
+          </a:p>
+        </p:txBody>
+      </p:sp>
+      <p:sp>
+        <p:nvSpPr>
+          <p:cNvPr id="6" name="Rounded Rectangle 5"/>
+          <p:cNvSpPr/>
+          <p:nvPr/>
+        </p:nvSpPr>
+        <p:spPr>
+          <a:xfrm>
+            <a:off x="648000" y="1800000"/>
+            <a:ext cx="2592000" cy="1368000"/>
+          </a:xfrm>
+          <a:prstGeom prst="roundRect">
+            <a:avLst>
+              <a:gd name="adj" fmla="val 8000"/>
+            </a:avLst>
+          </a:prstGeom>
+          <a:solidFill>
+            <a:srgbClr val="E8EEF5"/>
+          </a:solidFill>
+          <a:ln>
+            <a:noFill/>
+          </a:ln>
+          <a:effectLst/>
+        </p:spPr>
+        <p:style>
+          <a:lnRef idx="1">
+            <a:schemeClr val="accent1"/>
+          </a:lnRef>
+          <a:fillRef idx="3">
+            <a:schemeClr val="accent1"/>
+          </a:fillRef>
+          <a:effectRef idx="2">
+            <a:schemeClr val="accent1"/>
+          </a:effectRef>
+          <a:fontRef idx="minor">
+            <a:schemeClr val="lt1"/>
+          </a:fontRef>
+        </p:style>
+        <p:txBody>
+          <a:bodyPr rtlCol="0" anchor="t" wrap="square" lIns="180000" rIns="180000" tIns="180000"/>
+          <a:lstStyle/>
+          <a:p>
+            <a:pPr algn="l">
+              <a:spcAft>
+                <a:spcPts val="600"/>
+              </a:spcAft>
+            </a:pPr>
+            <a:r>
+              <a:rPr sz="1500" b="1">
+                <a:solidFill>
+                  <a:srgbClr val="1F3A5F"/>
+                </a:solidFill>
+                <a:latin typeface="Calibri"/>
+              </a:rPr>
+              <a:t>Ambiente Surcin e Base Mestre</a:t>
+            </a:r>
+          </a:p>
+        </p:txBody>
+      </p:sp>
+      <p:sp>
+        <p:nvSpPr>
+          <p:cNvPr id="7" name="Rounded Rectangle 6"/>
+          <p:cNvSpPr/>
+          <p:nvPr/>
+        </p:nvSpPr>
+        <p:spPr>
+          <a:xfrm>
+            <a:off x="3384000" y="1800000"/>
+            <a:ext cx="2592000" cy="1368000"/>
+          </a:xfrm>
+          <a:prstGeom prst="roundRect">
+            <a:avLst>
+              <a:gd name="adj" fmla="val 8000"/>
+            </a:avLst>
+          </a:prstGeom>
+          <a:solidFill>
+            <a:srgbClr val="E8EEF5"/>
+          </a:solidFill>
+          <a:ln>
+            <a:noFill/>
+          </a:ln>
+          <a:effectLst/>
+        </p:spPr>
+        <p:style>
+          <a:lnRef idx="1">
+            <a:schemeClr val="accent1"/>
+          </a:lnRef>
+          <a:fillRef idx="3">
+            <a:schemeClr val="accent1"/>
+          </a:fillRef>
+          <a:effectRef idx="2">
+            <a:schemeClr val="accent1"/>
+          </a:effectRef>
+          <a:fontRef idx="minor">
+            <a:schemeClr val="lt1"/>
+          </a:fontRef>
+        </p:style>
+        <p:txBody>
+          <a:bodyPr rtlCol="0" anchor="t" wrap="square" lIns="180000" rIns="180000" tIns="180000"/>
+          <a:lstStyle/>
+          <a:p>
+            <a:pPr algn="l">
+              <a:spcAft>
+                <a:spcPts val="600"/>
+              </a:spcAft>
+            </a:pPr>
+            <a:r>
+              <a:rPr sz="1500" b="1">
+                <a:solidFill>
+                  <a:srgbClr val="1F3A5F"/>
+                </a:solidFill>
+                <a:latin typeface="Calibri"/>
+              </a:rPr>
+              <a:t>Especialista de dúvidas</a:t>
+            </a:r>
+          </a:p>
+        </p:txBody>
+      </p:sp>
+      <p:sp>
+        <p:nvSpPr>
+          <p:cNvPr id="8" name="Rounded Rectangle 7"/>
+          <p:cNvSpPr/>
+          <p:nvPr/>
+        </p:nvSpPr>
+        <p:spPr>
+          <a:xfrm>
+            <a:off x="6120000" y="1800000"/>
+            <a:ext cx="2592000" cy="1368000"/>
+          </a:xfrm>
+          <a:prstGeom prst="roundRect">
+            <a:avLst>
+              <a:gd name="adj" fmla="val 8000"/>
+            </a:avLst>
+          </a:prstGeom>
+          <a:solidFill>
+            <a:srgbClr val="E8EEF5"/>
+          </a:solidFill>
+          <a:ln>
+            <a:noFill/>
+          </a:ln>
+          <a:effectLst/>
+        </p:spPr>
+        <p:style>
+          <a:lnRef idx="1">
+            <a:schemeClr val="accent1"/>
+          </a:lnRef>
+          <a:fillRef idx="3">
+            <a:schemeClr val="accent1"/>
+          </a:fillRef>
+          <a:effectRef idx="2">
+            <a:schemeClr val="accent1"/>
+          </a:effectRef>
+          <a:fontRef idx="minor">
+            <a:schemeClr val="lt1"/>
+          </a:fontRef>
+        </p:style>
+        <p:txBody>
+          <a:bodyPr rtlCol="0" anchor="t" wrap="square" lIns="180000" rIns="180000" tIns="180000"/>
+          <a:lstStyle/>
+          <a:p>
+            <a:pPr algn="l">
+              <a:spcAft>
+                <a:spcPts val="600"/>
+              </a:spcAft>
+            </a:pPr>
+            <a:r>
+              <a:rPr sz="1500" b="1">
+                <a:solidFill>
+                  <a:srgbClr val="1F3A5F"/>
+                </a:solidFill>
+                <a:latin typeface="Calibri"/>
+              </a:rPr>
+              <a:t>Validador de guias</a:t>
+            </a:r>
+          </a:p>
+        </p:txBody>
+      </p:sp>
+      <p:sp>
+        <p:nvSpPr>
+          <p:cNvPr id="9" name="Rounded Rectangle 8"/>
+          <p:cNvSpPr/>
+          <p:nvPr/>
+        </p:nvSpPr>
+        <p:spPr>
+          <a:xfrm>
+            <a:off x="8856000" y="1800000"/>
+            <a:ext cx="2592000" cy="1368000"/>
+          </a:xfrm>
+          <a:prstGeom prst="roundRect">
+            <a:avLst>
+              <a:gd name="adj" fmla="val 8000"/>
+            </a:avLst>
+          </a:prstGeom>
+          <a:solidFill>
+            <a:srgbClr val="E8EEF5"/>
+          </a:solidFill>
+          <a:ln>
+            <a:noFill/>
+          </a:ln>
+          <a:effectLst/>
+        </p:spPr>
+        <p:style>
+          <a:lnRef idx="1">
+            <a:schemeClr val="accent1"/>
+          </a:lnRef>
+          <a:fillRef idx="3">
+            <a:schemeClr val="accent1"/>
+          </a:fillRef>
+          <a:effectRef idx="2">
+            <a:schemeClr val="accent1"/>
+          </a:effectRef>
+          <a:fontRef idx="minor">
+            <a:schemeClr val="lt1"/>
+          </a:fontRef>
+        </p:style>
+        <p:txBody>
+          <a:bodyPr rtlCol="0" anchor="t" wrap="square" lIns="180000" rIns="180000" tIns="180000"/>
+          <a:lstStyle/>
+          <a:p>
+            <a:pPr algn="l">
+              <a:spcAft>
+                <a:spcPts val="600"/>
+              </a:spcAft>
+            </a:pPr>
+            <a:r>
+              <a:rPr sz="1500" b="1">
+                <a:solidFill>
+                  <a:srgbClr val="1F3A5F"/>
+                </a:solidFill>
+                <a:latin typeface="Calibri"/>
+              </a:rPr>
+              <a:t>Fechamento interativo (piloto)</a:t>
+            </a:r>
+          </a:p>
+        </p:txBody>
+      </p:sp>
+      <p:sp>
+        <p:nvSpPr>
+          <p:cNvPr id="10" name="Rounded Rectangle 9"/>
+          <p:cNvSpPr/>
+          <p:nvPr/>
+        </p:nvSpPr>
+        <p:spPr>
+          <a:xfrm>
+            <a:off x="648000" y="3456000"/>
+            <a:ext cx="2592000" cy="1368000"/>
+          </a:xfrm>
+          <a:prstGeom prst="roundRect">
+            <a:avLst>
+              <a:gd name="adj" fmla="val 8000"/>
+            </a:avLst>
+          </a:prstGeom>
+          <a:solidFill>
+            <a:srgbClr val="E8EEF5"/>
+          </a:solidFill>
+          <a:ln>
+            <a:noFill/>
+          </a:ln>
+          <a:effectLst/>
+        </p:spPr>
+        <p:style>
+          <a:lnRef idx="1">
+            <a:schemeClr val="accent1"/>
+          </a:lnRef>
+          <a:fillRef idx="3">
+            <a:schemeClr val="accent1"/>
+          </a:fillRef>
+          <a:effectRef idx="2">
+            <a:schemeClr val="accent1"/>
+          </a:effectRef>
+          <a:fontRef idx="minor">
+            <a:schemeClr val="lt1"/>
+          </a:fontRef>
+        </p:style>
+        <p:txBody>
+          <a:bodyPr rtlCol="0" anchor="t" wrap="square" lIns="180000" rIns="180000" tIns="180000"/>
+          <a:lstStyle/>
+          <a:p>
+            <a:pPr algn="l">
+              <a:spcAft>
+                <a:spcPts val="600"/>
+              </a:spcAft>
+            </a:pPr>
+            <a:r>
+              <a:rPr sz="1500" b="1">
+                <a:solidFill>
+                  <a:srgbClr val="1F3A5F"/>
+                </a:solidFill>
+                <a:latin typeface="Calibri"/>
+              </a:rPr>
+              <a:t>Auditoria Trello × OneDrive</a:t>
+            </a:r>
+          </a:p>
+        </p:txBody>
+      </p:sp>
+      <p:sp>
+        <p:nvSpPr>
+          <p:cNvPr id="11" name="Rounded Rectangle 10"/>
+          <p:cNvSpPr/>
+          <p:nvPr/>
+        </p:nvSpPr>
+        <p:spPr>
+          <a:xfrm>
+            <a:off x="3384000" y="3456000"/>
+            <a:ext cx="2592000" cy="1368000"/>
+          </a:xfrm>
+          <a:prstGeom prst="roundRect">
+            <a:avLst>
+              <a:gd name="adj" fmla="val 8000"/>
+            </a:avLst>
+          </a:prstGeom>
+          <a:solidFill>
+            <a:srgbClr val="E8EEF5"/>
+          </a:solidFill>
+          <a:ln>
+            <a:noFill/>
+          </a:ln>
+          <a:effectLst/>
+        </p:spPr>
+        <p:style>
+          <a:lnRef idx="1">
+            <a:schemeClr val="accent1"/>
+          </a:lnRef>
+          <a:fillRef idx="3">
+            <a:schemeClr val="accent1"/>
+          </a:fillRef>
+          <a:effectRef idx="2">
+            <a:schemeClr val="accent1"/>
+          </a:effectRef>
+          <a:fontRef idx="minor">
+            <a:schemeClr val="lt1"/>
+          </a:fontRef>
+        </p:style>
+        <p:txBody>
+          <a:bodyPr rtlCol="0" anchor="t" wrap="square" lIns="180000" rIns="180000" tIns="180000"/>
+          <a:lstStyle/>
+          <a:p>
+            <a:pPr algn="l">
+              <a:spcAft>
+                <a:spcPts val="600"/>
+              </a:spcAft>
+            </a:pPr>
+            <a:r>
+              <a:rPr sz="1500" b="1">
+                <a:solidFill>
+                  <a:srgbClr val="1F3A5F"/>
+                </a:solidFill>
+                <a:latin typeface="Calibri"/>
+              </a:rPr>
+              <a:t>Fila de pedidos de pagamento</a:t>
+            </a:r>
+          </a:p>
+        </p:txBody>
+      </p:sp>
+      <p:sp>
+        <p:nvSpPr>
+          <p:cNvPr id="12" name="Rounded Rectangle 11"/>
+          <p:cNvSpPr/>
+          <p:nvPr/>
+        </p:nvSpPr>
+        <p:spPr>
+          <a:xfrm>
+            <a:off x="6120000" y="3456000"/>
+            <a:ext cx="2592000" cy="1368000"/>
+          </a:xfrm>
+          <a:prstGeom prst="roundRect">
+            <a:avLst>
+              <a:gd name="adj" fmla="val 8000"/>
+            </a:avLst>
+          </a:prstGeom>
+          <a:solidFill>
+            <a:srgbClr val="E8EEF5"/>
+          </a:solidFill>
+          <a:ln>
+            <a:noFill/>
+          </a:ln>
+          <a:effectLst/>
+        </p:spPr>
+        <p:style>
+          <a:lnRef idx="1">
+            <a:schemeClr val="accent1"/>
+          </a:lnRef>
+          <a:fillRef idx="3">
+            <a:schemeClr val="accent1"/>
+          </a:fillRef>
+          <a:effectRef idx="2">
+            <a:schemeClr val="accent1"/>
+          </a:effectRef>
+          <a:fontRef idx="minor">
+            <a:schemeClr val="lt1"/>
+          </a:fontRef>
+        </p:style>
+        <p:txBody>
+          <a:bodyPr rtlCol="0" anchor="t" wrap="square" lIns="180000" rIns="180000" tIns="180000"/>
+          <a:lstStyle/>
+          <a:p>
+            <a:pPr algn="l">
+              <a:spcAft>
+                <a:spcPts val="600"/>
+              </a:spcAft>
+            </a:pPr>
+            <a:r>
+              <a:rPr sz="1500" b="1">
+                <a:solidFill>
+                  <a:srgbClr val="1F3A5F"/>
+                </a:solidFill>
+                <a:latin typeface="Calibri"/>
+              </a:rPr>
+              <a:t>Painel de desempenho</a:t>
+            </a:r>
+          </a:p>
+        </p:txBody>
+      </p:sp>
+      <p:sp>
+        <p:nvSpPr>
+          <p:cNvPr id="13" name="Rounded Rectangle 12"/>
+          <p:cNvSpPr/>
+          <p:nvPr/>
+        </p:nvSpPr>
+        <p:spPr>
+          <a:xfrm>
+            <a:off x="8856000" y="3456000"/>
+            <a:ext cx="2592000" cy="1368000"/>
+          </a:xfrm>
+          <a:prstGeom prst="roundRect">
+            <a:avLst>
+              <a:gd name="adj" fmla="val 8000"/>
+            </a:avLst>
+          </a:prstGeom>
+          <a:solidFill>
+            <a:srgbClr val="E8EEF5"/>
+          </a:solidFill>
+          <a:ln>
+            <a:noFill/>
+          </a:ln>
+          <a:effectLst/>
+        </p:spPr>
+        <p:style>
+          <a:lnRef idx="1">
+            <a:schemeClr val="accent1"/>
+          </a:lnRef>
+          <a:fillRef idx="3">
+            <a:schemeClr val="accent1"/>
+          </a:fillRef>
+          <a:effectRef idx="2">
+            <a:schemeClr val="accent1"/>
+          </a:effectRef>
+          <a:fontRef idx="minor">
+            <a:schemeClr val="lt1"/>
+          </a:fontRef>
+        </p:style>
+        <p:txBody>
+          <a:bodyPr rtlCol="0" anchor="t" wrap="square" lIns="180000" rIns="180000" tIns="180000"/>
+          <a:lstStyle/>
+          <a:p>
+            <a:pPr algn="l">
+              <a:spcAft>
+                <a:spcPts val="600"/>
+              </a:spcAft>
+            </a:pPr>
+            <a:r>
+              <a:rPr sz="1500" b="1">
+                <a:solidFill>
+                  <a:srgbClr val="1F3A5F"/>
+                </a:solidFill>
+                <a:latin typeface="Calibri"/>
+              </a:rPr>
+              <a:t>Comercial e CRM (2027)</a:t>
+            </a:r>
+          </a:p>
+        </p:txBody>
+      </p:sp>
+      <p:sp>
+        <p:nvSpPr>
+          <p:cNvPr id="14" name="TextBox 13"/>
+          <p:cNvSpPr txBox="1"/>
+          <p:nvPr/>
+        </p:nvSpPr>
+        <p:spPr>
+          <a:xfrm>
+            <a:off x="648000" y="5256000"/>
+            <a:ext cx="10800000" cy="720000"/>
+          </a:xfrm>
+          <a:prstGeom prst="rect">
+            <a:avLst/>
+          </a:prstGeom>
+          <a:noFill/>
+        </p:spPr>
+        <p:txBody>
+          <a:bodyPr wrap="square" anchor="t" lIns="180000" rIns="180000" tIns="180000">
+            <a:spAutoFit/>
+          </a:bodyPr>
+          <a:lstStyle/>
+          <a:p>
+            <a:pPr algn="l">
+              <a:spcAft>
+                <a:spcPts val="600"/>
+              </a:spcAft>
+            </a:pPr>
+            <a:r>
+              <a:rPr sz="1300" b="0">
+                <a:solidFill>
+                  <a:srgbClr val="595959"/>
+                </a:solidFill>
+                <a:latin typeface="Calibri"/>
+              </a:rPr>
+              <a:t>Porte de referência: P R$ 1,5 a 2,8 mil · M R$ 3,5 a 6,5 mil · G R$ 8 a 13 mil. Licenças por conta da Surcin.</a:t>
+            </a:r>
+          </a:p>
+        </p:txBody>
+      </p:sp>
+    </p:spTree>
+  </p:cSld>
+  <p:clrMapOvr>
+    <a:masterClrMapping/>
+  </p:clrMapOvr>
+</p:sld>
+</file>
+
+<file path=ppt/slides/slide11.xml><?xml version="1.0" encoding="utf-8"?>
+<p:sld xmlns:a="http://schemas.openxmlformats.org/drawingml/2006/main" xmlns:p="http://schemas.openxmlformats.org/presentationml/2006/main" xmlns:r="http://schemas.openxmlformats.org/officeDocument/2006/relationships">
+  <p:cSld>
+    <p:spTree>
+      <p:nvGrpSpPr>
+        <p:cNvPr id="1" name=""/>
+        <p:cNvGrpSpPr/>
+        <p:nvPr/>
+      </p:nvGrpSpPr>
+      <p:grpSpPr/>
+      <p:sp>
+        <p:nvSpPr>
+          <p:cNvPr id="2" name="Rectangle 1"/>
+          <p:cNvSpPr/>
+          <p:nvPr/>
+        </p:nvSpPr>
+        <p:spPr>
+          <a:xfrm>
+            <a:off x="0" y="0"/>
+            <a:ext cx="12192119" cy="180000"/>
+          </a:xfrm>
+          <a:prstGeom prst="rect">
+            <a:avLst/>
+          </a:prstGeom>
+          <a:solidFill>
+            <a:srgbClr val="1F3A5F"/>
+          </a:solidFill>
+          <a:ln>
+            <a:noFill/>
+          </a:ln>
+        </p:spPr>
+        <p:style>
+          <a:lnRef idx="1">
+            <a:schemeClr val="accent1"/>
+          </a:lnRef>
+          <a:fillRef idx="3">
+            <a:schemeClr val="accent1"/>
+          </a:fillRef>
+          <a:effectRef idx="2">
+            <a:schemeClr val="accent1"/>
+          </a:effectRef>
+          <a:fontRef idx="minor">
+            <a:schemeClr val="lt1"/>
+          </a:fontRef>
+        </p:style>
+        <p:txBody>
+          <a:bodyPr rtlCol="0" anchor="ctr"/>
+          <a:lstStyle/>
+          <a:p>
+            <a:pPr algn="ctr"/>
+          </a:p>
+        </p:txBody>
+      </p:sp>
+      <p:sp>
+        <p:nvSpPr>
+          <p:cNvPr id="3" name="TextBox 2"/>
+          <p:cNvSpPr txBox="1"/>
+          <p:nvPr/>
+        </p:nvSpPr>
+        <p:spPr>
+          <a:xfrm>
+            <a:off x="648000" y="468000"/>
+            <a:ext cx="10800000" cy="720000"/>
+          </a:xfrm>
+          <a:prstGeom prst="rect">
+            <a:avLst/>
+          </a:prstGeom>
+          <a:noFill/>
+        </p:spPr>
+        <p:txBody>
+          <a:bodyPr wrap="square" anchor="t" lIns="180000" rIns="180000" tIns="180000">
+            <a:spAutoFit/>
+          </a:bodyPr>
+          <a:lstStyle/>
+          <a:p>
+            <a:pPr algn="l">
+              <a:spcAft>
+                <a:spcPts val="600"/>
+              </a:spcAft>
+            </a:pPr>
+            <a:r>
+              <a:rPr sz="3000" b="1">
+                <a:solidFill>
+                  <a:srgbClr val="1F3A5F"/>
+                </a:solidFill>
+                <a:latin typeface="Calibri"/>
+              </a:rPr>
+              <a:t>Próximos passos</a:t>
+            </a:r>
+          </a:p>
+        </p:txBody>
+      </p:sp>
+      <p:sp>
+        <p:nvSpPr>
+          <p:cNvPr id="4" name="TextBox 3"/>
+          <p:cNvSpPr txBox="1"/>
+          <p:nvPr/>
+        </p:nvSpPr>
+        <p:spPr>
+          <a:xfrm>
+            <a:off x="648000" y="6336000"/>
+            <a:ext cx="10800000" cy="288000"/>
+          </a:xfrm>
+          <a:prstGeom prst="rect">
+            <a:avLst/>
+          </a:prstGeom>
+          <a:noFill/>
+        </p:spPr>
+        <p:txBody>
+          <a:bodyPr wrap="square" anchor="t" lIns="180000" rIns="180000" tIns="180000">
+            <a:spAutoFit/>
+          </a:bodyPr>
+          <a:lstStyle/>
+          <a:p>
+            <a:pPr algn="l">
+              <a:spcAft>
+                <a:spcPts val="600"/>
+              </a:spcAft>
+            </a:pPr>
+            <a:r>
+              <a:rPr sz="900" b="0">
+                <a:solidFill>
+                  <a:srgbClr val="595959"/>
+                </a:solidFill>
+                <a:latin typeface="Calibri"/>
+              </a:rPr>
+              <a:t>Surcin · Proposta de consultoria · Confidencial</a:t>
+            </a:r>
+          </a:p>
+        </p:txBody>
+      </p:sp>
+      <p:sp>
+        <p:nvSpPr>
+          <p:cNvPr id="5" name="TextBox 4"/>
+          <p:cNvSpPr txBox="1"/>
+          <p:nvPr/>
+        </p:nvSpPr>
+        <p:spPr>
+          <a:xfrm>
+            <a:off x="648000" y="1620000"/>
+            <a:ext cx="10800000" cy="3960000"/>
+          </a:xfrm>
+          <a:prstGeom prst="rect">
+            <a:avLst/>
+          </a:prstGeom>
+          <a:noFill/>
+        </p:spPr>
+        <p:txBody>
+          <a:bodyPr wrap="square" anchor="t" lIns="180000" rIns="180000" tIns="180000">
+            <a:spAutoFit/>
+          </a:bodyPr>
+          <a:lstStyle/>
+          <a:p>
+            <a:pPr algn="l">
+              <a:spcAft>
+                <a:spcPts val="600"/>
+              </a:spcAft>
+            </a:pPr>
+            <a:r>
+              <a:rPr sz="1800" b="0">
+                <a:solidFill>
+                  <a:srgbClr val="1F3A5F"/>
+                </a:solidFill>
+                <a:latin typeface="Calibri"/>
+              </a:rPr>
+              <a:t>1. Escolha da opção e aceite da proposta</a:t>
+            </a:r>
+          </a:p>
+          <a:p>
+            <a:pPr algn="l">
+              <a:spcAft>
+                <a:spcPts val="600"/>
+              </a:spcAft>
+            </a:pPr>
+            <a:r>
+              <a:rPr sz="1800" b="0">
+                <a:solidFill>
+                  <a:srgbClr val="1F3A5F"/>
+                </a:solidFill>
+                <a:latin typeface="Calibri"/>
+              </a:rPr>
+              <a:t>2. Acordo de confidencialidade</a:t>
+            </a:r>
+          </a:p>
+          <a:p>
+            <a:pPr algn="l">
+              <a:spcAft>
+                <a:spcPts val="600"/>
+              </a:spcAft>
+            </a:pPr>
+            <a:r>
+              <a:rPr sz="1800" b="0">
+                <a:solidFill>
+                  <a:srgbClr val="1F3A5F"/>
+                </a:solidFill>
+                <a:latin typeface="Calibri"/>
+              </a:rPr>
+              <a:t>3. Kick-off na semana de 19/10, com a Júlia como ponto focal</a:t>
+            </a:r>
+          </a:p>
+          <a:p>
+            <a:pPr algn="l">
+              <a:spcAft>
+                <a:spcPts val="600"/>
+              </a:spcAft>
+            </a:pPr>
+            <a:r>
+              <a:rPr sz="1800" b="0">
+                <a:solidFill>
+                  <a:srgbClr val="1F3A5F"/>
+                </a:solidFill>
+                <a:latin typeface="Calibri"/>
+              </a:rPr>
+              <a:t/>
+            </a:r>
+          </a:p>
+          <a:p>
+            <a:pPr algn="l">
+              <a:spcAft>
+                <a:spcPts val="600"/>
+              </a:spcAft>
+            </a:pPr>
+            <a:r>
+              <a:rPr sz="1800" b="0">
+                <a:solidFill>
+                  <a:srgbClr val="1F3A5F"/>
+                </a:solidFill>
+                <a:latin typeface="Calibri"/>
+              </a:rPr>
+              <a:t>Para confirmar hoje:</a:t>
+            </a:r>
+          </a:p>
+          <a:p>
+            <a:pPr algn="l">
+              <a:spcAft>
+                <a:spcPts val="600"/>
+              </a:spcAft>
+            </a:pPr>
+            <a:r>
+              <a:rPr sz="1800" b="0">
+                <a:solidFill>
+                  <a:srgbClr val="1F3A5F"/>
+                </a:solidFill>
+                <a:latin typeface="Calibri"/>
+              </a:rPr>
+              <a:t>• A contabilidade é executada pela Joyce?</a:t>
+            </a:r>
+          </a:p>
+          <a:p>
+            <a:pPr algn="l">
+              <a:spcAft>
+                <a:spcPts val="600"/>
+              </a:spcAft>
+            </a:pPr>
+            <a:r>
+              <a:rPr sz="1800" b="0">
+                <a:solidFill>
+                  <a:srgbClr val="1F3A5F"/>
+                </a:solidFill>
+                <a:latin typeface="Calibri"/>
+              </a:rPr>
+              <a:t>• Quem emite as notas a partir de novembro?</a:t>
+            </a:r>
+          </a:p>
+          <a:p>
+            <a:pPr algn="l">
+              <a:spcAft>
+                <a:spcPts val="600"/>
+              </a:spcAft>
+            </a:pPr>
+            <a:r>
+              <a:rPr sz="1800" b="0">
+                <a:solidFill>
+                  <a:srgbClr val="1F3A5F"/>
+                </a:solidFill>
+                <a:latin typeface="Calibri"/>
+              </a:rPr>
+              <a:t>• A equipe pode conversar antes das 10h30 ou no almoço?</a:t>
+            </a:r>
+          </a:p>
+          <a:p>
+            <a:pPr algn="l">
+              <a:spcAft>
+                <a:spcPts val="600"/>
+              </a:spcAft>
+            </a:pPr>
+            <a:r>
+              <a:rPr sz="1800" b="0">
+                <a:solidFill>
+                  <a:srgbClr val="1F3A5F"/>
+                </a:solidFill>
+                <a:latin typeface="Calibri"/>
+              </a:rPr>
+              <a:t>• Tráfego volta em 15/12 ou em janeiro?</a:t>
+            </a:r>
+          </a:p>
+          <a:p>
+            <a:pPr algn="l">
+              <a:spcAft>
+                <a:spcPts val="600"/>
+              </a:spcAft>
+            </a:pPr>
+            <a:r>
+              <a:rPr sz="1800" b="0">
+                <a:solidFill>
+                  <a:srgbClr val="1F3A5F"/>
+                </a:solidFill>
+                <a:latin typeface="Calibri"/>
+              </a:rPr>
+              <a:t>• Quem corrige a parametrização do Domínio?</a:t>
             </a:r>
           </a:p>
         </p:txBody>
@@ -3504,7 +4517,7 @@
                 </a:solidFill>
                 <a:latin typeface="Calibri"/>
               </a:rPr>
-              <a:t>• ~40 clientes de contabilidade</a:t>
+              <a:t>• 40 a 45 empresas no fiscal</a:t>
             </a:r>
           </a:p>
           <a:p>
@@ -3520,7 +4533,7 @@
                 </a:solidFill>
                 <a:latin typeface="Calibri"/>
               </a:rPr>
-              <a:t>• 12 a 16 clientes de financeiro</a:t>
+              <a:t>• 13 a 15 clientes de BPO financeiro</a:t>
             </a:r>
           </a:p>
           <a:p>
@@ -3675,7 +4688,7 @@
                 </a:solidFill>
                 <a:latin typeface="Calibri"/>
               </a:rPr>
-              <a:t>• Contabilidade sem responsável técnico</a:t>
+              <a:t>• Fiscal nas suas mãos desde agosto</a:t>
             </a:r>
           </a:p>
           <a:p>
@@ -3691,7 +4704,7 @@
                 </a:solidFill>
                 <a:latin typeface="Calibri"/>
               </a:rPr>
-              <a:t>• Erro de agosto no Domínio: multa e cliente perdido</a:t>
+              <a:t>• Parâmetros fiscais errados: ISS, multa, cliente perdido</a:t>
             </a:r>
           </a:p>
           <a:p>
@@ -3723,7 +4736,7 @@
                 </a:solidFill>
                 <a:latin typeface="Calibri"/>
               </a:rPr>
-              <a:t>• Sem métricas para premiar a equipe</a:t>
+              <a:t>• Guia na pasta errada, tarefa concluída sem evidência</a:t>
             </a:r>
           </a:p>
         </p:txBody>
@@ -3985,7 +4998,7 @@
                 </a:solidFill>
                 <a:latin typeface="Calibri"/>
               </a:rPr>
-              <a:t>Partir do que você já construiu. Entender antes de automatizar.</a:t>
+              <a:t>Processo e controle antes de ferramenta. Cada fase termina com uma entrega e uma decisão sua.</a:t>
             </a:r>
           </a:p>
         </p:txBody>
@@ -4038,7 +5051,7 @@
         <p:spPr>
           <a:xfrm>
             <a:off x="648000" y="2160000"/>
-            <a:ext cx="2052000" cy="2520000"/>
+            <a:ext cx="2592000" cy="2520000"/>
           </a:xfrm>
           <a:prstGeom prst="roundRect">
             <a:avLst>
@@ -4083,7 +5096,7 @@
                 </a:solidFill>
                 <a:latin typeface="Calibri"/>
               </a:rPr>
-              <a:t>Etapa 0</a:t>
+              <a:t>Fase 0</a:t>
             </a:r>
           </a:p>
           <a:p>
@@ -4099,7 +5112,7 @@
                 </a:solidFill>
                 <a:latin typeface="Calibri"/>
               </a:rPr>
-              <a:t>Reunião inicial e diagnóstico preliminar</a:t>
+              <a:t>Reunião e briefing</a:t>
             </a:r>
           </a:p>
           <a:p>
@@ -4144,8 +5157,8 @@
         </p:nvSpPr>
         <p:spPr>
           <a:xfrm>
-            <a:off x="2844000" y="2160000"/>
-            <a:ext cx="2052000" cy="2520000"/>
+            <a:off x="3384000" y="2160000"/>
+            <a:ext cx="2592000" cy="2520000"/>
           </a:xfrm>
           <a:prstGeom prst="roundRect">
             <a:avLst>
@@ -4190,7 +5203,7 @@
                 </a:solidFill>
                 <a:latin typeface="Calibri"/>
               </a:rPr>
-              <a:t>Etapa 1</a:t>
+              <a:t>Fase 1</a:t>
             </a:r>
           </a:p>
           <a:p>
@@ -4206,7 +5219,7 @@
                 </a:solidFill>
                 <a:latin typeface="Calibri"/>
               </a:rPr>
-              <a:t>Mapeamento dos processos atuais</a:t>
+              <a:t>Contenção, mapeamento, estrutura e plano</a:t>
             </a:r>
           </a:p>
           <a:p>
@@ -4251,222 +5264,8 @@
         </p:nvSpPr>
         <p:spPr>
           <a:xfrm>
-            <a:off x="5040000" y="2160000"/>
-            <a:ext cx="2052000" cy="2520000"/>
-          </a:xfrm>
-          <a:prstGeom prst="roundRect">
-            <a:avLst>
-              <a:gd name="adj" fmla="val 8000"/>
-            </a:avLst>
-          </a:prstGeom>
-          <a:solidFill>
-            <a:srgbClr val="1F3A5F"/>
-          </a:solidFill>
-          <a:ln>
-            <a:noFill/>
-          </a:ln>
-          <a:effectLst/>
-        </p:spPr>
-        <p:style>
-          <a:lnRef idx="1">
-            <a:schemeClr val="accent1"/>
-          </a:lnRef>
-          <a:fillRef idx="3">
-            <a:schemeClr val="accent1"/>
-          </a:fillRef>
-          <a:effectRef idx="2">
-            <a:schemeClr val="accent1"/>
-          </a:effectRef>
-          <a:fontRef idx="minor">
-            <a:schemeClr val="lt1"/>
-          </a:fontRef>
-        </p:style>
-        <p:txBody>
-          <a:bodyPr rtlCol="0" anchor="t" wrap="square" lIns="180000" rIns="180000" tIns="180000"/>
-          <a:lstStyle/>
-          <a:p>
-            <a:pPr algn="l">
-              <a:spcAft>
-                <a:spcPts val="600"/>
-              </a:spcAft>
-            </a:pPr>
-            <a:r>
-              <a:rPr sz="1500" b="1">
-                <a:solidFill>
-                  <a:srgbClr val="FFFFFF"/>
-                </a:solidFill>
-                <a:latin typeface="Calibri"/>
-              </a:rPr>
-              <a:t>Etapa 2</a:t>
-            </a:r>
-          </a:p>
-          <a:p>
-            <a:pPr algn="l">
-              <a:spcAft>
-                <a:spcPts val="600"/>
-              </a:spcAft>
-            </a:pPr>
-            <a:r>
-              <a:rPr sz="1500" b="0">
-                <a:solidFill>
-                  <a:srgbClr val="FFFFFF"/>
-                </a:solidFill>
-                <a:latin typeface="Calibri"/>
-              </a:rPr>
-              <a:t>Estrutura organizacional</a:t>
-            </a:r>
-          </a:p>
-          <a:p>
-            <a:pPr algn="l">
-              <a:spcAft>
-                <a:spcPts val="600"/>
-              </a:spcAft>
-            </a:pPr>
-            <a:r>
-              <a:rPr sz="1500" b="0">
-                <a:solidFill>
-                  <a:srgbClr val="FFFFFF"/>
-                </a:solidFill>
-                <a:latin typeface="Calibri"/>
-              </a:rPr>
-              <a:t/>
-            </a:r>
-          </a:p>
-          <a:p>
-            <a:pPr algn="l">
-              <a:spcAft>
-                <a:spcPts val="600"/>
-              </a:spcAft>
-            </a:pPr>
-            <a:r>
-              <a:rPr sz="1500" b="0">
-                <a:solidFill>
-                  <a:srgbClr val="FFFFFF"/>
-                </a:solidFill>
-                <a:latin typeface="Calibri"/>
-              </a:rPr>
-              <a:t>Nesta proposta</a:t>
-            </a:r>
-          </a:p>
-        </p:txBody>
-      </p:sp>
-      <p:sp>
-        <p:nvSpPr>
-          <p:cNvPr id="9" name="Rounded Rectangle 8"/>
-          <p:cNvSpPr/>
-          <p:nvPr/>
-        </p:nvSpPr>
-        <p:spPr>
-          <a:xfrm>
-            <a:off x="7235999" y="2160000"/>
-            <a:ext cx="2052000" cy="2520000"/>
-          </a:xfrm>
-          <a:prstGeom prst="roundRect">
-            <a:avLst>
-              <a:gd name="adj" fmla="val 8000"/>
-            </a:avLst>
-          </a:prstGeom>
-          <a:solidFill>
-            <a:srgbClr val="1F3A5F"/>
-          </a:solidFill>
-          <a:ln>
-            <a:noFill/>
-          </a:ln>
-          <a:effectLst/>
-        </p:spPr>
-        <p:style>
-          <a:lnRef idx="1">
-            <a:schemeClr val="accent1"/>
-          </a:lnRef>
-          <a:fillRef idx="3">
-            <a:schemeClr val="accent1"/>
-          </a:fillRef>
-          <a:effectRef idx="2">
-            <a:schemeClr val="accent1"/>
-          </a:effectRef>
-          <a:fontRef idx="minor">
-            <a:schemeClr val="lt1"/>
-          </a:fontRef>
-        </p:style>
-        <p:txBody>
-          <a:bodyPr rtlCol="0" anchor="t" wrap="square" lIns="180000" rIns="180000" tIns="180000"/>
-          <a:lstStyle/>
-          <a:p>
-            <a:pPr algn="l">
-              <a:spcAft>
-                <a:spcPts val="600"/>
-              </a:spcAft>
-            </a:pPr>
-            <a:r>
-              <a:rPr sz="1500" b="1">
-                <a:solidFill>
-                  <a:srgbClr val="FFFFFF"/>
-                </a:solidFill>
-                <a:latin typeface="Calibri"/>
-              </a:rPr>
-              <a:t>Etapa 3</a:t>
-            </a:r>
-          </a:p>
-          <a:p>
-            <a:pPr algn="l">
-              <a:spcAft>
-                <a:spcPts val="600"/>
-              </a:spcAft>
-            </a:pPr>
-            <a:r>
-              <a:rPr sz="1500" b="0">
-                <a:solidFill>
-                  <a:srgbClr val="FFFFFF"/>
-                </a:solidFill>
-                <a:latin typeface="Calibri"/>
-              </a:rPr>
-              <a:t>Fluxos otimizados e plano de automação</a:t>
-            </a:r>
-          </a:p>
-          <a:p>
-            <a:pPr algn="l">
-              <a:spcAft>
-                <a:spcPts val="600"/>
-              </a:spcAft>
-            </a:pPr>
-            <a:r>
-              <a:rPr sz="1500" b="0">
-                <a:solidFill>
-                  <a:srgbClr val="FFFFFF"/>
-                </a:solidFill>
-                <a:latin typeface="Calibri"/>
-              </a:rPr>
-              <a:t/>
-            </a:r>
-          </a:p>
-          <a:p>
-            <a:pPr algn="l">
-              <a:spcAft>
-                <a:spcPts val="600"/>
-              </a:spcAft>
-            </a:pPr>
-            <a:r>
-              <a:rPr sz="1500" b="0">
-                <a:solidFill>
-                  <a:srgbClr val="FFFFFF"/>
-                </a:solidFill>
-                <a:latin typeface="Calibri"/>
-              </a:rPr>
-              <a:t>Nesta proposta</a:t>
-            </a:r>
-          </a:p>
-        </p:txBody>
-      </p:sp>
-      <p:sp>
-        <p:nvSpPr>
-          <p:cNvPr id="10" name="Rounded Rectangle 9"/>
-          <p:cNvSpPr/>
-          <p:nvPr/>
-        </p:nvSpPr>
-        <p:spPr>
-          <a:xfrm>
-            <a:off x="9432000" y="2160000"/>
-            <a:ext cx="2052000" cy="2520000"/>
+            <a:off x="6120000" y="2160000"/>
+            <a:ext cx="2592000" cy="2520000"/>
           </a:xfrm>
           <a:prstGeom prst="roundRect">
             <a:avLst>
@@ -4511,7 +5310,7 @@
                 </a:solidFill>
                 <a:latin typeface="Calibri"/>
               </a:rPr>
-              <a:t>Etapa 4</a:t>
+              <a:t>Fase 2</a:t>
             </a:r>
           </a:p>
           <a:p>
@@ -4527,7 +5326,7 @@
                 </a:solidFill>
                 <a:latin typeface="Calibri"/>
               </a:rPr>
-              <a:t>Implementação e acompanhamento</a:t>
+              <a:t>Implantação em módulos</a:t>
             </a:r>
           </a:p>
           <a:p>
@@ -4559,7 +5358,114 @@
                 </a:solidFill>
                 <a:latin typeface="Calibri"/>
               </a:rPr>
-              <a:t>Proposta futura</a:t>
+              <a:t>Orçada após o plano</a:t>
+            </a:r>
+          </a:p>
+        </p:txBody>
+      </p:sp>
+      <p:sp>
+        <p:nvSpPr>
+          <p:cNvPr id="9" name="Rounded Rectangle 8"/>
+          <p:cNvSpPr/>
+          <p:nvPr/>
+        </p:nvSpPr>
+        <p:spPr>
+          <a:xfrm>
+            <a:off x="8856000" y="2160000"/>
+            <a:ext cx="2592000" cy="2520000"/>
+          </a:xfrm>
+          <a:prstGeom prst="roundRect">
+            <a:avLst>
+              <a:gd name="adj" fmla="val 8000"/>
+            </a:avLst>
+          </a:prstGeom>
+          <a:solidFill>
+            <a:srgbClr val="E8EEF5"/>
+          </a:solidFill>
+          <a:ln>
+            <a:noFill/>
+          </a:ln>
+          <a:effectLst/>
+        </p:spPr>
+        <p:style>
+          <a:lnRef idx="1">
+            <a:schemeClr val="accent1"/>
+          </a:lnRef>
+          <a:fillRef idx="3">
+            <a:schemeClr val="accent1"/>
+          </a:fillRef>
+          <a:effectRef idx="2">
+            <a:schemeClr val="accent1"/>
+          </a:effectRef>
+          <a:fontRef idx="minor">
+            <a:schemeClr val="lt1"/>
+          </a:fontRef>
+        </p:style>
+        <p:txBody>
+          <a:bodyPr rtlCol="0" anchor="t" wrap="square" lIns="180000" rIns="180000" tIns="180000"/>
+          <a:lstStyle/>
+          <a:p>
+            <a:pPr algn="l">
+              <a:spcAft>
+                <a:spcPts val="600"/>
+              </a:spcAft>
+            </a:pPr>
+            <a:r>
+              <a:rPr sz="1500" b="1">
+                <a:solidFill>
+                  <a:srgbClr val="1F3A5F"/>
+                </a:solidFill>
+                <a:latin typeface="Calibri"/>
+              </a:rPr>
+              <a:t>Fase 3</a:t>
+            </a:r>
+          </a:p>
+          <a:p>
+            <a:pPr algn="l">
+              <a:spcAft>
+                <a:spcPts val="600"/>
+              </a:spcAft>
+            </a:pPr>
+            <a:r>
+              <a:rPr sz="1500" b="0">
+                <a:solidFill>
+                  <a:srgbClr val="1F3A5F"/>
+                </a:solidFill>
+                <a:latin typeface="Calibri"/>
+              </a:rPr>
+              <a:t>Acompanhamento mensal</a:t>
+            </a:r>
+          </a:p>
+          <a:p>
+            <a:pPr algn="l">
+              <a:spcAft>
+                <a:spcPts val="600"/>
+              </a:spcAft>
+            </a:pPr>
+            <a:r>
+              <a:rPr sz="1500" b="0">
+                <a:solidFill>
+                  <a:srgbClr val="1F3A5F"/>
+                </a:solidFill>
+                <a:latin typeface="Calibri"/>
+              </a:rPr>
+              <a:t/>
+            </a:r>
+          </a:p>
+          <a:p>
+            <a:pPr algn="l">
+              <a:spcAft>
+                <a:spcPts val="600"/>
+              </a:spcAft>
+            </a:pPr>
+            <a:r>
+              <a:rPr sz="1500" b="0">
+                <a:solidFill>
+                  <a:srgbClr val="1F3A5F"/>
+                </a:solidFill>
+                <a:latin typeface="Calibri"/>
+              </a:rPr>
+              <a:t>Opcional</a:t>
             </a:r>
           </a:p>
         </p:txBody>
@@ -4659,7 +5565,7 @@
                 </a:solidFill>
                 <a:latin typeface="Calibri"/>
               </a:rPr>
-              <a:t>Estrutura organizacional</a:t>
+              <a:t>Antes da sua prova</a:t>
             </a:r>
           </a:p>
         </p:txBody>
@@ -4698,7 +5604,7 @@
                 </a:solidFill>
                 <a:latin typeface="Calibri"/>
               </a:rPr>
-              <a:t>Hipótese para validarmos juntas: organizar pelo caminho do cliente</a:t>
+              <a:t>Três controles manuais em uso até 15/11, sem software e sem depender de você no dia a dia</a:t>
             </a:r>
           </a:p>
         </p:txBody>
@@ -4750,67 +5656,8 @@
         </p:nvSpPr>
         <p:spPr>
           <a:xfrm>
-            <a:off x="4464000" y="1620000"/>
-            <a:ext cx="3240000" cy="648000"/>
-          </a:xfrm>
-          <a:prstGeom prst="roundRect">
-            <a:avLst>
-              <a:gd name="adj" fmla="val 8000"/>
-            </a:avLst>
-          </a:prstGeom>
-          <a:solidFill>
-            <a:srgbClr val="1F3A5F"/>
-          </a:solidFill>
-          <a:ln>
-            <a:noFill/>
-          </a:ln>
-          <a:effectLst/>
-        </p:spPr>
-        <p:style>
-          <a:lnRef idx="1">
-            <a:schemeClr val="accent1"/>
-          </a:lnRef>
-          <a:fillRef idx="3">
-            <a:schemeClr val="accent1"/>
-          </a:fillRef>
-          <a:effectRef idx="2">
-            <a:schemeClr val="accent1"/>
-          </a:effectRef>
-          <a:fontRef idx="minor">
-            <a:schemeClr val="lt1"/>
-          </a:fontRef>
-        </p:style>
-        <p:txBody>
-          <a:bodyPr rtlCol="0" anchor="t" wrap="square" lIns="180000" rIns="180000" tIns="180000"/>
-          <a:lstStyle/>
-          <a:p>
-            <a:pPr algn="l">
-              <a:spcAft>
-                <a:spcPts val="600"/>
-              </a:spcAft>
-            </a:pPr>
-            <a:r>
-              <a:rPr sz="1600" b="1">
-                <a:solidFill>
-                  <a:srgbClr val="FFFFFF"/>
-                </a:solidFill>
-                <a:latin typeface="Calibri"/>
-              </a:rPr>
-              <a:t>Direção · Thamires</a:t>
-            </a:r>
-          </a:p>
-        </p:txBody>
-      </p:sp>
-      <p:sp>
-        <p:nvSpPr>
-          <p:cNvPr id="7" name="Rounded Rectangle 6"/>
-          <p:cNvSpPr/>
-          <p:nvPr/>
-        </p:nvSpPr>
-        <p:spPr>
-          <a:xfrm>
-            <a:off x="648000" y="2736000"/>
-            <a:ext cx="2052000" cy="936000"/>
+            <a:off x="648000" y="1980000"/>
+            <a:ext cx="3456000" cy="2880000"/>
           </a:xfrm>
           <a:prstGeom prst="roundRect">
             <a:avLst>
@@ -4849,43 +5696,59 @@
               </a:spcAft>
             </a:pPr>
             <a:r>
-              <a:rPr sz="1300" b="1">
-                <a:solidFill>
-                  <a:srgbClr val="1F3A5F"/>
-                </a:solidFill>
-                <a:latin typeface="Calibri"/>
-              </a:rPr>
-              <a:t>Revisão técnica</a:t>
-            </a:r>
-          </a:p>
-          <a:p>
-            <a:pPr algn="l">
-              <a:spcAft>
-                <a:spcPts val="600"/>
-              </a:spcAft>
-            </a:pPr>
-            <a:r>
-              <a:rPr sz="1300" b="0">
-                <a:solidFill>
-                  <a:srgbClr val="1F3A5F"/>
-                </a:solidFill>
-                <a:latin typeface="Calibri"/>
-              </a:rPr>
-              <a:t>Contador(a) em 2027</a:t>
-            </a:r>
-          </a:p>
-        </p:txBody>
-      </p:sp>
-      <p:sp>
-        <p:nvSpPr>
-          <p:cNvPr id="8" name="Rounded Rectangle 7"/>
+              <a:rPr sz="1600" b="1">
+                <a:solidFill>
+                  <a:srgbClr val="1F3A5F"/>
+                </a:solidFill>
+                <a:latin typeface="Calibri"/>
+              </a:rPr>
+              <a:t>Guia conferida</a:t>
+            </a:r>
+          </a:p>
+          <a:p>
+            <a:pPr algn="l">
+              <a:spcAft>
+                <a:spcPts val="600"/>
+              </a:spcAft>
+            </a:pPr>
+            <a:r>
+              <a:rPr sz="1600" b="0">
+                <a:solidFill>
+                  <a:srgbClr val="1F3A5F"/>
+                </a:solidFill>
+                <a:latin typeface="Calibri"/>
+              </a:rPr>
+              <a:t/>
+            </a:r>
+          </a:p>
+          <a:p>
+            <a:pPr algn="l">
+              <a:spcAft>
+                <a:spcPts val="600"/>
+              </a:spcAft>
+            </a:pPr>
+            <a:r>
+              <a:rPr sz="1600" b="0">
+                <a:solidFill>
+                  <a:srgbClr val="1F3A5F"/>
+                </a:solidFill>
+                <a:latin typeface="Calibri"/>
+              </a:rPr>
+              <a:t>Cliente, CNPJ, pasta, tributo, competência e valor conferidos antes de pagar</a:t>
+            </a:r>
+          </a:p>
+        </p:txBody>
+      </p:sp>
+      <p:sp>
+        <p:nvSpPr>
+          <p:cNvPr id="7" name="Rounded Rectangle 6"/>
           <p:cNvSpPr/>
           <p:nvPr/>
         </p:nvSpPr>
         <p:spPr>
           <a:xfrm>
-            <a:off x="2844000" y="2736000"/>
-            <a:ext cx="2052000" cy="936000"/>
+            <a:off x="4320000" y="1980000"/>
+            <a:ext cx="3456000" cy="2880000"/>
           </a:xfrm>
           <a:prstGeom prst="roundRect">
             <a:avLst>
@@ -4924,43 +5787,59 @@
               </a:spcAft>
             </a:pPr>
             <a:r>
-              <a:rPr sz="1300" b="1">
-                <a:solidFill>
-                  <a:srgbClr val="1F3A5F"/>
-                </a:solidFill>
-                <a:latin typeface="Calibri"/>
-              </a:rPr>
-              <a:t>Entrada e relacionamento</a:t>
-            </a:r>
-          </a:p>
-          <a:p>
-            <a:pPr algn="l">
-              <a:spcAft>
-                <a:spcPts val="600"/>
-              </a:spcAft>
-            </a:pPr>
-            <a:r>
-              <a:rPr sz="1300" b="0">
-                <a:solidFill>
-                  <a:srgbClr val="1F3A5F"/>
-                </a:solidFill>
-                <a:latin typeface="Calibri"/>
-              </a:rPr>
-              <a:t>Júlia</a:t>
-            </a:r>
-          </a:p>
-        </p:txBody>
-      </p:sp>
-      <p:sp>
-        <p:nvSpPr>
-          <p:cNvPr id="9" name="Rounded Rectangle 8"/>
+              <a:rPr sz="1600" b="1">
+                <a:solidFill>
+                  <a:srgbClr val="1F3A5F"/>
+                </a:solidFill>
+                <a:latin typeface="Calibri"/>
+              </a:rPr>
+              <a:t>Evidência para concluir</a:t>
+            </a:r>
+          </a:p>
+          <a:p>
+            <a:pPr algn="l">
+              <a:spcAft>
+                <a:spcPts val="600"/>
+              </a:spcAft>
+            </a:pPr>
+            <a:r>
+              <a:rPr sz="1600" b="0">
+                <a:solidFill>
+                  <a:srgbClr val="1F3A5F"/>
+                </a:solidFill>
+                <a:latin typeface="Calibri"/>
+              </a:rPr>
+              <a:t/>
+            </a:r>
+          </a:p>
+          <a:p>
+            <a:pPr algn="l">
+              <a:spcAft>
+                <a:spcPts val="600"/>
+              </a:spcAft>
+            </a:pPr>
+            <a:r>
+              <a:rPr sz="1600" b="0">
+                <a:solidFill>
+                  <a:srgbClr val="1F3A5F"/>
+                </a:solidFill>
+                <a:latin typeface="Calibri"/>
+              </a:rPr>
+              <a:t>Cartão crítico do Trello só fecha com o comprovante no OneDrive</a:t>
+            </a:r>
+          </a:p>
+        </p:txBody>
+      </p:sp>
+      <p:sp>
+        <p:nvSpPr>
+          <p:cNvPr id="8" name="Rounded Rectangle 7"/>
           <p:cNvSpPr/>
           <p:nvPr/>
         </p:nvSpPr>
         <p:spPr>
           <a:xfrm>
-            <a:off x="5040000" y="2736000"/>
-            <a:ext cx="2052000" cy="936000"/>
+            <a:off x="7992000" y="1980000"/>
+            <a:ext cx="3456000" cy="2880000"/>
           </a:xfrm>
           <a:prstGeom prst="roundRect">
             <a:avLst>
@@ -4999,234 +5878,45 @@
               </a:spcAft>
             </a:pPr>
             <a:r>
-              <a:rPr sz="1300" b="1">
-                <a:solidFill>
-                  <a:srgbClr val="1F3A5F"/>
-                </a:solidFill>
-                <a:latin typeface="Calibri"/>
-              </a:rPr>
-              <a:t>Financeiro</a:t>
-            </a:r>
-          </a:p>
-          <a:p>
-            <a:pPr algn="l">
-              <a:spcAft>
-                <a:spcPts val="600"/>
-              </a:spcAft>
-            </a:pPr>
-            <a:r>
-              <a:rPr sz="1300" b="0">
-                <a:solidFill>
-                  <a:srgbClr val="1F3A5F"/>
-                </a:solidFill>
-                <a:latin typeface="Calibri"/>
-              </a:rPr>
-              <a:t>Vitória</a:t>
-            </a:r>
-          </a:p>
-        </p:txBody>
-      </p:sp>
-      <p:sp>
-        <p:nvSpPr>
-          <p:cNvPr id="10" name="Rounded Rectangle 9"/>
-          <p:cNvSpPr/>
-          <p:nvPr/>
-        </p:nvSpPr>
-        <p:spPr>
-          <a:xfrm>
-            <a:off x="7235999" y="2736000"/>
-            <a:ext cx="2052000" cy="936000"/>
-          </a:xfrm>
-          <a:prstGeom prst="roundRect">
-            <a:avLst>
-              <a:gd name="adj" fmla="val 8000"/>
-            </a:avLst>
-          </a:prstGeom>
-          <a:solidFill>
-            <a:srgbClr val="E8EEF5"/>
-          </a:solidFill>
-          <a:ln>
-            <a:noFill/>
-          </a:ln>
-          <a:effectLst/>
-        </p:spPr>
-        <p:style>
-          <a:lnRef idx="1">
-            <a:schemeClr val="accent1"/>
-          </a:lnRef>
-          <a:fillRef idx="3">
-            <a:schemeClr val="accent1"/>
-          </a:fillRef>
-          <a:effectRef idx="2">
-            <a:schemeClr val="accent1"/>
-          </a:effectRef>
-          <a:fontRef idx="minor">
-            <a:schemeClr val="lt1"/>
-          </a:fontRef>
-        </p:style>
-        <p:txBody>
-          <a:bodyPr rtlCol="0" anchor="t" wrap="square" lIns="180000" rIns="180000" tIns="180000"/>
-          <a:lstStyle/>
-          <a:p>
-            <a:pPr algn="l">
-              <a:spcAft>
-                <a:spcPts val="600"/>
-              </a:spcAft>
-            </a:pPr>
-            <a:r>
-              <a:rPr sz="1300" b="1">
-                <a:solidFill>
-                  <a:srgbClr val="1F3A5F"/>
-                </a:solidFill>
-                <a:latin typeface="Calibri"/>
-              </a:rPr>
-              <a:t>Departamento Pessoal</a:t>
-            </a:r>
-          </a:p>
-          <a:p>
-            <a:pPr algn="l">
-              <a:spcAft>
-                <a:spcPts val="600"/>
-              </a:spcAft>
-            </a:pPr>
-            <a:r>
-              <a:rPr sz="1300" b="0">
-                <a:solidFill>
-                  <a:srgbClr val="1F3A5F"/>
-                </a:solidFill>
-                <a:latin typeface="Calibri"/>
-              </a:rPr>
-              <a:t>Tamara</a:t>
-            </a:r>
-          </a:p>
-        </p:txBody>
-      </p:sp>
-      <p:sp>
-        <p:nvSpPr>
-          <p:cNvPr id="11" name="Rounded Rectangle 10"/>
-          <p:cNvSpPr/>
-          <p:nvPr/>
-        </p:nvSpPr>
-        <p:spPr>
-          <a:xfrm>
-            <a:off x="9432000" y="2736000"/>
-            <a:ext cx="2052000" cy="936000"/>
-          </a:xfrm>
-          <a:prstGeom prst="roundRect">
-            <a:avLst>
-              <a:gd name="adj" fmla="val 8000"/>
-            </a:avLst>
-          </a:prstGeom>
-          <a:solidFill>
-            <a:srgbClr val="E8EEF5"/>
-          </a:solidFill>
-          <a:ln>
-            <a:noFill/>
-          </a:ln>
-          <a:effectLst/>
-        </p:spPr>
-        <p:style>
-          <a:lnRef idx="1">
-            <a:schemeClr val="accent1"/>
-          </a:lnRef>
-          <a:fillRef idx="3">
-            <a:schemeClr val="accent1"/>
-          </a:fillRef>
-          <a:effectRef idx="2">
-            <a:schemeClr val="accent1"/>
-          </a:effectRef>
-          <a:fontRef idx="minor">
-            <a:schemeClr val="lt1"/>
-          </a:fontRef>
-        </p:style>
-        <p:txBody>
-          <a:bodyPr rtlCol="0" anchor="t" wrap="square" lIns="180000" rIns="180000" tIns="180000"/>
-          <a:lstStyle/>
-          <a:p>
-            <a:pPr algn="l">
-              <a:spcAft>
-                <a:spcPts val="600"/>
-              </a:spcAft>
-            </a:pPr>
-            <a:r>
-              <a:rPr sz="1300" b="1">
-                <a:solidFill>
-                  <a:srgbClr val="1F3A5F"/>
-                </a:solidFill>
-                <a:latin typeface="Calibri"/>
-              </a:rPr>
-              <a:t>Jurídico</a:t>
-            </a:r>
-          </a:p>
-          <a:p>
-            <a:pPr algn="l">
-              <a:spcAft>
-                <a:spcPts val="600"/>
-              </a:spcAft>
-            </a:pPr>
-            <a:r>
-              <a:rPr sz="1300" b="0">
-                <a:solidFill>
-                  <a:srgbClr val="1F3A5F"/>
-                </a:solidFill>
-                <a:latin typeface="Calibri"/>
-              </a:rPr>
-              <a:t>Legado: a decidir</a:t>
-            </a:r>
-          </a:p>
-        </p:txBody>
-      </p:sp>
-      <p:sp>
-        <p:nvSpPr>
-          <p:cNvPr id="12" name="TextBox 11"/>
-          <p:cNvSpPr txBox="1"/>
-          <p:nvPr/>
-        </p:nvSpPr>
-        <p:spPr>
-          <a:xfrm>
-            <a:off x="648000" y="4068000"/>
-            <a:ext cx="10800000" cy="1800000"/>
-          </a:xfrm>
-          <a:prstGeom prst="rect">
-            <a:avLst/>
-          </a:prstGeom>
-          <a:noFill/>
-        </p:spPr>
-        <p:txBody>
-          <a:bodyPr wrap="square" anchor="t" lIns="180000" rIns="180000" tIns="180000">
-            <a:spAutoFit/>
-          </a:bodyPr>
-          <a:lstStyle/>
-          <a:p>
-            <a:pPr algn="l">
-              <a:spcAft>
-                <a:spcPts val="600"/>
-              </a:spcAft>
-            </a:pPr>
-            <a:r>
-              <a:rPr sz="1500" b="0">
-                <a:solidFill>
-                  <a:srgbClr val="595959"/>
-                </a:solidFill>
-                <a:latin typeface="Calibri"/>
-              </a:rPr>
-              <a:t>Entregável: organograma atual e proposto, papéis, responsabilidades e indicadores por função.</a:t>
-            </a:r>
-          </a:p>
-          <a:p>
-            <a:pPr algn="l">
-              <a:spcAft>
-                <a:spcPts val="600"/>
-              </a:spcAft>
-            </a:pPr>
-            <a:r>
-              <a:rPr sz="1500" b="0">
-                <a:solidFill>
-                  <a:srgbClr val="595959"/>
-                </a:solidFill>
-                <a:latin typeface="Calibri"/>
-              </a:rPr>
-              <a:t>É a base para delegar revisões, receber o(a) contador(a) e criar a remuneração por pontos.</a:t>
+              <a:rPr sz="1600" b="1">
+                <a:solidFill>
+                  <a:srgbClr val="1F3A5F"/>
+                </a:solidFill>
+                <a:latin typeface="Calibri"/>
+              </a:rPr>
+              <a:t>Dúvida registrada</a:t>
+            </a:r>
+          </a:p>
+          <a:p>
+            <a:pPr algn="l">
+              <a:spcAft>
+                <a:spcPts val="600"/>
+              </a:spcAft>
+            </a:pPr>
+            <a:r>
+              <a:rPr sz="1600" b="0">
+                <a:solidFill>
+                  <a:srgbClr val="1F3A5F"/>
+                </a:solidFill>
+                <a:latin typeface="Calibri"/>
+              </a:rPr>
+              <a:t/>
+            </a:r>
+          </a:p>
+          <a:p>
+            <a:pPr algn="l">
+              <a:spcAft>
+                <a:spcPts val="600"/>
+              </a:spcAft>
+            </a:pPr>
+            <a:r>
+              <a:rPr sz="1600" b="0">
+                <a:solidFill>
+                  <a:srgbClr val="1F3A5F"/>
+                </a:solidFill>
+                <a:latin typeface="Calibri"/>
+              </a:rPr>
+              <a:t>Toda dúvida levada a você vira registro: mede a dependência e alimenta o futuro assistente</a:t>
             </a:r>
           </a:p>
         </p:txBody>
@@ -5326,7 +6016,7 @@
                 </a:solidFill>
                 <a:latin typeface="Calibri"/>
               </a:rPr>
-              <a:t>Processos identificados</a:t>
+              <a:t>Estrutura organizacional</a:t>
             </a:r>
           </a:p>
         </p:txBody>
@@ -5365,7 +6055,7 @@
                 </a:solidFill>
                 <a:latin typeface="Calibri"/>
               </a:rPr>
-              <a:t>11 processos; a prioridade inicial é onde há mais risco e mais tempo gasto</a:t>
+              <a:t>Hipótese para validarmos juntas: organizar pelo caminho do cliente</a:t>
             </a:r>
           </a:p>
         </p:txBody>
@@ -5417,8 +6107,8 @@
         </p:nvSpPr>
         <p:spPr>
           <a:xfrm>
-            <a:off x="648000" y="1728000"/>
-            <a:ext cx="5220000" cy="4140000"/>
+            <a:off x="4464000" y="1620000"/>
+            <a:ext cx="3240000" cy="648000"/>
           </a:xfrm>
           <a:prstGeom prst="roundRect">
             <a:avLst>
@@ -5457,125 +6147,13 @@
               </a:spcAft>
             </a:pPr>
             <a:r>
-              <a:rPr sz="1500" b="1">
+              <a:rPr sz="1600" b="1">
                 <a:solidFill>
                   <a:srgbClr val="FFFFFF"/>
                 </a:solidFill>
                 <a:latin typeface="Calibri"/>
               </a:rPr>
-              <a:t>Prioridade 1</a:t>
-            </a:r>
-          </a:p>
-          <a:p>
-            <a:pPr algn="l">
-              <a:spcAft>
-                <a:spcPts val="600"/>
-              </a:spcAft>
-            </a:pPr>
-            <a:r>
-              <a:rPr sz="1500" b="0">
-                <a:solidFill>
-                  <a:srgbClr val="FFFFFF"/>
-                </a:solidFill>
-                <a:latin typeface="Calibri"/>
-              </a:rPr>
-              <a:t>• Fiscal mensal (44 clientes, risco de multa)</a:t>
-            </a:r>
-          </a:p>
-          <a:p>
-            <a:pPr algn="l">
-              <a:spcAft>
-                <a:spcPts val="600"/>
-              </a:spcAft>
-            </a:pPr>
-            <a:r>
-              <a:rPr sz="1500" b="0">
-                <a:solidFill>
-                  <a:srgbClr val="FFFFFF"/>
-                </a:solidFill>
-                <a:latin typeface="Calibri"/>
-              </a:rPr>
-              <a:t>• Conciliação e fechamento financeiro</a:t>
-            </a:r>
-          </a:p>
-          <a:p>
-            <a:pPr algn="l">
-              <a:spcAft>
-                <a:spcPts val="600"/>
-              </a:spcAft>
-            </a:pPr>
-            <a:r>
-              <a:rPr sz="1500" b="0">
-                <a:solidFill>
-                  <a:srgbClr val="FFFFFF"/>
-                </a:solidFill>
-                <a:latin typeface="Calibri"/>
-              </a:rPr>
-              <a:t/>
-            </a:r>
-          </a:p>
-          <a:p>
-            <a:pPr algn="l">
-              <a:spcAft>
-                <a:spcPts val="600"/>
-              </a:spcAft>
-            </a:pPr>
-            <a:r>
-              <a:rPr sz="1500" b="0">
-                <a:solidFill>
-                  <a:srgbClr val="FFFFFF"/>
-                </a:solidFill>
-                <a:latin typeface="Calibri"/>
-              </a:rPr>
-              <a:t>Prioridade 2</a:t>
-            </a:r>
-          </a:p>
-          <a:p>
-            <a:pPr algn="l">
-              <a:spcAft>
-                <a:spcPts val="600"/>
-              </a:spcAft>
-            </a:pPr>
-            <a:r>
-              <a:rPr sz="1500" b="0">
-                <a:solidFill>
-                  <a:srgbClr val="FFFFFF"/>
-                </a:solidFill>
-                <a:latin typeface="Calibri"/>
-              </a:rPr>
-              <a:t>• Implantação de novos clientes</a:t>
-            </a:r>
-          </a:p>
-          <a:p>
-            <a:pPr algn="l">
-              <a:spcAft>
-                <a:spcPts val="600"/>
-              </a:spcAft>
-            </a:pPr>
-            <a:r>
-              <a:rPr sz="1500" b="0">
-                <a:solidFill>
-                  <a:srgbClr val="FFFFFF"/>
-                </a:solidFill>
-                <a:latin typeface="Calibri"/>
-              </a:rPr>
-              <a:t>• Atendimento e triagem</a:t>
-            </a:r>
-          </a:p>
-          <a:p>
-            <a:pPr algn="l">
-              <a:spcAft>
-                <a:spcPts val="600"/>
-              </a:spcAft>
-            </a:pPr>
-            <a:r>
-              <a:rPr sz="1500" b="0">
-                <a:solidFill>
-                  <a:srgbClr val="FFFFFF"/>
-                </a:solidFill>
-                <a:latin typeface="Calibri"/>
-              </a:rPr>
-              <a:t>• Emissão de notas</a:t>
+              <a:t>Direção · Thamires</a:t>
             </a:r>
           </a:p>
         </p:txBody>
@@ -5588,8 +6166,8 @@
         </p:nvSpPr>
         <p:spPr>
           <a:xfrm>
-            <a:off x="6300000" y="1728000"/>
-            <a:ext cx="5220000" cy="4140000"/>
+            <a:off x="648000" y="2736000"/>
+            <a:ext cx="2052000" cy="936000"/>
           </a:xfrm>
           <a:prstGeom prst="roundRect">
             <a:avLst>
@@ -5628,15 +6206,354 @@
               </a:spcAft>
             </a:pPr>
             <a:r>
-              <a:rPr sz="1500" b="1">
-                <a:solidFill>
-                  <a:srgbClr val="1F3A5F"/>
-                </a:solidFill>
-                <a:latin typeface="Calibri"/>
-              </a:rPr>
-              <a:t>Prioridade 3</a:t>
-            </a:r>
-          </a:p>
+              <a:rPr sz="1300" b="1">
+                <a:solidFill>
+                  <a:srgbClr val="1F3A5F"/>
+                </a:solidFill>
+                <a:latin typeface="Calibri"/>
+              </a:rPr>
+              <a:t>Revisão técnica</a:t>
+            </a:r>
+          </a:p>
+          <a:p>
+            <a:pPr algn="l">
+              <a:spcAft>
+                <a:spcPts val="600"/>
+              </a:spcAft>
+            </a:pPr>
+            <a:r>
+              <a:rPr sz="1300" b="0">
+                <a:solidFill>
+                  <a:srgbClr val="1F3A5F"/>
+                </a:solidFill>
+                <a:latin typeface="Calibri"/>
+              </a:rPr>
+              <a:t>Terceirizada e/ou contador(a)</a:t>
+            </a:r>
+          </a:p>
+        </p:txBody>
+      </p:sp>
+      <p:sp>
+        <p:nvSpPr>
+          <p:cNvPr id="8" name="Rounded Rectangle 7"/>
+          <p:cNvSpPr/>
+          <p:nvPr/>
+        </p:nvSpPr>
+        <p:spPr>
+          <a:xfrm>
+            <a:off x="2844000" y="2736000"/>
+            <a:ext cx="2052000" cy="936000"/>
+          </a:xfrm>
+          <a:prstGeom prst="roundRect">
+            <a:avLst>
+              <a:gd name="adj" fmla="val 8000"/>
+            </a:avLst>
+          </a:prstGeom>
+          <a:solidFill>
+            <a:srgbClr val="E8EEF5"/>
+          </a:solidFill>
+          <a:ln>
+            <a:noFill/>
+          </a:ln>
+          <a:effectLst/>
+        </p:spPr>
+        <p:style>
+          <a:lnRef idx="1">
+            <a:schemeClr val="accent1"/>
+          </a:lnRef>
+          <a:fillRef idx="3">
+            <a:schemeClr val="accent1"/>
+          </a:fillRef>
+          <a:effectRef idx="2">
+            <a:schemeClr val="accent1"/>
+          </a:effectRef>
+          <a:fontRef idx="minor">
+            <a:schemeClr val="lt1"/>
+          </a:fontRef>
+        </p:style>
+        <p:txBody>
+          <a:bodyPr rtlCol="0" anchor="t" wrap="square" lIns="180000" rIns="180000" tIns="180000"/>
+          <a:lstStyle/>
+          <a:p>
+            <a:pPr algn="l">
+              <a:spcAft>
+                <a:spcPts val="600"/>
+              </a:spcAft>
+            </a:pPr>
+            <a:r>
+              <a:rPr sz="1300" b="1">
+                <a:solidFill>
+                  <a:srgbClr val="1F3A5F"/>
+                </a:solidFill>
+                <a:latin typeface="Calibri"/>
+              </a:rPr>
+              <a:t>Entrada e relacionamento</a:t>
+            </a:r>
+          </a:p>
+          <a:p>
+            <a:pPr algn="l">
+              <a:spcAft>
+                <a:spcPts val="600"/>
+              </a:spcAft>
+            </a:pPr>
+            <a:r>
+              <a:rPr sz="1300" b="0">
+                <a:solidFill>
+                  <a:srgbClr val="1F3A5F"/>
+                </a:solidFill>
+                <a:latin typeface="Calibri"/>
+              </a:rPr>
+              <a:t>Júlia</a:t>
+            </a:r>
+          </a:p>
+        </p:txBody>
+      </p:sp>
+      <p:sp>
+        <p:nvSpPr>
+          <p:cNvPr id="9" name="Rounded Rectangle 8"/>
+          <p:cNvSpPr/>
+          <p:nvPr/>
+        </p:nvSpPr>
+        <p:spPr>
+          <a:xfrm>
+            <a:off x="5040000" y="2736000"/>
+            <a:ext cx="2052000" cy="936000"/>
+          </a:xfrm>
+          <a:prstGeom prst="roundRect">
+            <a:avLst>
+              <a:gd name="adj" fmla="val 8000"/>
+            </a:avLst>
+          </a:prstGeom>
+          <a:solidFill>
+            <a:srgbClr val="E8EEF5"/>
+          </a:solidFill>
+          <a:ln>
+            <a:noFill/>
+          </a:ln>
+          <a:effectLst/>
+        </p:spPr>
+        <p:style>
+          <a:lnRef idx="1">
+            <a:schemeClr val="accent1"/>
+          </a:lnRef>
+          <a:fillRef idx="3">
+            <a:schemeClr val="accent1"/>
+          </a:fillRef>
+          <a:effectRef idx="2">
+            <a:schemeClr val="accent1"/>
+          </a:effectRef>
+          <a:fontRef idx="minor">
+            <a:schemeClr val="lt1"/>
+          </a:fontRef>
+        </p:style>
+        <p:txBody>
+          <a:bodyPr rtlCol="0" anchor="t" wrap="square" lIns="180000" rIns="180000" tIns="180000"/>
+          <a:lstStyle/>
+          <a:p>
+            <a:pPr algn="l">
+              <a:spcAft>
+                <a:spcPts val="600"/>
+              </a:spcAft>
+            </a:pPr>
+            <a:r>
+              <a:rPr sz="1300" b="1">
+                <a:solidFill>
+                  <a:srgbClr val="1F3A5F"/>
+                </a:solidFill>
+                <a:latin typeface="Calibri"/>
+              </a:rPr>
+              <a:t>Financeiro</a:t>
+            </a:r>
+          </a:p>
+          <a:p>
+            <a:pPr algn="l">
+              <a:spcAft>
+                <a:spcPts val="600"/>
+              </a:spcAft>
+            </a:pPr>
+            <a:r>
+              <a:rPr sz="1300" b="0">
+                <a:solidFill>
+                  <a:srgbClr val="1F3A5F"/>
+                </a:solidFill>
+                <a:latin typeface="Calibri"/>
+              </a:rPr>
+              <a:t>Vitória</a:t>
+            </a:r>
+          </a:p>
+        </p:txBody>
+      </p:sp>
+      <p:sp>
+        <p:nvSpPr>
+          <p:cNvPr id="10" name="Rounded Rectangle 9"/>
+          <p:cNvSpPr/>
+          <p:nvPr/>
+        </p:nvSpPr>
+        <p:spPr>
+          <a:xfrm>
+            <a:off x="7235999" y="2736000"/>
+            <a:ext cx="2052000" cy="936000"/>
+          </a:xfrm>
+          <a:prstGeom prst="roundRect">
+            <a:avLst>
+              <a:gd name="adj" fmla="val 8000"/>
+            </a:avLst>
+          </a:prstGeom>
+          <a:solidFill>
+            <a:srgbClr val="E8EEF5"/>
+          </a:solidFill>
+          <a:ln>
+            <a:noFill/>
+          </a:ln>
+          <a:effectLst/>
+        </p:spPr>
+        <p:style>
+          <a:lnRef idx="1">
+            <a:schemeClr val="accent1"/>
+          </a:lnRef>
+          <a:fillRef idx="3">
+            <a:schemeClr val="accent1"/>
+          </a:fillRef>
+          <a:effectRef idx="2">
+            <a:schemeClr val="accent1"/>
+          </a:effectRef>
+          <a:fontRef idx="minor">
+            <a:schemeClr val="lt1"/>
+          </a:fontRef>
+        </p:style>
+        <p:txBody>
+          <a:bodyPr rtlCol="0" anchor="t" wrap="square" lIns="180000" rIns="180000" tIns="180000"/>
+          <a:lstStyle/>
+          <a:p>
+            <a:pPr algn="l">
+              <a:spcAft>
+                <a:spcPts val="600"/>
+              </a:spcAft>
+            </a:pPr>
+            <a:r>
+              <a:rPr sz="1300" b="1">
+                <a:solidFill>
+                  <a:srgbClr val="1F3A5F"/>
+                </a:solidFill>
+                <a:latin typeface="Calibri"/>
+              </a:rPr>
+              <a:t>Departamento Pessoal</a:t>
+            </a:r>
+          </a:p>
+          <a:p>
+            <a:pPr algn="l">
+              <a:spcAft>
+                <a:spcPts val="600"/>
+              </a:spcAft>
+            </a:pPr>
+            <a:r>
+              <a:rPr sz="1300" b="0">
+                <a:solidFill>
+                  <a:srgbClr val="1F3A5F"/>
+                </a:solidFill>
+                <a:latin typeface="Calibri"/>
+              </a:rPr>
+              <a:t>Tamara</a:t>
+            </a:r>
+          </a:p>
+        </p:txBody>
+      </p:sp>
+      <p:sp>
+        <p:nvSpPr>
+          <p:cNvPr id="11" name="Rounded Rectangle 10"/>
+          <p:cNvSpPr/>
+          <p:nvPr/>
+        </p:nvSpPr>
+        <p:spPr>
+          <a:xfrm>
+            <a:off x="9432000" y="2736000"/>
+            <a:ext cx="2052000" cy="936000"/>
+          </a:xfrm>
+          <a:prstGeom prst="roundRect">
+            <a:avLst>
+              <a:gd name="adj" fmla="val 8000"/>
+            </a:avLst>
+          </a:prstGeom>
+          <a:solidFill>
+            <a:srgbClr val="E8EEF5"/>
+          </a:solidFill>
+          <a:ln>
+            <a:noFill/>
+          </a:ln>
+          <a:effectLst/>
+        </p:spPr>
+        <p:style>
+          <a:lnRef idx="1">
+            <a:schemeClr val="accent1"/>
+          </a:lnRef>
+          <a:fillRef idx="3">
+            <a:schemeClr val="accent1"/>
+          </a:fillRef>
+          <a:effectRef idx="2">
+            <a:schemeClr val="accent1"/>
+          </a:effectRef>
+          <a:fontRef idx="minor">
+            <a:schemeClr val="lt1"/>
+          </a:fontRef>
+        </p:style>
+        <p:txBody>
+          <a:bodyPr rtlCol="0" anchor="t" wrap="square" lIns="180000" rIns="180000" tIns="180000"/>
+          <a:lstStyle/>
+          <a:p>
+            <a:pPr algn="l">
+              <a:spcAft>
+                <a:spcPts val="600"/>
+              </a:spcAft>
+            </a:pPr>
+            <a:r>
+              <a:rPr sz="1300" b="1">
+                <a:solidFill>
+                  <a:srgbClr val="1F3A5F"/>
+                </a:solidFill>
+                <a:latin typeface="Calibri"/>
+              </a:rPr>
+              <a:t>Jurídico</a:t>
+            </a:r>
+          </a:p>
+          <a:p>
+            <a:pPr algn="l">
+              <a:spcAft>
+                <a:spcPts val="600"/>
+              </a:spcAft>
+            </a:pPr>
+            <a:r>
+              <a:rPr sz="1300" b="0">
+                <a:solidFill>
+                  <a:srgbClr val="1F3A5F"/>
+                </a:solidFill>
+                <a:latin typeface="Calibri"/>
+              </a:rPr>
+              <a:t>Legado: a decidir</a:t>
+            </a:r>
+          </a:p>
+        </p:txBody>
+      </p:sp>
+      <p:sp>
+        <p:nvSpPr>
+          <p:cNvPr id="12" name="TextBox 11"/>
+          <p:cNvSpPr txBox="1"/>
+          <p:nvPr/>
+        </p:nvSpPr>
+        <p:spPr>
+          <a:xfrm>
+            <a:off x="648000" y="4068000"/>
+            <a:ext cx="10800000" cy="1800000"/>
+          </a:xfrm>
+          <a:prstGeom prst="rect">
+            <a:avLst/>
+          </a:prstGeom>
+          <a:noFill/>
+        </p:spPr>
+        <p:txBody>
+          <a:bodyPr wrap="square" anchor="t" lIns="180000" rIns="180000" tIns="180000">
+            <a:spAutoFit/>
+          </a:bodyPr>
+          <a:lstStyle/>
           <a:p>
             <a:pPr algn="l">
               <a:spcAft>
@@ -5646,11 +6563,11 @@
             <a:r>
               <a:rPr sz="1500" b="0">
                 <a:solidFill>
-                  <a:srgbClr val="1F3A5F"/>
-                </a:solidFill>
-                <a:latin typeface="Calibri"/>
-              </a:rPr>
-              <a:t>• Pagamentos dos clientes do financeiro</a:t>
+                  <a:srgbClr val="595959"/>
+                </a:solidFill>
+                <a:latin typeface="Calibri"/>
+              </a:rPr>
+              <a:t>Entregável: organograma atual e proposto, papéis, responsabilidades e indicadores por função.</a:t>
             </a:r>
           </a:p>
           <a:p>
@@ -5662,91 +6579,11 @@
             <a:r>
               <a:rPr sz="1500" b="0">
                 <a:solidFill>
-                  <a:srgbClr val="1F3A5F"/>
-                </a:solidFill>
-                <a:latin typeface="Calibri"/>
-              </a:rPr>
-              <a:t>• Folha e DP</a:t>
-            </a:r>
-          </a:p>
-          <a:p>
-            <a:pPr algn="l">
-              <a:spcAft>
-                <a:spcPts val="600"/>
-              </a:spcAft>
-            </a:pPr>
-            <a:r>
-              <a:rPr sz="1500" b="0">
-                <a:solidFill>
-                  <a:srgbClr val="1F3A5F"/>
-                </a:solidFill>
-                <a:latin typeface="Calibri"/>
-              </a:rPr>
-              <a:t>• Comercial</a:t>
-            </a:r>
-          </a:p>
-          <a:p>
-            <a:pPr algn="l">
-              <a:spcAft>
-                <a:spcPts val="600"/>
-              </a:spcAft>
-            </a:pPr>
-            <a:r>
-              <a:rPr sz="1500" b="0">
-                <a:solidFill>
-                  <a:srgbClr val="1F3A5F"/>
-                </a:solidFill>
-                <a:latin typeface="Calibri"/>
-              </a:rPr>
-              <a:t>• Abertura de empresa</a:t>
-            </a:r>
-          </a:p>
-          <a:p>
-            <a:pPr algn="l">
-              <a:spcAft>
-                <a:spcPts val="600"/>
-              </a:spcAft>
-            </a:pPr>
-            <a:r>
-              <a:rPr sz="1500" b="0">
-                <a:solidFill>
-                  <a:srgbClr val="1F3A5F"/>
-                </a:solidFill>
-                <a:latin typeface="Calibri"/>
-              </a:rPr>
-              <a:t>• Acompanhamento jurídico</a:t>
-            </a:r>
-          </a:p>
-          <a:p>
-            <a:pPr algn="l">
-              <a:spcAft>
-                <a:spcPts val="600"/>
-              </a:spcAft>
-            </a:pPr>
-            <a:r>
-              <a:rPr sz="1500" b="0">
-                <a:solidFill>
-                  <a:srgbClr val="1F3A5F"/>
-                </a:solidFill>
-                <a:latin typeface="Calibri"/>
-              </a:rPr>
-              <a:t/>
-            </a:r>
-          </a:p>
-          <a:p>
-            <a:pPr algn="l">
-              <a:spcAft>
-                <a:spcPts val="600"/>
-              </a:spcAft>
-            </a:pPr>
-            <a:r>
-              <a:rPr sz="1500" b="0">
-                <a:solidFill>
-                  <a:srgbClr val="1F3A5F"/>
-                </a:solidFill>
-                <a:latin typeface="Calibri"/>
-              </a:rPr>
-              <a:t>Escolha final na primeira semana, com você.</a:t>
+                  <a:srgbClr val="595959"/>
+                </a:solidFill>
+                <a:latin typeface="Calibri"/>
+              </a:rPr>
+              <a:t>É a base para delegar revisões, receber o(a) contador(a) e criar a remuneração por pontos.</a:t>
             </a:r>
           </a:p>
         </p:txBody>
@@ -5846,7 +6683,7 @@
                 </a:solidFill>
                 <a:latin typeface="Calibri"/>
               </a:rPr>
-              <a:t>Duas opções de escopo</a:t>
+              <a:t>Processos identificados</a:t>
             </a:r>
           </a:p>
         </p:txBody>
@@ -5885,7 +6722,7 @@
                 </a:solidFill>
                 <a:latin typeface="Calibri"/>
               </a:rPr>
-              <a:t>Você escolhe o tamanho; a Essencial pode virar Completa depois</a:t>
+              <a:t>12 processos; a prioridade inicial é onde há mais risco e mais tempo gasto</a:t>
             </a:r>
           </a:p>
         </p:txBody>
@@ -5937,8 +6774,195 @@
         </p:nvSpPr>
         <p:spPr>
           <a:xfrm>
-            <a:off x="648000" y="1800000"/>
-            <a:ext cx="5220000" cy="3888000"/>
+            <a:off x="648000" y="1728000"/>
+            <a:ext cx="5220000" cy="4140000"/>
+          </a:xfrm>
+          <a:prstGeom prst="roundRect">
+            <a:avLst>
+              <a:gd name="adj" fmla="val 8000"/>
+            </a:avLst>
+          </a:prstGeom>
+          <a:solidFill>
+            <a:srgbClr val="1F3A5F"/>
+          </a:solidFill>
+          <a:ln>
+            <a:noFill/>
+          </a:ln>
+          <a:effectLst/>
+        </p:spPr>
+        <p:style>
+          <a:lnRef idx="1">
+            <a:schemeClr val="accent1"/>
+          </a:lnRef>
+          <a:fillRef idx="3">
+            <a:schemeClr val="accent1"/>
+          </a:fillRef>
+          <a:effectRef idx="2">
+            <a:schemeClr val="accent1"/>
+          </a:effectRef>
+          <a:fontRef idx="minor">
+            <a:schemeClr val="lt1"/>
+          </a:fontRef>
+        </p:style>
+        <p:txBody>
+          <a:bodyPr rtlCol="0" anchor="t" wrap="square" lIns="180000" rIns="180000" tIns="180000"/>
+          <a:lstStyle/>
+          <a:p>
+            <a:pPr algn="l">
+              <a:spcAft>
+                <a:spcPts val="600"/>
+              </a:spcAft>
+            </a:pPr>
+            <a:r>
+              <a:rPr sz="1500" b="1">
+                <a:solidFill>
+                  <a:srgbClr val="FFFFFF"/>
+                </a:solidFill>
+                <a:latin typeface="Calibri"/>
+              </a:rPr>
+              <a:t>Prioridade 1</a:t>
+            </a:r>
+          </a:p>
+          <a:p>
+            <a:pPr algn="l">
+              <a:spcAft>
+                <a:spcPts val="600"/>
+              </a:spcAft>
+            </a:pPr>
+            <a:r>
+              <a:rPr sz="1500" b="0">
+                <a:solidFill>
+                  <a:srgbClr val="FFFFFF"/>
+                </a:solidFill>
+                <a:latin typeface="Calibri"/>
+              </a:rPr>
+              <a:t>• Fiscal mensal (44 clientes, risco de multa)</a:t>
+            </a:r>
+          </a:p>
+          <a:p>
+            <a:pPr algn="l">
+              <a:spcAft>
+                <a:spcPts val="600"/>
+              </a:spcAft>
+            </a:pPr>
+            <a:r>
+              <a:rPr sz="1500" b="0">
+                <a:solidFill>
+                  <a:srgbClr val="FFFFFF"/>
+                </a:solidFill>
+                <a:latin typeface="Calibri"/>
+              </a:rPr>
+              <a:t>• Conciliação e fechamento financeiro</a:t>
+            </a:r>
+          </a:p>
+          <a:p>
+            <a:pPr algn="l">
+              <a:spcAft>
+                <a:spcPts val="600"/>
+              </a:spcAft>
+            </a:pPr>
+            <a:r>
+              <a:rPr sz="1500" b="0">
+                <a:solidFill>
+                  <a:srgbClr val="FFFFFF"/>
+                </a:solidFill>
+                <a:latin typeface="Calibri"/>
+              </a:rPr>
+              <a:t/>
+            </a:r>
+          </a:p>
+          <a:p>
+            <a:pPr algn="l">
+              <a:spcAft>
+                <a:spcPts val="600"/>
+              </a:spcAft>
+            </a:pPr>
+            <a:r>
+              <a:rPr sz="1500" b="0">
+                <a:solidFill>
+                  <a:srgbClr val="FFFFFF"/>
+                </a:solidFill>
+                <a:latin typeface="Calibri"/>
+              </a:rPr>
+              <a:t>Prioridade 2</a:t>
+            </a:r>
+          </a:p>
+          <a:p>
+            <a:pPr algn="l">
+              <a:spcAft>
+                <a:spcPts val="600"/>
+              </a:spcAft>
+            </a:pPr>
+            <a:r>
+              <a:rPr sz="1500" b="0">
+                <a:solidFill>
+                  <a:srgbClr val="FFFFFF"/>
+                </a:solidFill>
+                <a:latin typeface="Calibri"/>
+              </a:rPr>
+              <a:t>• Conferência do contábil terceirizado</a:t>
+            </a:r>
+          </a:p>
+          <a:p>
+            <a:pPr algn="l">
+              <a:spcAft>
+                <a:spcPts val="600"/>
+              </a:spcAft>
+            </a:pPr>
+            <a:r>
+              <a:rPr sz="1500" b="0">
+                <a:solidFill>
+                  <a:srgbClr val="FFFFFF"/>
+                </a:solidFill>
+                <a:latin typeface="Calibri"/>
+              </a:rPr>
+              <a:t>• Implantação de novos clientes</a:t>
+            </a:r>
+          </a:p>
+          <a:p>
+            <a:pPr algn="l">
+              <a:spcAft>
+                <a:spcPts val="600"/>
+              </a:spcAft>
+            </a:pPr>
+            <a:r>
+              <a:rPr sz="1500" b="0">
+                <a:solidFill>
+                  <a:srgbClr val="FFFFFF"/>
+                </a:solidFill>
+                <a:latin typeface="Calibri"/>
+              </a:rPr>
+              <a:t>• Atendimento e triagem</a:t>
+            </a:r>
+          </a:p>
+          <a:p>
+            <a:pPr algn="l">
+              <a:spcAft>
+                <a:spcPts val="600"/>
+              </a:spcAft>
+            </a:pPr>
+            <a:r>
+              <a:rPr sz="1500" b="0">
+                <a:solidFill>
+                  <a:srgbClr val="FFFFFF"/>
+                </a:solidFill>
+                <a:latin typeface="Calibri"/>
+              </a:rPr>
+              <a:t>• Emissão de notas</a:t>
+            </a:r>
+          </a:p>
+        </p:txBody>
+      </p:sp>
+      <p:sp>
+        <p:nvSpPr>
+          <p:cNvPr id="7" name="Rounded Rectangle 6"/>
+          <p:cNvSpPr/>
+          <p:nvPr/>
+        </p:nvSpPr>
+        <p:spPr>
+          <a:xfrm>
+            <a:off x="6300000" y="1728000"/>
+            <a:ext cx="5220000" cy="4140000"/>
           </a:xfrm>
           <a:prstGeom prst="roundRect">
             <a:avLst>
@@ -5983,7 +7007,7 @@
                 </a:solidFill>
                 <a:latin typeface="Calibri"/>
               </a:rPr>
-              <a:t>Essencial · 19/10 a ~22/11</a:t>
+              <a:t>Prioridade 3</a:t>
             </a:r>
           </a:p>
           <a:p>
@@ -5999,7 +7023,7 @@
                 </a:solidFill>
                 <a:latin typeface="Calibri"/>
               </a:rPr>
-              <a:t>• Entrevistas com 4 pessoas</a:t>
+              <a:t>• Pagamentos dos clientes do financeiro</a:t>
             </a:r>
           </a:p>
           <a:p>
@@ -6015,7 +7039,7 @@
                 </a:solidFill>
                 <a:latin typeface="Calibri"/>
               </a:rPr>
-              <a:t>• Até 5 processos mapeados</a:t>
+              <a:t>• Folha e DP</a:t>
             </a:r>
           </a:p>
           <a:p>
@@ -6031,7 +7055,7 @@
                 </a:solidFill>
                 <a:latin typeface="Calibri"/>
               </a:rPr>
-              <a:t>• Gargalos e dependências</a:t>
+              <a:t>• Comercial</a:t>
             </a:r>
           </a:p>
           <a:p>
@@ -6047,7 +7071,7 @@
                 </a:solidFill>
                 <a:latin typeface="Calibri"/>
               </a:rPr>
-              <a:t>• Organograma e matriz de responsabilidades</a:t>
+              <a:t>• Abertura de empresa</a:t>
             </a:r>
           </a:p>
           <a:p>
@@ -6063,66 +7087,7 @@
                 </a:solidFill>
                 <a:latin typeface="Calibri"/>
               </a:rPr>
-              <a:t>• Lista priorizada de automações</a:t>
-            </a:r>
-          </a:p>
-        </p:txBody>
-      </p:sp>
-      <p:sp>
-        <p:nvSpPr>
-          <p:cNvPr id="7" name="Rounded Rectangle 6"/>
-          <p:cNvSpPr/>
-          <p:nvPr/>
-        </p:nvSpPr>
-        <p:spPr>
-          <a:xfrm>
-            <a:off x="6300000" y="1800000"/>
-            <a:ext cx="5220000" cy="3888000"/>
-          </a:xfrm>
-          <a:prstGeom prst="roundRect">
-            <a:avLst>
-              <a:gd name="adj" fmla="val 8000"/>
-            </a:avLst>
-          </a:prstGeom>
-          <a:solidFill>
-            <a:srgbClr val="1F3A5F"/>
-          </a:solidFill>
-          <a:ln>
-            <a:noFill/>
-          </a:ln>
-          <a:effectLst/>
-        </p:spPr>
-        <p:style>
-          <a:lnRef idx="1">
-            <a:schemeClr val="accent1"/>
-          </a:lnRef>
-          <a:fillRef idx="3">
-            <a:schemeClr val="accent1"/>
-          </a:fillRef>
-          <a:effectRef idx="2">
-            <a:schemeClr val="accent1"/>
-          </a:effectRef>
-          <a:fontRef idx="minor">
-            <a:schemeClr val="lt1"/>
-          </a:fontRef>
-        </p:style>
-        <p:txBody>
-          <a:bodyPr rtlCol="0" anchor="t" wrap="square" lIns="180000" rIns="180000" tIns="180000"/>
-          <a:lstStyle/>
-          <a:p>
-            <a:pPr algn="l">
-              <a:spcAft>
-                <a:spcPts val="600"/>
-              </a:spcAft>
-            </a:pPr>
-            <a:r>
-              <a:rPr sz="1500" b="1">
-                <a:solidFill>
-                  <a:srgbClr val="FFFFFF"/>
-                </a:solidFill>
-                <a:latin typeface="Calibri"/>
-              </a:rPr>
-              <a:t>Completa (recomendada) · 19/10 a 18/12</a:t>
+              <a:t>• Acompanhamento jurídico</a:t>
             </a:r>
           </a:p>
           <a:p>
@@ -6134,11 +7099,11 @@
             <a:r>
               <a:rPr sz="1500" b="0">
                 <a:solidFill>
-                  <a:srgbClr val="FFFFFF"/>
-                </a:solidFill>
-                <a:latin typeface="Calibri"/>
-              </a:rPr>
-              <a:t>• Entrevistas com até 5 pessoas</a:t>
+                  <a:srgbClr val="1F3A5F"/>
+                </a:solidFill>
+                <a:latin typeface="Calibri"/>
+              </a:rPr>
+              <a:t>• Reinf, IRPF e parcelamentos</a:t>
             </a:r>
           </a:p>
           <a:p>
@@ -6150,11 +7115,11 @@
             <a:r>
               <a:rPr sz="1500" b="0">
                 <a:solidFill>
-                  <a:srgbClr val="FFFFFF"/>
-                </a:solidFill>
-                <a:latin typeface="Calibri"/>
-              </a:rPr>
-              <a:t>• Até 8 processos mapeados</a:t>
+                  <a:srgbClr val="1F3A5F"/>
+                </a:solidFill>
+                <a:latin typeface="Calibri"/>
+              </a:rPr>
+              <a:t/>
             </a:r>
           </a:p>
           <a:p>
@@ -6166,59 +7131,11 @@
             <a:r>
               <a:rPr sz="1500" b="0">
                 <a:solidFill>
-                  <a:srgbClr val="FFFFFF"/>
-                </a:solidFill>
-                <a:latin typeface="Calibri"/>
-              </a:rPr>
-              <a:t>• Gargalos e dependências</a:t>
-            </a:r>
-          </a:p>
-          <a:p>
-            <a:pPr algn="l">
-              <a:spcAft>
-                <a:spcPts val="600"/>
-              </a:spcAft>
-            </a:pPr>
-            <a:r>
-              <a:rPr sz="1500" b="0">
-                <a:solidFill>
-                  <a:srgbClr val="FFFFFF"/>
-                </a:solidFill>
-                <a:latin typeface="Calibri"/>
-              </a:rPr>
-              <a:t>• Organograma, papéis e indicadores</a:t>
-            </a:r>
-          </a:p>
-          <a:p>
-            <a:pPr algn="l">
-              <a:spcAft>
-                <a:spcPts val="600"/>
-              </a:spcAft>
-            </a:pPr>
-            <a:r>
-              <a:rPr sz="1500" b="0">
-                <a:solidFill>
-                  <a:srgbClr val="FFFFFF"/>
-                </a:solidFill>
-                <a:latin typeface="Calibri"/>
-              </a:rPr>
-              <a:t>• 5 fluxos otimizados</a:t>
-            </a:r>
-          </a:p>
-          <a:p>
-            <a:pPr algn="l">
-              <a:spcAft>
-                <a:spcPts val="600"/>
-              </a:spcAft>
-            </a:pPr>
-            <a:r>
-              <a:rPr sz="1500" b="0">
-                <a:solidFill>
-                  <a:srgbClr val="FFFFFF"/>
-                </a:solidFill>
-                <a:latin typeface="Calibri"/>
-              </a:rPr>
-              <a:t>• Plano de automação com esforço e custo</a:t>
+                  <a:srgbClr val="1F3A5F"/>
+                </a:solidFill>
+                <a:latin typeface="Calibri"/>
+              </a:rPr>
+              <a:t>Escolha final na primeira semana, com você.</a:t>
             </a:r>
           </a:p>
         </p:txBody>
@@ -6318,7 +7235,7 @@
                 </a:solidFill>
                 <a:latin typeface="Calibri"/>
               </a:rPr>
-              <a:t>Cronograma</a:t>
+              <a:t>Duas opções de escopo</a:t>
             </a:r>
           </a:p>
         </p:txBody>
@@ -6357,7 +7274,7 @@
                 </a:solidFill>
                 <a:latin typeface="Calibri"/>
               </a:rPr>
-              <a:t>Cerca de 7 horas suas no total, sem reuniões na semana dos fechamentos nem na semana da prova</a:t>
+              <a:t>Você escolhe o tamanho; a Essencial pode virar Completa depois</a:t>
             </a:r>
           </a:p>
         </p:txBody>
@@ -6409,8 +7326,8 @@
         </p:nvSpPr>
         <p:spPr>
           <a:xfrm>
-            <a:off x="648000" y="2160000"/>
-            <a:ext cx="1710000" cy="1980000"/>
+            <a:off x="648000" y="1800000"/>
+            <a:ext cx="5220000" cy="3888000"/>
           </a:xfrm>
           <a:prstGeom prst="roundRect">
             <a:avLst>
@@ -6455,7 +7372,7 @@
                 </a:solidFill>
                 <a:latin typeface="Calibri"/>
               </a:rPr>
-              <a:t>19/10</a:t>
+              <a:t>Essencial · 19/10 a ~22/11</a:t>
             </a:r>
           </a:p>
           <a:p>
@@ -6471,7 +7388,71 @@
                 </a:solidFill>
                 <a:latin typeface="Calibri"/>
               </a:rPr>
-              <a:t>Kick-off e entrevistas</a:t>
+              <a:t>• Entrevistas com 4 pessoas</a:t>
+            </a:r>
+          </a:p>
+          <a:p>
+            <a:pPr algn="l">
+              <a:spcAft>
+                <a:spcPts val="600"/>
+              </a:spcAft>
+            </a:pPr>
+            <a:r>
+              <a:rPr sz="1500" b="0">
+                <a:solidFill>
+                  <a:srgbClr val="1F3A5F"/>
+                </a:solidFill>
+                <a:latin typeface="Calibri"/>
+              </a:rPr>
+              <a:t>• Até 5 processos mapeados</a:t>
+            </a:r>
+          </a:p>
+          <a:p>
+            <a:pPr algn="l">
+              <a:spcAft>
+                <a:spcPts val="600"/>
+              </a:spcAft>
+            </a:pPr>
+            <a:r>
+              <a:rPr sz="1500" b="0">
+                <a:solidFill>
+                  <a:srgbClr val="1F3A5F"/>
+                </a:solidFill>
+                <a:latin typeface="Calibri"/>
+              </a:rPr>
+              <a:t>• Gargalos e dependências</a:t>
+            </a:r>
+          </a:p>
+          <a:p>
+            <a:pPr algn="l">
+              <a:spcAft>
+                <a:spcPts val="600"/>
+              </a:spcAft>
+            </a:pPr>
+            <a:r>
+              <a:rPr sz="1500" b="0">
+                <a:solidFill>
+                  <a:srgbClr val="1F3A5F"/>
+                </a:solidFill>
+                <a:latin typeface="Calibri"/>
+              </a:rPr>
+              <a:t>• Organograma e matriz de responsabilidades</a:t>
+            </a:r>
+          </a:p>
+          <a:p>
+            <a:pPr algn="l">
+              <a:spcAft>
+                <a:spcPts val="600"/>
+              </a:spcAft>
+            </a:pPr>
+            <a:r>
+              <a:rPr sz="1500" b="0">
+                <a:solidFill>
+                  <a:srgbClr val="1F3A5F"/>
+                </a:solidFill>
+                <a:latin typeface="Calibri"/>
+              </a:rPr>
+              <a:t>• Lista priorizada de automações</a:t>
             </a:r>
           </a:p>
         </p:txBody>
@@ -6484,83 +7465,8 @@
         </p:nvSpPr>
         <p:spPr>
           <a:xfrm>
-            <a:off x="2466000" y="2160000"/>
-            <a:ext cx="1710000" cy="1980000"/>
-          </a:xfrm>
-          <a:prstGeom prst="roundRect">
-            <a:avLst>
-              <a:gd name="adj" fmla="val 8000"/>
-            </a:avLst>
-          </a:prstGeom>
-          <a:solidFill>
-            <a:srgbClr val="E8EEF5"/>
-          </a:solidFill>
-          <a:ln>
-            <a:noFill/>
-          </a:ln>
-          <a:effectLst/>
-        </p:spPr>
-        <p:style>
-          <a:lnRef idx="1">
-            <a:schemeClr val="accent1"/>
-          </a:lnRef>
-          <a:fillRef idx="3">
-            <a:schemeClr val="accent1"/>
-          </a:fillRef>
-          <a:effectRef idx="2">
-            <a:schemeClr val="accent1"/>
-          </a:effectRef>
-          <a:fontRef idx="minor">
-            <a:schemeClr val="lt1"/>
-          </a:fontRef>
-        </p:style>
-        <p:txBody>
-          <a:bodyPr rtlCol="0" anchor="t" wrap="square" lIns="180000" rIns="180000" tIns="180000"/>
-          <a:lstStyle/>
-          <a:p>
-            <a:pPr algn="l">
-              <a:spcAft>
-                <a:spcPts val="600"/>
-              </a:spcAft>
-            </a:pPr>
-            <a:r>
-              <a:rPr sz="1500" b="1">
-                <a:solidFill>
-                  <a:srgbClr val="1F3A5F"/>
-                </a:solidFill>
-                <a:latin typeface="Calibri"/>
-              </a:rPr>
-              <a:t>26/10</a:t>
-            </a:r>
-          </a:p>
-          <a:p>
-            <a:pPr algn="l">
-              <a:spcAft>
-                <a:spcPts val="600"/>
-              </a:spcAft>
-            </a:pPr>
-            <a:r>
-              <a:rPr sz="1500" b="0">
-                <a:solidFill>
-                  <a:srgbClr val="1F3A5F"/>
-                </a:solidFill>
-                <a:latin typeface="Calibri"/>
-              </a:rPr>
-              <a:t>Entrevistas com Tamara e Vitória</a:t>
-            </a:r>
-          </a:p>
-        </p:txBody>
-      </p:sp>
-      <p:sp>
-        <p:nvSpPr>
-          <p:cNvPr id="8" name="Rounded Rectangle 7"/>
-          <p:cNvSpPr/>
-          <p:nvPr/>
-        </p:nvSpPr>
-        <p:spPr>
-          <a:xfrm>
-            <a:off x="4284000" y="2160000"/>
-            <a:ext cx="1710000" cy="1980000"/>
+            <a:off x="6300000" y="1800000"/>
+            <a:ext cx="5220000" cy="3888000"/>
           </a:xfrm>
           <a:prstGeom prst="roundRect">
             <a:avLst>
@@ -6605,7 +7511,7 @@
                 </a:solidFill>
                 <a:latin typeface="Calibri"/>
               </a:rPr>
-              <a:t>15/11</a:t>
+              <a:t>Completa (recomendada) · 19/10 a 18/12</a:t>
             </a:r>
           </a:p>
           <a:p>
@@ -6621,66 +7527,7 @@
                 </a:solidFill>
                 <a:latin typeface="Calibri"/>
               </a:rPr>
-              <a:t>Entrega do mapeamento</a:t>
-            </a:r>
-          </a:p>
-        </p:txBody>
-      </p:sp>
-      <p:sp>
-        <p:nvSpPr>
-          <p:cNvPr id="9" name="Rounded Rectangle 8"/>
-          <p:cNvSpPr/>
-          <p:nvPr/>
-        </p:nvSpPr>
-        <p:spPr>
-          <a:xfrm>
-            <a:off x="6102000" y="2160000"/>
-            <a:ext cx="1710000" cy="1980000"/>
-          </a:xfrm>
-          <a:prstGeom prst="roundRect">
-            <a:avLst>
-              <a:gd name="adj" fmla="val 8000"/>
-            </a:avLst>
-          </a:prstGeom>
-          <a:solidFill>
-            <a:srgbClr val="E8EEF5"/>
-          </a:solidFill>
-          <a:ln>
-            <a:noFill/>
-          </a:ln>
-          <a:effectLst/>
-        </p:spPr>
-        <p:style>
-          <a:lnRef idx="1">
-            <a:schemeClr val="accent1"/>
-          </a:lnRef>
-          <a:fillRef idx="3">
-            <a:schemeClr val="accent1"/>
-          </a:fillRef>
-          <a:effectRef idx="2">
-            <a:schemeClr val="accent1"/>
-          </a:effectRef>
-          <a:fontRef idx="minor">
-            <a:schemeClr val="lt1"/>
-          </a:fontRef>
-        </p:style>
-        <p:txBody>
-          <a:bodyPr rtlCol="0" anchor="t" wrap="square" lIns="180000" rIns="180000" tIns="180000"/>
-          <a:lstStyle/>
-          <a:p>
-            <a:pPr algn="l">
-              <a:spcAft>
-                <a:spcPts val="600"/>
-              </a:spcAft>
-            </a:pPr>
-            <a:r>
-              <a:rPr sz="1500" b="1">
-                <a:solidFill>
-                  <a:srgbClr val="1F3A5F"/>
-                </a:solidFill>
-                <a:latin typeface="Calibri"/>
-              </a:rPr>
-              <a:t>29/11</a:t>
+              <a:t>• 3 controles de contenção até 15/11</a:t>
             </a:r>
           </a:p>
           <a:p>
@@ -6692,70 +7539,11 @@
             <a:r>
               <a:rPr sz="1500" b="0">
                 <a:solidFill>
-                  <a:srgbClr val="1F3A5F"/>
-                </a:solidFill>
-                <a:latin typeface="Calibri"/>
-              </a:rPr>
-              <a:t>Estrutura organizacional</a:t>
-            </a:r>
-          </a:p>
-        </p:txBody>
-      </p:sp>
-      <p:sp>
-        <p:nvSpPr>
-          <p:cNvPr id="10" name="Rounded Rectangle 9"/>
-          <p:cNvSpPr/>
-          <p:nvPr/>
-        </p:nvSpPr>
-        <p:spPr>
-          <a:xfrm>
-            <a:off x="7920000" y="2160000"/>
-            <a:ext cx="1710000" cy="1980000"/>
-          </a:xfrm>
-          <a:prstGeom prst="roundRect">
-            <a:avLst>
-              <a:gd name="adj" fmla="val 8000"/>
-            </a:avLst>
-          </a:prstGeom>
-          <a:solidFill>
-            <a:srgbClr val="FFF4D6"/>
-          </a:solidFill>
-          <a:ln>
-            <a:noFill/>
-          </a:ln>
-          <a:effectLst/>
-        </p:spPr>
-        <p:style>
-          <a:lnRef idx="1">
-            <a:schemeClr val="accent1"/>
-          </a:lnRef>
-          <a:fillRef idx="3">
-            <a:schemeClr val="accent1"/>
-          </a:fillRef>
-          <a:effectRef idx="2">
-            <a:schemeClr val="accent1"/>
-          </a:effectRef>
-          <a:fontRef idx="minor">
-            <a:schemeClr val="lt1"/>
-          </a:fontRef>
-        </p:style>
-        <p:txBody>
-          <a:bodyPr rtlCol="0" anchor="t" wrap="square" lIns="180000" rIns="180000" tIns="180000"/>
-          <a:lstStyle/>
-          <a:p>
-            <a:pPr algn="l">
-              <a:spcAft>
-                <a:spcPts val="600"/>
-              </a:spcAft>
-            </a:pPr>
-            <a:r>
-              <a:rPr sz="1500" b="1">
-                <a:solidFill>
-                  <a:srgbClr val="1F3A5F"/>
-                </a:solidFill>
-                <a:latin typeface="Calibri"/>
-              </a:rPr>
-              <a:t>13/12</a:t>
+                  <a:srgbClr val="FFFFFF"/>
+                </a:solidFill>
+                <a:latin typeface="Calibri"/>
+              </a:rPr>
+              <a:t>• Entrevistas com até 5 pessoas</a:t>
             </a:r>
           </a:p>
           <a:p>
@@ -6767,70 +7555,11 @@
             <a:r>
               <a:rPr sz="1500" b="0">
                 <a:solidFill>
-                  <a:srgbClr val="1F3A5F"/>
-                </a:solidFill>
-                <a:latin typeface="Calibri"/>
-              </a:rPr>
-              <a:t>Sua prova (sem reuniões)</a:t>
-            </a:r>
-          </a:p>
-        </p:txBody>
-      </p:sp>
-      <p:sp>
-        <p:nvSpPr>
-          <p:cNvPr id="11" name="Rounded Rectangle 10"/>
-          <p:cNvSpPr/>
-          <p:nvPr/>
-        </p:nvSpPr>
-        <p:spPr>
-          <a:xfrm>
-            <a:off x="9738000" y="2160000"/>
-            <a:ext cx="1710000" cy="1980000"/>
-          </a:xfrm>
-          <a:prstGeom prst="roundRect">
-            <a:avLst>
-              <a:gd name="adj" fmla="val 8000"/>
-            </a:avLst>
-          </a:prstGeom>
-          <a:solidFill>
-            <a:srgbClr val="1F3A5F"/>
-          </a:solidFill>
-          <a:ln>
-            <a:noFill/>
-          </a:ln>
-          <a:effectLst/>
-        </p:spPr>
-        <p:style>
-          <a:lnRef idx="1">
-            <a:schemeClr val="accent1"/>
-          </a:lnRef>
-          <a:fillRef idx="3">
-            <a:schemeClr val="accent1"/>
-          </a:fillRef>
-          <a:effectRef idx="2">
-            <a:schemeClr val="accent1"/>
-          </a:effectRef>
-          <a:fontRef idx="minor">
-            <a:schemeClr val="lt1"/>
-          </a:fontRef>
-        </p:style>
-        <p:txBody>
-          <a:bodyPr rtlCol="0" anchor="t" wrap="square" lIns="180000" rIns="180000" tIns="180000"/>
-          <a:lstStyle/>
-          <a:p>
-            <a:pPr algn="l">
-              <a:spcAft>
-                <a:spcPts val="600"/>
-              </a:spcAft>
-            </a:pPr>
-            <a:r>
-              <a:rPr sz="1500" b="1">
-                <a:solidFill>
                   <a:srgbClr val="FFFFFF"/>
                 </a:solidFill>
                 <a:latin typeface="Calibri"/>
               </a:rPr>
-              <a:t>18/12</a:t>
+              <a:t>• Até 8 processos mapeados</a:t>
             </a:r>
           </a:p>
           <a:p>
@@ -6846,7 +7575,55 @@
                 </a:solidFill>
                 <a:latin typeface="Calibri"/>
               </a:rPr>
-              <a:t>Apresentação final</a:t>
+              <a:t>• Gargalos e dependências</a:t>
+            </a:r>
+          </a:p>
+          <a:p>
+            <a:pPr algn="l">
+              <a:spcAft>
+                <a:spcPts val="600"/>
+              </a:spcAft>
+            </a:pPr>
+            <a:r>
+              <a:rPr sz="1500" b="0">
+                <a:solidFill>
+                  <a:srgbClr val="FFFFFF"/>
+                </a:solidFill>
+                <a:latin typeface="Calibri"/>
+              </a:rPr>
+              <a:t>• Organograma, papéis e indicadores</a:t>
+            </a:r>
+          </a:p>
+          <a:p>
+            <a:pPr algn="l">
+              <a:spcAft>
+                <a:spcPts val="600"/>
+              </a:spcAft>
+            </a:pPr>
+            <a:r>
+              <a:rPr sz="1500" b="0">
+                <a:solidFill>
+                  <a:srgbClr val="FFFFFF"/>
+                </a:solidFill>
+                <a:latin typeface="Calibri"/>
+              </a:rPr>
+              <a:t>• 5 fluxos otimizados</a:t>
+            </a:r>
+          </a:p>
+          <a:p>
+            <a:pPr algn="l">
+              <a:spcAft>
+                <a:spcPts val="600"/>
+              </a:spcAft>
+            </a:pPr>
+            <a:r>
+              <a:rPr sz="1500" b="0">
+                <a:solidFill>
+                  <a:srgbClr val="FFFFFF"/>
+                </a:solidFill>
+                <a:latin typeface="Calibri"/>
+              </a:rPr>
+              <a:t>• Plano de automação com esforço e custo</a:t>
             </a:r>
           </a:p>
         </p:txBody>
@@ -6946,7 +7723,7 @@
                 </a:solidFill>
                 <a:latin typeface="Calibri"/>
               </a:rPr>
-              <a:t>Investimento</a:t>
+              <a:t>Cronograma</a:t>
             </a:r>
           </a:p>
         </p:txBody>
@@ -6985,7 +7762,7 @@
                 </a:solidFill>
                 <a:latin typeface="Calibri"/>
               </a:rPr>
-              <a:t>Preço fechado. A implementação é orçada depois, por pacotes.</a:t>
+              <a:t>Cerca de 7 horas suas no total, sem reuniões na semana dos fechamentos nem na semana da prova</a:t>
             </a:r>
           </a:p>
         </p:txBody>
@@ -7037,8 +7814,8 @@
         </p:nvSpPr>
         <p:spPr>
           <a:xfrm>
-            <a:off x="648000" y="1908000"/>
-            <a:ext cx="5256000" cy="2340000"/>
+            <a:off x="648000" y="2160000"/>
+            <a:ext cx="1710000" cy="1980000"/>
           </a:xfrm>
           <a:prstGeom prst="roundRect">
             <a:avLst>
@@ -7077,45 +7854,29 @@
               </a:spcAft>
             </a:pPr>
             <a:r>
-              <a:rPr sz="2000" b="1">
-                <a:solidFill>
-                  <a:srgbClr val="1F3A5F"/>
-                </a:solidFill>
-                <a:latin typeface="Calibri"/>
-              </a:rPr>
-              <a:t>Essencial</a:t>
-            </a:r>
-          </a:p>
-          <a:p>
-            <a:pPr algn="l">
-              <a:spcAft>
-                <a:spcPts val="600"/>
-              </a:spcAft>
-            </a:pPr>
-            <a:r>
-              <a:rPr sz="2000" b="1">
-                <a:solidFill>
-                  <a:srgbClr val="1F3A5F"/>
-                </a:solidFill>
-                <a:latin typeface="Calibri"/>
-              </a:rPr>
-              <a:t>R$ 7.800</a:t>
-            </a:r>
-          </a:p>
-          <a:p>
-            <a:pPr algn="l">
-              <a:spcAft>
-                <a:spcPts val="600"/>
-              </a:spcAft>
-            </a:pPr>
-            <a:r>
-              <a:rPr sz="2000" b="1">
-                <a:solidFill>
-                  <a:srgbClr val="1F3A5F"/>
-                </a:solidFill>
-                <a:latin typeface="Calibri"/>
-              </a:rPr>
-              <a:t>50% no aceite, 50% na entrega</a:t>
+              <a:rPr sz="1500" b="1">
+                <a:solidFill>
+                  <a:srgbClr val="1F3A5F"/>
+                </a:solidFill>
+                <a:latin typeface="Calibri"/>
+              </a:rPr>
+              <a:t>19/10</a:t>
+            </a:r>
+          </a:p>
+          <a:p>
+            <a:pPr algn="l">
+              <a:spcAft>
+                <a:spcPts val="600"/>
+              </a:spcAft>
+            </a:pPr>
+            <a:r>
+              <a:rPr sz="1500" b="0">
+                <a:solidFill>
+                  <a:srgbClr val="1F3A5F"/>
+                </a:solidFill>
+                <a:latin typeface="Calibri"/>
+              </a:rPr>
+              <a:t>Kick-off e entrevistas</a:t>
             </a:r>
           </a:p>
         </p:txBody>
@@ -7128,8 +7889,83 @@
         </p:nvSpPr>
         <p:spPr>
           <a:xfrm>
-            <a:off x="6263999" y="1908000"/>
-            <a:ext cx="5256000" cy="2340000"/>
+            <a:off x="2466000" y="2160000"/>
+            <a:ext cx="1710000" cy="1980000"/>
+          </a:xfrm>
+          <a:prstGeom prst="roundRect">
+            <a:avLst>
+              <a:gd name="adj" fmla="val 8000"/>
+            </a:avLst>
+          </a:prstGeom>
+          <a:solidFill>
+            <a:srgbClr val="E8EEF5"/>
+          </a:solidFill>
+          <a:ln>
+            <a:noFill/>
+          </a:ln>
+          <a:effectLst/>
+        </p:spPr>
+        <p:style>
+          <a:lnRef idx="1">
+            <a:schemeClr val="accent1"/>
+          </a:lnRef>
+          <a:fillRef idx="3">
+            <a:schemeClr val="accent1"/>
+          </a:fillRef>
+          <a:effectRef idx="2">
+            <a:schemeClr val="accent1"/>
+          </a:effectRef>
+          <a:fontRef idx="minor">
+            <a:schemeClr val="lt1"/>
+          </a:fontRef>
+        </p:style>
+        <p:txBody>
+          <a:bodyPr rtlCol="0" anchor="t" wrap="square" lIns="180000" rIns="180000" tIns="180000"/>
+          <a:lstStyle/>
+          <a:p>
+            <a:pPr algn="l">
+              <a:spcAft>
+                <a:spcPts val="600"/>
+              </a:spcAft>
+            </a:pPr>
+            <a:r>
+              <a:rPr sz="1500" b="1">
+                <a:solidFill>
+                  <a:srgbClr val="1F3A5F"/>
+                </a:solidFill>
+                <a:latin typeface="Calibri"/>
+              </a:rPr>
+              <a:t>26/10</a:t>
+            </a:r>
+          </a:p>
+          <a:p>
+            <a:pPr algn="l">
+              <a:spcAft>
+                <a:spcPts val="600"/>
+              </a:spcAft>
+            </a:pPr>
+            <a:r>
+              <a:rPr sz="1500" b="0">
+                <a:solidFill>
+                  <a:srgbClr val="1F3A5F"/>
+                </a:solidFill>
+                <a:latin typeface="Calibri"/>
+              </a:rPr>
+              <a:t>Entrevistas com Tamara e Vitória</a:t>
+            </a:r>
+          </a:p>
+        </p:txBody>
+      </p:sp>
+      <p:sp>
+        <p:nvSpPr>
+          <p:cNvPr id="8" name="Rounded Rectangle 7"/>
+          <p:cNvSpPr/>
+          <p:nvPr/>
+        </p:nvSpPr>
+        <p:spPr>
+          <a:xfrm>
+            <a:off x="4284000" y="2160000"/>
+            <a:ext cx="1710000" cy="1980000"/>
           </a:xfrm>
           <a:prstGeom prst="roundRect">
             <a:avLst>
@@ -7168,100 +8004,254 @@
               </a:spcAft>
             </a:pPr>
             <a:r>
-              <a:rPr sz="2000" b="1">
+              <a:rPr sz="1500" b="1">
                 <a:solidFill>
                   <a:srgbClr val="FFFFFF"/>
                 </a:solidFill>
                 <a:latin typeface="Calibri"/>
               </a:rPr>
-              <a:t>Completa (recomendada)</a:t>
-            </a:r>
-          </a:p>
-          <a:p>
-            <a:pPr algn="l">
-              <a:spcAft>
-                <a:spcPts val="600"/>
-              </a:spcAft>
-            </a:pPr>
-            <a:r>
-              <a:rPr sz="2000" b="1">
+              <a:t>15/11</a:t>
+            </a:r>
+          </a:p>
+          <a:p>
+            <a:pPr algn="l">
+              <a:spcAft>
+                <a:spcPts val="600"/>
+              </a:spcAft>
+            </a:pPr>
+            <a:r>
+              <a:rPr sz="1500" b="0">
                 <a:solidFill>
                   <a:srgbClr val="FFFFFF"/>
                 </a:solidFill>
                 <a:latin typeface="Calibri"/>
               </a:rPr>
-              <a:t>R$ 14.800</a:t>
-            </a:r>
-          </a:p>
-          <a:p>
-            <a:pPr algn="l">
-              <a:spcAft>
-                <a:spcPts val="600"/>
-              </a:spcAft>
-            </a:pPr>
-            <a:r>
-              <a:rPr sz="2000" b="1">
+              <a:t>Entrega do mapeamento</a:t>
+            </a:r>
+          </a:p>
+        </p:txBody>
+      </p:sp>
+      <p:sp>
+        <p:nvSpPr>
+          <p:cNvPr id="9" name="Rounded Rectangle 8"/>
+          <p:cNvSpPr/>
+          <p:nvPr/>
+        </p:nvSpPr>
+        <p:spPr>
+          <a:xfrm>
+            <a:off x="6102000" y="2160000"/>
+            <a:ext cx="1710000" cy="1980000"/>
+          </a:xfrm>
+          <a:prstGeom prst="roundRect">
+            <a:avLst>
+              <a:gd name="adj" fmla="val 8000"/>
+            </a:avLst>
+          </a:prstGeom>
+          <a:solidFill>
+            <a:srgbClr val="E8EEF5"/>
+          </a:solidFill>
+          <a:ln>
+            <a:noFill/>
+          </a:ln>
+          <a:effectLst/>
+        </p:spPr>
+        <p:style>
+          <a:lnRef idx="1">
+            <a:schemeClr val="accent1"/>
+          </a:lnRef>
+          <a:fillRef idx="3">
+            <a:schemeClr val="accent1"/>
+          </a:fillRef>
+          <a:effectRef idx="2">
+            <a:schemeClr val="accent1"/>
+          </a:effectRef>
+          <a:fontRef idx="minor">
+            <a:schemeClr val="lt1"/>
+          </a:fontRef>
+        </p:style>
+        <p:txBody>
+          <a:bodyPr rtlCol="0" anchor="t" wrap="square" lIns="180000" rIns="180000" tIns="180000"/>
+          <a:lstStyle/>
+          <a:p>
+            <a:pPr algn="l">
+              <a:spcAft>
+                <a:spcPts val="600"/>
+              </a:spcAft>
+            </a:pPr>
+            <a:r>
+              <a:rPr sz="1500" b="1">
+                <a:solidFill>
+                  <a:srgbClr val="1F3A5F"/>
+                </a:solidFill>
+                <a:latin typeface="Calibri"/>
+              </a:rPr>
+              <a:t>29/11</a:t>
+            </a:r>
+          </a:p>
+          <a:p>
+            <a:pPr algn="l">
+              <a:spcAft>
+                <a:spcPts val="600"/>
+              </a:spcAft>
+            </a:pPr>
+            <a:r>
+              <a:rPr sz="1500" b="0">
+                <a:solidFill>
+                  <a:srgbClr val="1F3A5F"/>
+                </a:solidFill>
+                <a:latin typeface="Calibri"/>
+              </a:rPr>
+              <a:t>Estrutura organizacional</a:t>
+            </a:r>
+          </a:p>
+        </p:txBody>
+      </p:sp>
+      <p:sp>
+        <p:nvSpPr>
+          <p:cNvPr id="10" name="Rounded Rectangle 9"/>
+          <p:cNvSpPr/>
+          <p:nvPr/>
+        </p:nvSpPr>
+        <p:spPr>
+          <a:xfrm>
+            <a:off x="7920000" y="2160000"/>
+            <a:ext cx="1710000" cy="1980000"/>
+          </a:xfrm>
+          <a:prstGeom prst="roundRect">
+            <a:avLst>
+              <a:gd name="adj" fmla="val 8000"/>
+            </a:avLst>
+          </a:prstGeom>
+          <a:solidFill>
+            <a:srgbClr val="FFF4D6"/>
+          </a:solidFill>
+          <a:ln>
+            <a:noFill/>
+          </a:ln>
+          <a:effectLst/>
+        </p:spPr>
+        <p:style>
+          <a:lnRef idx="1">
+            <a:schemeClr val="accent1"/>
+          </a:lnRef>
+          <a:fillRef idx="3">
+            <a:schemeClr val="accent1"/>
+          </a:fillRef>
+          <a:effectRef idx="2">
+            <a:schemeClr val="accent1"/>
+          </a:effectRef>
+          <a:fontRef idx="minor">
+            <a:schemeClr val="lt1"/>
+          </a:fontRef>
+        </p:style>
+        <p:txBody>
+          <a:bodyPr rtlCol="0" anchor="t" wrap="square" lIns="180000" rIns="180000" tIns="180000"/>
+          <a:lstStyle/>
+          <a:p>
+            <a:pPr algn="l">
+              <a:spcAft>
+                <a:spcPts val="600"/>
+              </a:spcAft>
+            </a:pPr>
+            <a:r>
+              <a:rPr sz="1500" b="1">
+                <a:solidFill>
+                  <a:srgbClr val="1F3A5F"/>
+                </a:solidFill>
+                <a:latin typeface="Calibri"/>
+              </a:rPr>
+              <a:t>13/12</a:t>
+            </a:r>
+          </a:p>
+          <a:p>
+            <a:pPr algn="l">
+              <a:spcAft>
+                <a:spcPts val="600"/>
+              </a:spcAft>
+            </a:pPr>
+            <a:r>
+              <a:rPr sz="1500" b="0">
+                <a:solidFill>
+                  <a:srgbClr val="1F3A5F"/>
+                </a:solidFill>
+                <a:latin typeface="Calibri"/>
+              </a:rPr>
+              <a:t>Sua prova (sem reuniões)</a:t>
+            </a:r>
+          </a:p>
+        </p:txBody>
+      </p:sp>
+      <p:sp>
+        <p:nvSpPr>
+          <p:cNvPr id="11" name="Rounded Rectangle 10"/>
+          <p:cNvSpPr/>
+          <p:nvPr/>
+        </p:nvSpPr>
+        <p:spPr>
+          <a:xfrm>
+            <a:off x="9738000" y="2160000"/>
+            <a:ext cx="1710000" cy="1980000"/>
+          </a:xfrm>
+          <a:prstGeom prst="roundRect">
+            <a:avLst>
+              <a:gd name="adj" fmla="val 8000"/>
+            </a:avLst>
+          </a:prstGeom>
+          <a:solidFill>
+            <a:srgbClr val="1F3A5F"/>
+          </a:solidFill>
+          <a:ln>
+            <a:noFill/>
+          </a:ln>
+          <a:effectLst/>
+        </p:spPr>
+        <p:style>
+          <a:lnRef idx="1">
+            <a:schemeClr val="accent1"/>
+          </a:lnRef>
+          <a:fillRef idx="3">
+            <a:schemeClr val="accent1"/>
+          </a:fillRef>
+          <a:effectRef idx="2">
+            <a:schemeClr val="accent1"/>
+          </a:effectRef>
+          <a:fontRef idx="minor">
+            <a:schemeClr val="lt1"/>
+          </a:fontRef>
+        </p:style>
+        <p:txBody>
+          <a:bodyPr rtlCol="0" anchor="t" wrap="square" lIns="180000" rIns="180000" tIns="180000"/>
+          <a:lstStyle/>
+          <a:p>
+            <a:pPr algn="l">
+              <a:spcAft>
+                <a:spcPts val="600"/>
+              </a:spcAft>
+            </a:pPr>
+            <a:r>
+              <a:rPr sz="1500" b="1">
                 <a:solidFill>
                   <a:srgbClr val="FFFFFF"/>
                 </a:solidFill>
                 <a:latin typeface="Calibri"/>
               </a:rPr>
-              <a:t>30% no aceite, 35% no mapeamento, 35% na entrega final</a:t>
-            </a:r>
-          </a:p>
-        </p:txBody>
-      </p:sp>
-      <p:sp>
-        <p:nvSpPr>
-          <p:cNvPr id="8" name="TextBox 7"/>
-          <p:cNvSpPr txBox="1"/>
-          <p:nvPr/>
-        </p:nvSpPr>
-        <p:spPr>
-          <a:xfrm>
-            <a:off x="648000" y="4536000"/>
-            <a:ext cx="10800000" cy="1440000"/>
-          </a:xfrm>
-          <a:prstGeom prst="rect">
-            <a:avLst/>
-          </a:prstGeom>
-          <a:noFill/>
-        </p:spPr>
-        <p:txBody>
-          <a:bodyPr wrap="square" anchor="t" lIns="180000" rIns="180000" tIns="180000">
-            <a:spAutoFit/>
-          </a:bodyPr>
-          <a:lstStyle/>
-          <a:p>
-            <a:pPr algn="l">
-              <a:spcAft>
-                <a:spcPts val="600"/>
-              </a:spcAft>
-            </a:pPr>
-            <a:r>
-              <a:rPr sz="1400" b="0">
-                <a:solidFill>
-                  <a:srgbClr val="595959"/>
-                </a:solidFill>
-                <a:latin typeface="Calibri"/>
-              </a:rPr>
-              <a:t>A reunião inicial e esta proposta não foram cobradas.</a:t>
-            </a:r>
-          </a:p>
-          <a:p>
-            <a:pPr algn="l">
-              <a:spcAft>
-                <a:spcPts val="600"/>
-              </a:spcAft>
-            </a:pPr>
-            <a:r>
-              <a:rPr sz="1400" b="0">
-                <a:solidFill>
-                  <a:srgbClr val="595959"/>
-                </a:solidFill>
-                <a:latin typeface="Calibri"/>
-              </a:rPr>
-              <a:t>Fora do escopo: automações, correção do Domínio, migração de contas, programa de bonificação e licenças.</a:t>
+              <a:t>18/12</a:t>
+            </a:r>
+          </a:p>
+          <a:p>
+            <a:pPr algn="l">
+              <a:spcAft>
+                <a:spcPts val="600"/>
+              </a:spcAft>
+            </a:pPr>
+            <a:r>
+              <a:rPr sz="1500" b="0">
+                <a:solidFill>
+                  <a:srgbClr val="FFFFFF"/>
+                </a:solidFill>
+                <a:latin typeface="Calibri"/>
+              </a:rPr>
+              <a:t>Apresentação final</a:t>
             </a:r>
           </a:p>
         </p:txBody>
@@ -7361,7 +8351,7 @@
                 </a:solidFill>
                 <a:latin typeface="Calibri"/>
               </a:rPr>
-              <a:t>Próximos passos</a:t>
+              <a:t>Investimento</a:t>
             </a:r>
           </a:p>
         </p:txBody>
@@ -7374,8 +8364,8 @@
         </p:nvSpPr>
         <p:spPr>
           <a:xfrm>
-            <a:off x="648000" y="6336000"/>
-            <a:ext cx="10800000" cy="288000"/>
+            <a:off x="648000" y="1152000"/>
+            <a:ext cx="10800000" cy="432000"/>
           </a:xfrm>
           <a:prstGeom prst="rect">
             <a:avLst/>
@@ -7394,13 +8384,13 @@
               </a:spcAft>
             </a:pPr>
             <a:r>
-              <a:rPr sz="900" b="0">
+              <a:rPr sz="1600" b="0">
                 <a:solidFill>
                   <a:srgbClr val="595959"/>
                 </a:solidFill>
                 <a:latin typeface="Calibri"/>
               </a:rPr>
-              <a:t>Surcin · Proposta de consultoria · Confidencial</a:t>
+              <a:t>Preço fechado. A implementação é orçada depois, por pacotes.</a:t>
             </a:r>
           </a:p>
         </p:txBody>
@@ -7413,8 +8403,8 @@
         </p:nvSpPr>
         <p:spPr>
           <a:xfrm>
-            <a:off x="648000" y="1620000"/>
-            <a:ext cx="10800000" cy="3960000"/>
+            <a:off x="648000" y="6336000"/>
+            <a:ext cx="10800000" cy="288000"/>
           </a:xfrm>
           <a:prstGeom prst="rect">
             <a:avLst/>
@@ -7433,141 +8423,250 @@
               </a:spcAft>
             </a:pPr>
             <a:r>
-              <a:rPr sz="1800" b="0">
-                <a:solidFill>
-                  <a:srgbClr val="1F3A5F"/>
-                </a:solidFill>
-                <a:latin typeface="Calibri"/>
-              </a:rPr>
-              <a:t>1. Escolha da opção e aceite da proposta</a:t>
-            </a:r>
-          </a:p>
-          <a:p>
-            <a:pPr algn="l">
-              <a:spcAft>
-                <a:spcPts val="600"/>
-              </a:spcAft>
-            </a:pPr>
-            <a:r>
-              <a:rPr sz="1800" b="0">
-                <a:solidFill>
-                  <a:srgbClr val="1F3A5F"/>
-                </a:solidFill>
-                <a:latin typeface="Calibri"/>
-              </a:rPr>
-              <a:t>2. Acordo de confidencialidade</a:t>
-            </a:r>
-          </a:p>
-          <a:p>
-            <a:pPr algn="l">
-              <a:spcAft>
-                <a:spcPts val="600"/>
-              </a:spcAft>
-            </a:pPr>
-            <a:r>
-              <a:rPr sz="1800" b="0">
-                <a:solidFill>
-                  <a:srgbClr val="1F3A5F"/>
-                </a:solidFill>
-                <a:latin typeface="Calibri"/>
-              </a:rPr>
-              <a:t>3. Kick-off na semana de 19/10, com a Júlia como ponto focal</a:t>
-            </a:r>
-          </a:p>
-          <a:p>
-            <a:pPr algn="l">
-              <a:spcAft>
-                <a:spcPts val="600"/>
-              </a:spcAft>
-            </a:pPr>
-            <a:r>
-              <a:rPr sz="1800" b="0">
-                <a:solidFill>
-                  <a:srgbClr val="1F3A5F"/>
-                </a:solidFill>
-                <a:latin typeface="Calibri"/>
-              </a:rPr>
-              <a:t/>
-            </a:r>
-          </a:p>
-          <a:p>
-            <a:pPr algn="l">
-              <a:spcAft>
-                <a:spcPts val="600"/>
-              </a:spcAft>
-            </a:pPr>
-            <a:r>
-              <a:rPr sz="1800" b="0">
-                <a:solidFill>
-                  <a:srgbClr val="1F3A5F"/>
-                </a:solidFill>
-                <a:latin typeface="Calibri"/>
-              </a:rPr>
-              <a:t>Para confirmar hoje:</a:t>
-            </a:r>
-          </a:p>
-          <a:p>
-            <a:pPr algn="l">
-              <a:spcAft>
-                <a:spcPts val="600"/>
-              </a:spcAft>
-            </a:pPr>
-            <a:r>
-              <a:rPr sz="1800" b="0">
-                <a:solidFill>
-                  <a:srgbClr val="1F3A5F"/>
-                </a:solidFill>
-                <a:latin typeface="Calibri"/>
-              </a:rPr>
-              <a:t>• Quantos clientes há em cada serviço?</a:t>
-            </a:r>
-          </a:p>
-          <a:p>
-            <a:pPr algn="l">
-              <a:spcAft>
-                <a:spcPts val="600"/>
-              </a:spcAft>
-            </a:pPr>
-            <a:r>
-              <a:rPr sz="1800" b="0">
-                <a:solidFill>
-                  <a:srgbClr val="1F3A5F"/>
-                </a:solidFill>
-                <a:latin typeface="Calibri"/>
-              </a:rPr>
-              <a:t>• Qual processo, resolvido primeiro, mais devolve seu tempo?</a:t>
-            </a:r>
-          </a:p>
-          <a:p>
-            <a:pPr algn="l">
-              <a:spcAft>
-                <a:spcPts val="600"/>
-              </a:spcAft>
-            </a:pPr>
-            <a:r>
-              <a:rPr sz="1800" b="0">
-                <a:solidFill>
-                  <a:srgbClr val="1F3A5F"/>
-                </a:solidFill>
-                <a:latin typeface="Calibri"/>
-              </a:rPr>
-              <a:t>• A equipe pode conversar antes das 10h30 ou no almoço?</a:t>
-            </a:r>
-          </a:p>
-          <a:p>
-            <a:pPr algn="l">
-              <a:spcAft>
-                <a:spcPts val="600"/>
-              </a:spcAft>
-            </a:pPr>
-            <a:r>
-              <a:rPr sz="1800" b="0">
-                <a:solidFill>
-                  <a:srgbClr val="1F3A5F"/>
-                </a:solidFill>
-                <a:latin typeface="Calibri"/>
-              </a:rPr>
-              <a:t>• Quem vai corrigir a configuração do Domínio?</a:t>
+              <a:rPr sz="900" b="0">
+                <a:solidFill>
+                  <a:srgbClr val="595959"/>
+                </a:solidFill>
+                <a:latin typeface="Calibri"/>
+              </a:rPr>
+              <a:t>Surcin · Proposta de consultoria · Confidencial</a:t>
+            </a:r>
+          </a:p>
+        </p:txBody>
+      </p:sp>
+      <p:sp>
+        <p:nvSpPr>
+          <p:cNvPr id="6" name="Rounded Rectangle 5"/>
+          <p:cNvSpPr/>
+          <p:nvPr/>
+        </p:nvSpPr>
+        <p:spPr>
+          <a:xfrm>
+            <a:off x="648000" y="1908000"/>
+            <a:ext cx="5256000" cy="2340000"/>
+          </a:xfrm>
+          <a:prstGeom prst="roundRect">
+            <a:avLst>
+              <a:gd name="adj" fmla="val 8000"/>
+            </a:avLst>
+          </a:prstGeom>
+          <a:solidFill>
+            <a:srgbClr val="E8EEF5"/>
+          </a:solidFill>
+          <a:ln>
+            <a:noFill/>
+          </a:ln>
+          <a:effectLst/>
+        </p:spPr>
+        <p:style>
+          <a:lnRef idx="1">
+            <a:schemeClr val="accent1"/>
+          </a:lnRef>
+          <a:fillRef idx="3">
+            <a:schemeClr val="accent1"/>
+          </a:fillRef>
+          <a:effectRef idx="2">
+            <a:schemeClr val="accent1"/>
+          </a:effectRef>
+          <a:fontRef idx="minor">
+            <a:schemeClr val="lt1"/>
+          </a:fontRef>
+        </p:style>
+        <p:txBody>
+          <a:bodyPr rtlCol="0" anchor="t" wrap="square" lIns="180000" rIns="180000" tIns="180000"/>
+          <a:lstStyle/>
+          <a:p>
+            <a:pPr algn="l">
+              <a:spcAft>
+                <a:spcPts val="600"/>
+              </a:spcAft>
+            </a:pPr>
+            <a:r>
+              <a:rPr sz="2000" b="1">
+                <a:solidFill>
+                  <a:srgbClr val="1F3A5F"/>
+                </a:solidFill>
+                <a:latin typeface="Calibri"/>
+              </a:rPr>
+              <a:t>Essencial</a:t>
+            </a:r>
+          </a:p>
+          <a:p>
+            <a:pPr algn="l">
+              <a:spcAft>
+                <a:spcPts val="600"/>
+              </a:spcAft>
+            </a:pPr>
+            <a:r>
+              <a:rPr sz="2000" b="1">
+                <a:solidFill>
+                  <a:srgbClr val="1F3A5F"/>
+                </a:solidFill>
+                <a:latin typeface="Calibri"/>
+              </a:rPr>
+              <a:t>R$ 7.800</a:t>
+            </a:r>
+          </a:p>
+          <a:p>
+            <a:pPr algn="l">
+              <a:spcAft>
+                <a:spcPts val="600"/>
+              </a:spcAft>
+            </a:pPr>
+            <a:r>
+              <a:rPr sz="2000" b="1">
+                <a:solidFill>
+                  <a:srgbClr val="1F3A5F"/>
+                </a:solidFill>
+                <a:latin typeface="Calibri"/>
+              </a:rPr>
+              <a:t>50% no aceite, 50% na entrega</a:t>
+            </a:r>
+          </a:p>
+        </p:txBody>
+      </p:sp>
+      <p:sp>
+        <p:nvSpPr>
+          <p:cNvPr id="7" name="Rounded Rectangle 6"/>
+          <p:cNvSpPr/>
+          <p:nvPr/>
+        </p:nvSpPr>
+        <p:spPr>
+          <a:xfrm>
+            <a:off x="6263999" y="1908000"/>
+            <a:ext cx="5256000" cy="2340000"/>
+          </a:xfrm>
+          <a:prstGeom prst="roundRect">
+            <a:avLst>
+              <a:gd name="adj" fmla="val 8000"/>
+            </a:avLst>
+          </a:prstGeom>
+          <a:solidFill>
+            <a:srgbClr val="1F3A5F"/>
+          </a:solidFill>
+          <a:ln>
+            <a:noFill/>
+          </a:ln>
+          <a:effectLst/>
+        </p:spPr>
+        <p:style>
+          <a:lnRef idx="1">
+            <a:schemeClr val="accent1"/>
+          </a:lnRef>
+          <a:fillRef idx="3">
+            <a:schemeClr val="accent1"/>
+          </a:fillRef>
+          <a:effectRef idx="2">
+            <a:schemeClr val="accent1"/>
+          </a:effectRef>
+          <a:fontRef idx="minor">
+            <a:schemeClr val="lt1"/>
+          </a:fontRef>
+        </p:style>
+        <p:txBody>
+          <a:bodyPr rtlCol="0" anchor="t" wrap="square" lIns="180000" rIns="180000" tIns="180000"/>
+          <a:lstStyle/>
+          <a:p>
+            <a:pPr algn="l">
+              <a:spcAft>
+                <a:spcPts val="600"/>
+              </a:spcAft>
+            </a:pPr>
+            <a:r>
+              <a:rPr sz="2000" b="1">
+                <a:solidFill>
+                  <a:srgbClr val="FFFFFF"/>
+                </a:solidFill>
+                <a:latin typeface="Calibri"/>
+              </a:rPr>
+              <a:t>Completa (recomendada)</a:t>
+            </a:r>
+          </a:p>
+          <a:p>
+            <a:pPr algn="l">
+              <a:spcAft>
+                <a:spcPts val="600"/>
+              </a:spcAft>
+            </a:pPr>
+            <a:r>
+              <a:rPr sz="2000" b="1">
+                <a:solidFill>
+                  <a:srgbClr val="FFFFFF"/>
+                </a:solidFill>
+                <a:latin typeface="Calibri"/>
+              </a:rPr>
+              <a:t>R$ 14.800</a:t>
+            </a:r>
+          </a:p>
+          <a:p>
+            <a:pPr algn="l">
+              <a:spcAft>
+                <a:spcPts val="600"/>
+              </a:spcAft>
+            </a:pPr>
+            <a:r>
+              <a:rPr sz="2000" b="1">
+                <a:solidFill>
+                  <a:srgbClr val="FFFFFF"/>
+                </a:solidFill>
+                <a:latin typeface="Calibri"/>
+              </a:rPr>
+              <a:t>30% no aceite, 35% no mapeamento, 35% na entrega final</a:t>
+            </a:r>
+          </a:p>
+        </p:txBody>
+      </p:sp>
+      <p:sp>
+        <p:nvSpPr>
+          <p:cNvPr id="8" name="TextBox 7"/>
+          <p:cNvSpPr txBox="1"/>
+          <p:nvPr/>
+        </p:nvSpPr>
+        <p:spPr>
+          <a:xfrm>
+            <a:off x="648000" y="4536000"/>
+            <a:ext cx="10800000" cy="1440000"/>
+          </a:xfrm>
+          <a:prstGeom prst="rect">
+            <a:avLst/>
+          </a:prstGeom>
+          <a:noFill/>
+        </p:spPr>
+        <p:txBody>
+          <a:bodyPr wrap="square" anchor="t" lIns="180000" rIns="180000" tIns="180000">
+            <a:spAutoFit/>
+          </a:bodyPr>
+          <a:lstStyle/>
+          <a:p>
+            <a:pPr algn="l">
+              <a:spcAft>
+                <a:spcPts val="600"/>
+              </a:spcAft>
+            </a:pPr>
+            <a:r>
+              <a:rPr sz="1400" b="0">
+                <a:solidFill>
+                  <a:srgbClr val="595959"/>
+                </a:solidFill>
+                <a:latin typeface="Calibri"/>
+              </a:rPr>
+              <a:t>A reunião inicial e esta proposta não foram cobradas.</a:t>
+            </a:r>
+          </a:p>
+          <a:p>
+            <a:pPr algn="l">
+              <a:spcAft>
+                <a:spcPts val="600"/>
+              </a:spcAft>
+            </a:pPr>
+            <a:r>
+              <a:rPr sz="1400" b="0">
+                <a:solidFill>
+                  <a:srgbClr val="595959"/>
+                </a:solidFill>
+                <a:latin typeface="Calibri"/>
+              </a:rPr>
+              <a:t>Fora da Fase 1: desenvolvimento e integrações (Fase 2), correção do Domínio, migração de contas, valores da premiação e licenças.</a:t>
             </a:r>
           </a:p>
         </p:txBody>

</xml_diff>

<commit_message>
Proposta Surcin v4: remove BPO, Joyce e contabilidade terceirizada; reconfere números com a transcrição
Co-Authored-By: Claude Opus 5.5 (1M context) <noreply@anthropic.com>
Claude-Session: https://claude.ai/code/session_0127xFh2xB8HoQ18BDMAY2QJ
</commit_message>
<xml_diff>
--- a/proposta-surcin/06-apresentacao-proposta.pptx
+++ b/proposta-surcin/06-apresentacao-proposta.pptx
@@ -4200,7 +4200,7 @@
                 </a:solidFill>
                 <a:latin typeface="Calibri"/>
               </a:rPr>
-              <a:t>• A contabilidade é executada pela Joyce?</a:t>
+              <a:t>• Quantos clientes o financeiro atende hoje?</a:t>
             </a:r>
           </a:p>
           <a:p>
@@ -4533,7 +4533,7 @@
                 </a:solidFill>
                 <a:latin typeface="Calibri"/>
               </a:rPr>
-              <a:t>• 13 a 15 clientes de BPO financeiro</a:t>
+              <a:t>• Cerca de 12 a 16 clientes no financeiro</a:t>
             </a:r>
           </a:p>
           <a:p>
@@ -6228,7 +6228,7 @@
                 </a:solidFill>
                 <a:latin typeface="Calibri"/>
               </a:rPr>
-              <a:t>Terceirizada e/ou contador(a)</a:t>
+              <a:t>Contador(a) em 2027 [decisão dela]</a:t>
             </a:r>
           </a:p>
         </p:txBody>
@@ -6722,7 +6722,7 @@
                 </a:solidFill>
                 <a:latin typeface="Calibri"/>
               </a:rPr>
-              <a:t>12 processos; a prioridade inicial é onde há mais risco e mais tempo gasto</a:t>
+              <a:t>11 processos; a prioridade inicial é onde há mais risco e mais tempo gasto</a:t>
             </a:r>
           </a:p>
         </p:txBody>
@@ -6885,22 +6885,6 @@
                 <a:latin typeface="Calibri"/>
               </a:rPr>
               <a:t>Prioridade 2</a:t>
-            </a:r>
-          </a:p>
-          <a:p>
-            <a:pPr algn="l">
-              <a:spcAft>
-                <a:spcPts val="600"/>
-              </a:spcAft>
-            </a:pPr>
-            <a:r>
-              <a:rPr sz="1500" b="0">
-                <a:solidFill>
-                  <a:srgbClr val="FFFFFF"/>
-                </a:solidFill>
-                <a:latin typeface="Calibri"/>
-              </a:rPr>
-              <a:t>• Conferência do contábil terceirizado</a:t>
             </a:r>
           </a:p>
           <a:p>

</xml_diff>

<commit_message>
Proposta Surcin: módulo opcional de avaliação de desempenho por competência
Co-Authored-By: Claude Opus 5.5 (1M context) <noreply@anthropic.com>
Claude-Session: https://claude.ai/code/session_0127xFh2xB8HoQ18BDMAY2QJ
</commit_message>
<xml_diff>
--- a/proposta-surcin/06-apresentacao-proposta.pptx
+++ b/proposta-surcin/06-apresentacao-proposta.pptx
@@ -8635,6 +8635,22 @@
                 <a:latin typeface="Calibri"/>
               </a:rPr>
               <a:t>A reunião inicial e esta proposta não foram cobradas.</a:t>
+            </a:r>
+          </a:p>
+          <a:p>
+            <a:pPr algn="l">
+              <a:spcAft>
+                <a:spcPts val="600"/>
+              </a:spcAft>
+            </a:pPr>
+            <a:r>
+              <a:rPr sz="1400" b="0">
+                <a:solidFill>
+                  <a:srgbClr val="595959"/>
+                </a:solidFill>
+                <a:latin typeface="Calibri"/>
+              </a:rPr>
+              <a:t>Opcional: avaliação de desempenho por competência, R$ 3.200 (R$ 2.600 junto com a Completa), em janeiro de 2027.</a:t>
             </a:r>
           </a:p>
           <a:p>

</xml_diff>

<commit_message>
Proposta Surcin: avaliação por competência dentro da Completa (R$ 17.400, entrega final em 22/01/2027)
Co-Authored-By: Claude Opus 5.5 (1M context) <noreply@anthropic.com>
Claude-Session: https://claude.ai/code/session_0127xFh2xB8HoQ18BDMAY2QJ
</commit_message>
<xml_diff>
--- a/proposta-surcin/06-apresentacao-proposta.pptx
+++ b/proposta-surcin/06-apresentacao-proposta.pptx
@@ -7495,7 +7495,7 @@
                 </a:solidFill>
                 <a:latin typeface="Calibri"/>
               </a:rPr>
-              <a:t>Completa (recomendada) · 19/10 a 18/12</a:t>
+              <a:t>Completa (recomendada) · 19/10 a 22/01</a:t>
             </a:r>
           </a:p>
           <a:p>
@@ -7608,6 +7608,22 @@
                 <a:latin typeface="Calibri"/>
               </a:rPr>
               <a:t>• Plano de automação com esforço e custo</a:t>
+            </a:r>
+          </a:p>
+          <a:p>
+            <a:pPr algn="l">
+              <a:spcAft>
+                <a:spcPts val="600"/>
+              </a:spcAft>
+            </a:pPr>
+            <a:r>
+              <a:rPr sz="1500" b="0">
+                <a:solidFill>
+                  <a:srgbClr val="FFFFFF"/>
+                </a:solidFill>
+                <a:latin typeface="Calibri"/>
+              </a:rPr>
+              <a:t>• Avaliação de desempenho por competência (jan.)</a:t>
             </a:r>
           </a:p>
         </p:txBody>
@@ -7746,7 +7762,7 @@
                 </a:solidFill>
                 <a:latin typeface="Calibri"/>
               </a:rPr>
-              <a:t>Cerca de 7 horas suas no total, sem reuniões na semana dos fechamentos nem na semana da prova</a:t>
+              <a:t>Cerca de 9 horas suas no total, sem reuniões na semana dos fechamentos nem na semana da prova</a:t>
             </a:r>
           </a:p>
         </p:txBody>
@@ -7799,7 +7815,7 @@
         <p:spPr>
           <a:xfrm>
             <a:off x="648000" y="2160000"/>
-            <a:ext cx="1710000" cy="1980000"/>
+            <a:ext cx="1475999" cy="1980000"/>
           </a:xfrm>
           <a:prstGeom prst="roundRect">
             <a:avLst>
@@ -7838,7 +7854,7 @@
               </a:spcAft>
             </a:pPr>
             <a:r>
-              <a:rPr sz="1500" b="1">
+              <a:rPr sz="1400" b="1">
                 <a:solidFill>
                   <a:srgbClr val="1F3A5F"/>
                 </a:solidFill>
@@ -7854,7 +7870,7 @@
               </a:spcAft>
             </a:pPr>
             <a:r>
-              <a:rPr sz="1500" b="0">
+              <a:rPr sz="1400" b="0">
                 <a:solidFill>
                   <a:srgbClr val="1F3A5F"/>
                 </a:solidFill>
@@ -7873,8 +7889,8 @@
         </p:nvSpPr>
         <p:spPr>
           <a:xfrm>
-            <a:off x="2466000" y="2160000"/>
-            <a:ext cx="1710000" cy="1980000"/>
+            <a:off x="2206800" y="2160000"/>
+            <a:ext cx="1475999" cy="1980000"/>
           </a:xfrm>
           <a:prstGeom prst="roundRect">
             <a:avLst>
@@ -7913,7 +7929,7 @@
               </a:spcAft>
             </a:pPr>
             <a:r>
-              <a:rPr sz="1500" b="1">
+              <a:rPr sz="1400" b="1">
                 <a:solidFill>
                   <a:srgbClr val="1F3A5F"/>
                 </a:solidFill>
@@ -7929,7 +7945,7 @@
               </a:spcAft>
             </a:pPr>
             <a:r>
-              <a:rPr sz="1500" b="0">
+              <a:rPr sz="1400" b="0">
                 <a:solidFill>
                   <a:srgbClr val="1F3A5F"/>
                 </a:solidFill>
@@ -7948,8 +7964,8 @@
         </p:nvSpPr>
         <p:spPr>
           <a:xfrm>
-            <a:off x="4284000" y="2160000"/>
-            <a:ext cx="1710000" cy="1980000"/>
+            <a:off x="3765600" y="2160000"/>
+            <a:ext cx="1475999" cy="1980000"/>
           </a:xfrm>
           <a:prstGeom prst="roundRect">
             <a:avLst>
@@ -7988,7 +8004,7 @@
               </a:spcAft>
             </a:pPr>
             <a:r>
-              <a:rPr sz="1500" b="1">
+              <a:rPr sz="1400" b="1">
                 <a:solidFill>
                   <a:srgbClr val="FFFFFF"/>
                 </a:solidFill>
@@ -8004,7 +8020,7 @@
               </a:spcAft>
             </a:pPr>
             <a:r>
-              <a:rPr sz="1500" b="0">
+              <a:rPr sz="1400" b="0">
                 <a:solidFill>
                   <a:srgbClr val="FFFFFF"/>
                 </a:solidFill>
@@ -8023,8 +8039,8 @@
         </p:nvSpPr>
         <p:spPr>
           <a:xfrm>
-            <a:off x="6102000" y="2160000"/>
-            <a:ext cx="1710000" cy="1980000"/>
+            <a:off x="5324400" y="2160000"/>
+            <a:ext cx="1475999" cy="1980000"/>
           </a:xfrm>
           <a:prstGeom prst="roundRect">
             <a:avLst>
@@ -8063,7 +8079,7 @@
               </a:spcAft>
             </a:pPr>
             <a:r>
-              <a:rPr sz="1500" b="1">
+              <a:rPr sz="1400" b="1">
                 <a:solidFill>
                   <a:srgbClr val="1F3A5F"/>
                 </a:solidFill>
@@ -8079,7 +8095,7 @@
               </a:spcAft>
             </a:pPr>
             <a:r>
-              <a:rPr sz="1500" b="0">
+              <a:rPr sz="1400" b="0">
                 <a:solidFill>
                   <a:srgbClr val="1F3A5F"/>
                 </a:solidFill>
@@ -8098,8 +8114,8 @@
         </p:nvSpPr>
         <p:spPr>
           <a:xfrm>
-            <a:off x="7920000" y="2160000"/>
-            <a:ext cx="1710000" cy="1980000"/>
+            <a:off x="6883200" y="2160000"/>
+            <a:ext cx="1475999" cy="1980000"/>
           </a:xfrm>
           <a:prstGeom prst="roundRect">
             <a:avLst>
@@ -8138,7 +8154,7 @@
               </a:spcAft>
             </a:pPr>
             <a:r>
-              <a:rPr sz="1500" b="1">
+              <a:rPr sz="1400" b="1">
                 <a:solidFill>
                   <a:srgbClr val="1F3A5F"/>
                 </a:solidFill>
@@ -8154,7 +8170,7 @@
               </a:spcAft>
             </a:pPr>
             <a:r>
-              <a:rPr sz="1500" b="0">
+              <a:rPr sz="1400" b="0">
                 <a:solidFill>
                   <a:srgbClr val="1F3A5F"/>
                 </a:solidFill>
@@ -8173,8 +8189,83 @@
         </p:nvSpPr>
         <p:spPr>
           <a:xfrm>
-            <a:off x="9738000" y="2160000"/>
-            <a:ext cx="1710000" cy="1980000"/>
+            <a:off x="8442000" y="2160000"/>
+            <a:ext cx="1475999" cy="1980000"/>
+          </a:xfrm>
+          <a:prstGeom prst="roundRect">
+            <a:avLst>
+              <a:gd name="adj" fmla="val 8000"/>
+            </a:avLst>
+          </a:prstGeom>
+          <a:solidFill>
+            <a:srgbClr val="E8EEF5"/>
+          </a:solidFill>
+          <a:ln>
+            <a:noFill/>
+          </a:ln>
+          <a:effectLst/>
+        </p:spPr>
+        <p:style>
+          <a:lnRef idx="1">
+            <a:schemeClr val="accent1"/>
+          </a:lnRef>
+          <a:fillRef idx="3">
+            <a:schemeClr val="accent1"/>
+          </a:fillRef>
+          <a:effectRef idx="2">
+            <a:schemeClr val="accent1"/>
+          </a:effectRef>
+          <a:fontRef idx="minor">
+            <a:schemeClr val="lt1"/>
+          </a:fontRef>
+        </p:style>
+        <p:txBody>
+          <a:bodyPr rtlCol="0" anchor="t" wrap="square" lIns="180000" rIns="180000" tIns="180000"/>
+          <a:lstStyle/>
+          <a:p>
+            <a:pPr algn="l">
+              <a:spcAft>
+                <a:spcPts val="600"/>
+              </a:spcAft>
+            </a:pPr>
+            <a:r>
+              <a:rPr sz="1400" b="1">
+                <a:solidFill>
+                  <a:srgbClr val="1F3A5F"/>
+                </a:solidFill>
+                <a:latin typeface="Calibri"/>
+              </a:rPr>
+              <a:t>18/12</a:t>
+            </a:r>
+          </a:p>
+          <a:p>
+            <a:pPr algn="l">
+              <a:spcAft>
+                <a:spcPts val="600"/>
+              </a:spcAft>
+            </a:pPr>
+            <a:r>
+              <a:rPr sz="1400" b="0">
+                <a:solidFill>
+                  <a:srgbClr val="1F3A5F"/>
+                </a:solidFill>
+                <a:latin typeface="Calibri"/>
+              </a:rPr>
+              <a:t>Fluxos e plano de automação</a:t>
+            </a:r>
+          </a:p>
+        </p:txBody>
+      </p:sp>
+      <p:sp>
+        <p:nvSpPr>
+          <p:cNvPr id="12" name="Rounded Rectangle 11"/>
+          <p:cNvSpPr/>
+          <p:nvPr/>
+        </p:nvSpPr>
+        <p:spPr>
+          <a:xfrm>
+            <a:off x="10000800" y="2160000"/>
+            <a:ext cx="1475999" cy="1980000"/>
           </a:xfrm>
           <a:prstGeom prst="roundRect">
             <a:avLst>
@@ -8213,29 +8304,29 @@
               </a:spcAft>
             </a:pPr>
             <a:r>
-              <a:rPr sz="1500" b="1">
+              <a:rPr sz="1400" b="1">
                 <a:solidFill>
                   <a:srgbClr val="FFFFFF"/>
                 </a:solidFill>
                 <a:latin typeface="Calibri"/>
               </a:rPr>
-              <a:t>18/12</a:t>
-            </a:r>
-          </a:p>
-          <a:p>
-            <a:pPr algn="l">
-              <a:spcAft>
-                <a:spcPts val="600"/>
-              </a:spcAft>
-            </a:pPr>
-            <a:r>
-              <a:rPr sz="1500" b="0">
+              <a:t>22/01</a:t>
+            </a:r>
+          </a:p>
+          <a:p>
+            <a:pPr algn="l">
+              <a:spcAft>
+                <a:spcPts val="600"/>
+              </a:spcAft>
+            </a:pPr>
+            <a:r>
+              <a:rPr sz="1400" b="0">
                 <a:solidFill>
                   <a:srgbClr val="FFFFFF"/>
                 </a:solidFill>
                 <a:latin typeface="Calibri"/>
               </a:rPr>
-              <a:t>Apresentação final</a:t>
+              <a:t>Avaliação por competência e entrega final</a:t>
             </a:r>
           </a:p>
         </p:txBody>
@@ -8579,7 +8670,7 @@
                 </a:solidFill>
                 <a:latin typeface="Calibri"/>
               </a:rPr>
-              <a:t>R$ 14.800</a:t>
+              <a:t>R$ 17.400</a:t>
             </a:r>
           </a:p>
           <a:p>
@@ -8650,7 +8741,7 @@
                 </a:solidFill>
                 <a:latin typeface="Calibri"/>
               </a:rPr>
-              <a:t>Opcional: avaliação de desempenho por competência, R$ 3.200 (R$ 2.600 junto com a Completa), em janeiro de 2027.</a:t>
+              <a:t>A Completa inclui a avaliação de desempenho por competência, feita em janeiro de 2027.</a:t>
             </a:r>
           </a:p>
           <a:p>

</xml_diff>